<commit_message>
docs: update Java modernization orchestration deck
</commit_message>
<xml_diff>
--- a/docs/bob-java-modernization-orchestrate.pptx
+++ b/docs/bob-java-modernization-orchestrate.pptx
@@ -46604,7 +46604,7 @@
           </a:ln>
           <a:extLst>
             <a:ext uri="{C572A759-6A51-4108-AA02-DFA0A04FC94B}">
-              <ma14:wrappingTextBoxFlag xmlns="" xmlns:ma14="http://schemas.microsoft.com/office/mac/drawingml/2011/main" xmlns:a14="http://schemas.microsoft.com/office/drawing/2010/main" xmlns:m="http://schemas.openxmlformats.org/officeDocument/2006/math" val="1"/>
+              <ma14:wrappingTextBoxFlag xmlns:m="http://schemas.openxmlformats.org/officeDocument/2006/math" xmlns:a14="http://schemas.microsoft.com/office/drawing/2010/main" xmlns:ma14="http://schemas.microsoft.com/office/mac/drawingml/2011/main" xmlns="" val="1"/>
             </a:ext>
           </a:extLst>
         </p:spPr>
@@ -46641,7 +46641,7 @@
           </a:ln>
           <a:extLst>
             <a:ext uri="{C572A759-6A51-4108-AA02-DFA0A04FC94B}">
-              <ma14:wrappingTextBoxFlag xmlns="" xmlns:ma14="http://schemas.microsoft.com/office/mac/drawingml/2011/main" xmlns:a14="http://schemas.microsoft.com/office/drawing/2010/main" xmlns:m="http://schemas.openxmlformats.org/officeDocument/2006/math" val="1"/>
+              <ma14:wrappingTextBoxFlag xmlns:m="http://schemas.openxmlformats.org/officeDocument/2006/math" xmlns:a14="http://schemas.microsoft.com/office/drawing/2010/main" xmlns:ma14="http://schemas.microsoft.com/office/mac/drawingml/2011/main" xmlns="" val="1"/>
             </a:ext>
           </a:extLst>
         </p:spPr>
@@ -47700,7 +47700,7 @@
           </a:ln>
           <a:extLst>
             <a:ext uri="{C572A759-6A51-4108-AA02-DFA0A04FC94B}">
-              <ma14:wrappingTextBoxFlag xmlns="" xmlns:ma14="http://schemas.microsoft.com/office/mac/drawingml/2011/main" xmlns:a14="http://schemas.microsoft.com/office/drawing/2010/main" xmlns:m="http://schemas.openxmlformats.org/officeDocument/2006/math" val="1"/>
+              <ma14:wrappingTextBoxFlag xmlns:m="http://schemas.openxmlformats.org/officeDocument/2006/math" xmlns:a14="http://schemas.microsoft.com/office/drawing/2010/main" xmlns:ma14="http://schemas.microsoft.com/office/mac/drawingml/2011/main" xmlns="" val="1"/>
             </a:ext>
           </a:extLst>
         </p:spPr>
@@ -47737,7 +47737,7 @@
           </a:ln>
           <a:extLst>
             <a:ext uri="{C572A759-6A51-4108-AA02-DFA0A04FC94B}">
-              <ma14:wrappingTextBoxFlag xmlns="" xmlns:ma14="http://schemas.microsoft.com/office/mac/drawingml/2011/main" xmlns:a14="http://schemas.microsoft.com/office/drawing/2010/main" xmlns:m="http://schemas.openxmlformats.org/officeDocument/2006/math" val="1"/>
+              <ma14:wrappingTextBoxFlag xmlns:m="http://schemas.openxmlformats.org/officeDocument/2006/math" xmlns:a14="http://schemas.microsoft.com/office/drawing/2010/main" xmlns:ma14="http://schemas.microsoft.com/office/mac/drawingml/2011/main" xmlns="" val="1"/>
             </a:ext>
           </a:extLst>
         </p:spPr>
@@ -48788,7 +48788,7 @@
           </a:ln>
           <a:extLst>
             <a:ext uri="{C572A759-6A51-4108-AA02-DFA0A04FC94B}">
-              <ma14:wrappingTextBoxFlag xmlns="" xmlns:ma14="http://schemas.microsoft.com/office/mac/drawingml/2011/main" xmlns:a14="http://schemas.microsoft.com/office/drawing/2010/main" xmlns:m="http://schemas.openxmlformats.org/officeDocument/2006/math" val="1"/>
+              <ma14:wrappingTextBoxFlag xmlns:m="http://schemas.openxmlformats.org/officeDocument/2006/math" xmlns:a14="http://schemas.microsoft.com/office/drawing/2010/main" xmlns:ma14="http://schemas.microsoft.com/office/mac/drawingml/2011/main" xmlns="" val="1"/>
             </a:ext>
           </a:extLst>
         </p:spPr>
@@ -49077,7 +49077,7 @@
           </a:ln>
           <a:extLst>
             <a:ext uri="{C572A759-6A51-4108-AA02-DFA0A04FC94B}">
-              <ma14:wrappingTextBoxFlag xmlns="" xmlns:ma14="http://schemas.microsoft.com/office/mac/drawingml/2011/main" xmlns:a14="http://schemas.microsoft.com/office/drawing/2010/main" xmlns:m="http://schemas.openxmlformats.org/officeDocument/2006/math" val="1"/>
+              <ma14:wrappingTextBoxFlag xmlns:m="http://schemas.openxmlformats.org/officeDocument/2006/math" xmlns:a14="http://schemas.microsoft.com/office/drawing/2010/main" xmlns:ma14="http://schemas.microsoft.com/office/mac/drawingml/2011/main" xmlns="" val="1"/>
             </a:ext>
           </a:extLst>
         </p:spPr>
@@ -49414,7 +49414,7 @@
           </a:ln>
           <a:extLst>
             <a:ext uri="{C572A759-6A51-4108-AA02-DFA0A04FC94B}">
-              <ma14:wrappingTextBoxFlag xmlns="" xmlns:ma14="http://schemas.microsoft.com/office/mac/drawingml/2011/main" xmlns:a14="http://schemas.microsoft.com/office/drawing/2010/main" xmlns:m="http://schemas.openxmlformats.org/officeDocument/2006/math" val="1"/>
+              <ma14:wrappingTextBoxFlag xmlns:m="http://schemas.openxmlformats.org/officeDocument/2006/math" xmlns:a14="http://schemas.microsoft.com/office/drawing/2010/main" xmlns:ma14="http://schemas.microsoft.com/office/mac/drawingml/2011/main" xmlns="" val="1"/>
             </a:ext>
           </a:extLst>
         </p:spPr>
@@ -49933,7 +49933,7 @@
             </a:ln>
             <a:extLst>
               <a:ext uri="{C572A759-6A51-4108-AA02-DFA0A04FC94B}">
-                <ma14:wrappingTextBoxFlag xmlns="" xmlns:m="http://schemas.openxmlformats.org/officeDocument/2006/math" xmlns:a14="http://schemas.microsoft.com/office/drawing/2010/main" xmlns:ma14="http://schemas.microsoft.com/office/mac/drawingml/2011/main" val="1"/>
+                <ma14:wrappingTextBoxFlag xmlns:ma14="http://schemas.microsoft.com/office/mac/drawingml/2011/main" xmlns:a14="http://schemas.microsoft.com/office/drawing/2010/main" xmlns:m="http://schemas.openxmlformats.org/officeDocument/2006/math" xmlns="" val="1"/>
               </a:ext>
             </a:extLst>
           </p:spPr>
@@ -50216,7 +50216,7 @@
             </a:ln>
             <a:extLst>
               <a:ext uri="{C572A759-6A51-4108-AA02-DFA0A04FC94B}">
-                <ma14:wrappingTextBoxFlag xmlns="" xmlns:ma14="http://schemas.microsoft.com/office/mac/drawingml/2011/main" xmlns:a14="http://schemas.microsoft.com/office/drawing/2010/main" xmlns:m="http://schemas.openxmlformats.org/officeDocument/2006/math" val="1"/>
+                <ma14:wrappingTextBoxFlag xmlns:m="http://schemas.openxmlformats.org/officeDocument/2006/math" xmlns:a14="http://schemas.microsoft.com/office/drawing/2010/main" xmlns:ma14="http://schemas.microsoft.com/office/mac/drawingml/2011/main" xmlns="" val="1"/>
               </a:ext>
             </a:extLst>
           </p:spPr>
@@ -50335,7 +50335,7 @@
         </p:nvSpPr>
         <p:spPr>
           <a:xfrm>
-            <a:off x="314410" y="448229"/>
+            <a:off x="319839" y="245507"/>
             <a:ext cx="3687319" cy="397455"/>
           </a:xfrm>
         </p:spPr>
@@ -50375,7 +50375,7 @@
           </a:ln>
           <a:extLst>
             <a:ext uri="{C572A759-6A51-4108-AA02-DFA0A04FC94B}">
-              <ma14:wrappingTextBoxFlag xmlns="" xmlns:ma14="http://schemas.microsoft.com/office/mac/drawingml/2011/main" xmlns:a14="http://schemas.microsoft.com/office/drawing/2010/main" xmlns:m="http://schemas.openxmlformats.org/officeDocument/2006/math" val="1"/>
+              <ma14:wrappingTextBoxFlag xmlns:m="http://schemas.openxmlformats.org/officeDocument/2006/math" xmlns:a14="http://schemas.microsoft.com/office/drawing/2010/main" xmlns:ma14="http://schemas.microsoft.com/office/mac/drawingml/2011/main" xmlns="" val="1"/>
             </a:ext>
           </a:extLst>
         </p:spPr>
@@ -50405,7 +50405,7 @@
       </p:sp>
       <p:pic>
         <p:nvPicPr>
-          <p:cNvPr id="12" name="Picture 11" descr="java-arch-diagram.png"/>
+          <p:cNvPr id="12" name="Picture 11" descr="java-arch-light.png"/>
           <p:cNvPicPr>
             <a:picLocks noChangeAspect="1"/>
           </p:cNvPicPr>
@@ -50419,8 +50419,8 @@
         </p:blipFill>
         <p:spPr>
           <a:xfrm>
-            <a:off x="1610405" y="1104065"/>
-            <a:ext cx="8447995" cy="5305706"/>
+            <a:off x="319839" y="776146"/>
+            <a:ext cx="7367894" cy="5766733"/>
           </a:xfrm>
           <a:prstGeom prst="rect">
             <a:avLst/>
@@ -50577,7 +50577,7 @@
           </a:ln>
           <a:extLst>
             <a:ext uri="{C572A759-6A51-4108-AA02-DFA0A04FC94B}">
-              <ma14:wrappingTextBoxFlag xmlns="" xmlns:m="http://schemas.openxmlformats.org/officeDocument/2006/math" xmlns:a14="http://schemas.microsoft.com/office/drawing/2010/main" xmlns:ma14="http://schemas.microsoft.com/office/mac/drawingml/2011/main" val="1"/>
+              <ma14:wrappingTextBoxFlag xmlns:ma14="http://schemas.microsoft.com/office/mac/drawingml/2011/main" xmlns:a14="http://schemas.microsoft.com/office/drawing/2010/main" xmlns:m="http://schemas.openxmlformats.org/officeDocument/2006/math" xmlns="" val="1"/>
             </a:ext>
           </a:extLst>
         </p:spPr>
@@ -50632,7 +50632,7 @@
           </a:ln>
           <a:extLst>
             <a:ext uri="{C572A759-6A51-4108-AA02-DFA0A04FC94B}">
-              <ma14:wrappingTextBoxFlag xmlns="" xmlns:m="http://schemas.openxmlformats.org/officeDocument/2006/math" xmlns:a14="http://schemas.microsoft.com/office/drawing/2010/main" xmlns:ma14="http://schemas.microsoft.com/office/mac/drawingml/2011/main" val="1"/>
+              <ma14:wrappingTextBoxFlag xmlns:ma14="http://schemas.microsoft.com/office/mac/drawingml/2011/main" xmlns:a14="http://schemas.microsoft.com/office/drawing/2010/main" xmlns:m="http://schemas.openxmlformats.org/officeDocument/2006/math" xmlns="" val="1"/>
             </a:ext>
           </a:extLst>
         </p:spPr>
@@ -50954,7 +50954,7 @@
           </a:ln>
           <a:extLst>
             <a:ext uri="{C572A759-6A51-4108-AA02-DFA0A04FC94B}">
-              <ma14:wrappingTextBoxFlag xmlns="" xmlns:ma14="http://schemas.microsoft.com/office/mac/drawingml/2011/main" xmlns:a14="http://schemas.microsoft.com/office/drawing/2010/main" xmlns:m="http://schemas.openxmlformats.org/officeDocument/2006/math" val="1"/>
+              <ma14:wrappingTextBoxFlag xmlns:m="http://schemas.openxmlformats.org/officeDocument/2006/math" xmlns:a14="http://schemas.microsoft.com/office/drawing/2010/main" xmlns:ma14="http://schemas.microsoft.com/office/mac/drawingml/2011/main" xmlns="" val="1"/>
             </a:ext>
           </a:extLst>
         </p:spPr>
@@ -51305,7 +51305,7 @@
           </a:ln>
           <a:extLst>
             <a:ext uri="{C572A759-6A51-4108-AA02-DFA0A04FC94B}">
-              <ma14:wrappingTextBoxFlag xmlns:m="http://schemas.openxmlformats.org/officeDocument/2006/math" xmlns:a14="http://schemas.microsoft.com/office/drawing/2010/main" xmlns:ma14="http://schemas.microsoft.com/office/mac/drawingml/2011/main" xmlns="" val="1"/>
+              <ma14:wrappingTextBoxFlag xmlns="" xmlns:ma14="http://schemas.microsoft.com/office/mac/drawingml/2011/main" xmlns:a14="http://schemas.microsoft.com/office/drawing/2010/main" xmlns:m="http://schemas.openxmlformats.org/officeDocument/2006/math" val="1"/>
             </a:ext>
           </a:extLst>
         </p:spPr>
@@ -51611,8 +51611,8 @@
         </p:nvSpPr>
         <p:spPr>
           <a:xfrm>
-            <a:off x="368011" y="1913659"/>
-            <a:ext cx="6096000" cy="3862981"/>
+            <a:off x="279905" y="1507111"/>
+            <a:ext cx="6269855" cy="4678204"/>
           </a:xfrm>
           <a:prstGeom prst="rect">
             <a:avLst/>
@@ -51629,77 +51629,127 @@
           <a:lstStyle/>
           <a:p>
             <a:r>
-              <a:rPr b="1"/>
+              <a:rPr sz="1600" b="1" dirty="0"/>
               <a:t>Specialized Java and Modernization Expertise</a:t>
             </a:r>
-            <a:endParaRPr lang="en-US" dirty="0"/>
-          </a:p>
-          <a:p>
-            <a:endParaRPr lang="en-US" dirty="0"/>
-          </a:p>
-          <a:p>
-            <a:r>
-              <a:rPr b="1"/>
+            <a:endParaRPr lang="en-US" sz="1600" dirty="0"/>
+          </a:p>
+          <a:p>
+            <a:endParaRPr lang="en-US" sz="1600" dirty="0"/>
+          </a:p>
+          <a:p>
+            <a:r>
+              <a:rPr sz="1600" b="1" dirty="0"/>
               <a:t>This project required deep understanding of:</a:t>
             </a:r>
           </a:p>
           <a:p>
             <a:r>
-              <a:rPr b="1"/>
-              <a:t>Modern Java syntax: Records (JEP 395), Sealed Types (JEP 409), Pattern Matching (JEP 441), Virtual Threads (JEP 444)</a:t>
-            </a:r>
-          </a:p>
-          <a:p>
-            <a:r>
-              <a:rPr b="1"/>
-              <a:t>Maven build lifecycle (pom.xml, dependency management, compiler plugins)</a:t>
-            </a:r>
-          </a:p>
-          <a:p>
-            <a:r>
-              <a:rPr b="1"/>
+              <a:rPr sz="1600" b="1" dirty="0"/>
+              <a:t>Modern Java syntax: Records, Sealed Types</a:t>
+            </a:r>
+            <a:r>
+              <a:rPr lang="en-US" sz="1600" b="1" dirty="0"/>
+              <a:t>, </a:t>
+            </a:r>
+            <a:r>
+              <a:rPr sz="1600" b="1" dirty="0"/>
+              <a:t>Pattern Matching</a:t>
+            </a:r>
+            <a:r>
+              <a:rPr lang="en-US" sz="1600" b="1" dirty="0"/>
+              <a:t>, </a:t>
+            </a:r>
+            <a:r>
+              <a:rPr sz="1600" b="1" dirty="0"/>
+              <a:t>Virtual Threads</a:t>
+            </a:r>
+          </a:p>
+          <a:p>
+            <a:r>
+              <a:rPr sz="1600" b="1" dirty="0"/>
+              <a:t>Maven build lifecycle (</a:t>
+            </a:r>
+            <a:r>
+              <a:rPr sz="1600" b="1" dirty="0" err="1"/>
+              <a:t>pom.xml</a:t>
+            </a:r>
+            <a:r>
+              <a:rPr sz="1600" b="1" dirty="0"/>
+              <a:t>, dependency management, compiler plugins)</a:t>
+            </a:r>
+          </a:p>
+          <a:p>
+            <a:r>
+              <a:rPr sz="1600" b="1" dirty="0"/>
               <a:t>Enterprise Java patterns (Swing UI, layered MVC, in-memory repositories, exception hierarchies)</a:t>
             </a:r>
           </a:p>
           <a:p>
-            <a:endParaRPr b="1"/>
-          </a:p>
-          <a:p>
-            <a:endParaRPr b="1"/>
-          </a:p>
-          <a:p>
-            <a:r>
-              <a:rPr b="1"/>
+            <a:endParaRPr sz="1600" b="1" dirty="0"/>
+          </a:p>
+          <a:p>
+            <a:r>
+              <a:rPr sz="1600" b="1" dirty="0"/>
               <a:t>Native IBM Product Understanding</a:t>
             </a:r>
-          </a:p>
-          <a:p>
-            <a:r>
-              <a:rPr b="1"/>
-              <a:t>- Specialized /java-modernization mode trained for Java 8 → Java 21 migration</a:t>
-            </a:r>
-          </a:p>
-          <a:p>
-            <a:r>
-              <a:rPr b="1"/>
+            <a:r>
+              <a:rPr lang="en-US" sz="1600" b="1" dirty="0"/>
+              <a:t>:</a:t>
+            </a:r>
+            <a:endParaRPr sz="1600" b="1" dirty="0"/>
+          </a:p>
+          <a:p>
+            <a:r>
+              <a:rPr sz="1600" b="1" dirty="0"/>
+              <a:t>- Specialized /java-modernization mode trained for Java 8 → Java 21</a:t>
+            </a:r>
+            <a:r>
+              <a:rPr lang="en-US" sz="1600" b="1" dirty="0"/>
+              <a:t>+</a:t>
+            </a:r>
+            <a:r>
+              <a:rPr sz="1600" b="1" dirty="0"/>
+              <a:t> migration</a:t>
+            </a:r>
+          </a:p>
+          <a:p>
+            <a:r>
+              <a:rPr sz="1600" b="1" dirty="0"/>
               <a:t>- IBM Cloud and Code Engine deployment patterns and best practices</a:t>
             </a:r>
           </a:p>
           <a:p>
             <a:r>
-              <a:rPr b="1"/>
-              <a:t>- Integration with the IBM watsonx Orchestrate ecosystem</a:t>
-            </a:r>
-          </a:p>
-          <a:p>
-            <a:r>
-              <a:rPr b="1"/>
-              <a:t>- Understanding of IBM's enterprise Java tooling (Open Liberty, Semeru)</a:t>
-            </a:r>
-          </a:p>
-          <a:p>
-            <a:r>
-              <a:rPr b="1"/>
+              <a:rPr sz="1600" b="1" dirty="0"/>
+              <a:t>- Integration with the IBM </a:t>
+            </a:r>
+            <a:r>
+              <a:rPr sz="1600" b="1" dirty="0" err="1"/>
+              <a:t>watsonx</a:t>
+            </a:r>
+            <a:r>
+              <a:rPr sz="1600" b="1" dirty="0"/>
+              <a:t> Orchestrate ecosystem</a:t>
+            </a:r>
+          </a:p>
+          <a:p>
+            <a:r>
+              <a:rPr sz="1600" b="1" dirty="0"/>
+              <a:t>- Understanding of IBM's enterprise Java tooling (Open Liberty, </a:t>
+            </a:r>
+            <a:r>
+              <a:rPr sz="1600" b="1" dirty="0" err="1"/>
+              <a:t>Semeru</a:t>
+            </a:r>
+            <a:r>
+              <a:rPr sz="1600" b="1" dirty="0"/>
+              <a:t>)</a:t>
+            </a:r>
+          </a:p>
+          <a:p>
+            <a:r>
+              <a:rPr sz="1600" b="1" dirty="0"/>
               <a:t>- Access to IBM MCP servers</a:t>
             </a:r>
           </a:p>
@@ -53057,7 +53107,7 @@
         </a:ln>
         <a:extLst>
           <a:ext uri="{C572A759-6A51-4108-AA02-DFA0A04FC94B}">
-            <ma14:wrappingTextBoxFlag xmlns:r="http://schemas.openxmlformats.org/officeDocument/2006/relationships" xmlns:p="http://schemas.openxmlformats.org/presentationml/2006/main" xmlns="" xmlns:m="http://schemas.openxmlformats.org/officeDocument/2006/math" xmlns:a14="http://schemas.microsoft.com/office/drawing/2010/main" xmlns:ma14="http://schemas.microsoft.com/office/mac/drawingml/2011/main" val="1"/>
+            <ma14:wrappingTextBoxFlag xmlns:ma14="http://schemas.microsoft.com/office/mac/drawingml/2011/main" xmlns:a14="http://schemas.microsoft.com/office/drawing/2010/main" xmlns:m="http://schemas.openxmlformats.org/officeDocument/2006/math" xmlns="" xmlns:p="http://schemas.openxmlformats.org/presentationml/2006/main" xmlns:r="http://schemas.openxmlformats.org/officeDocument/2006/relationships" val="1"/>
           </a:ext>
         </a:extLst>
       </a:spPr>

</xml_diff>

<commit_message>
docs: add "Why a Mode — not just hand-coding?" value-prop slide
Comparison slide (By hand vs /java-modernization mode) inserted after the
"Why IBM BOB?" slide, in the deck's IBM Carbon style.

Co-Authored-By: Claude Opus 4.8 (1M context) <noreply@anthropic.com>
</commit_message>
<xml_diff>
--- a/docs/bob-java-modernization-orchestrate.pptx
+++ b/docs/bob-java-modernization-orchestrate.pptx
@@ -15,6 +15,7 @@
     <p:sldId id="2147483255" r:id="rId6"/>
     <p:sldId id="2147483256" r:id="rId7"/>
     <p:sldId id="2147483259" r:id="rId8"/>
+    <p:sldId id="2147483260" r:id="rId17"/>
     <p:sldId id="2147483258" r:id="rId9"/>
     <p:sldId id="2147469197" r:id="rId10"/>
   </p:sldIdLst>
@@ -51979,6 +51980,615 @@
 </p:sld>
 </file>
 
+<file path=ppt/slides/slide8.xml><?xml version="1.0" encoding="utf-8"?>
+<p:sld xmlns:a="http://schemas.openxmlformats.org/drawingml/2006/main" xmlns:p="http://schemas.openxmlformats.org/presentationml/2006/main" xmlns:r="http://schemas.openxmlformats.org/officeDocument/2006/relationships">
+  <p:cSld>
+    <p:spTree>
+      <p:nvGrpSpPr>
+        <p:cNvPr id="1" name=""/>
+        <p:cNvGrpSpPr/>
+        <p:nvPr/>
+      </p:nvGrpSpPr>
+      <p:grpSpPr/>
+      <p:pic>
+        <p:nvPicPr>
+          <p:cNvPr id="2" name="Picture 1" descr="robot.png"/>
+          <p:cNvPicPr>
+            <a:picLocks noChangeAspect="1"/>
+          </p:cNvPicPr>
+          <p:nvPr/>
+        </p:nvPicPr>
+        <p:blipFill>
+          <a:blip r:embed="rId2"/>
+          <a:stretch>
+            <a:fillRect/>
+          </a:stretch>
+        </p:blipFill>
+        <p:spPr>
+          <a:xfrm>
+            <a:off x="0" y="91440"/>
+            <a:ext cx="1563624" cy="1563624"/>
+          </a:xfrm>
+          <a:prstGeom prst="rect">
+            <a:avLst/>
+          </a:prstGeom>
+        </p:spPr>
+      </p:pic>
+      <p:sp>
+        <p:nvSpPr>
+          <p:cNvPr id="3" name="TextBox 2"/>
+          <p:cNvSpPr txBox="1"/>
+          <p:nvPr/>
+        </p:nvSpPr>
+        <p:spPr>
+          <a:xfrm>
+            <a:off x="1563624" y="310896"/>
+            <a:ext cx="9418320" cy="640080"/>
+          </a:xfrm>
+          <a:prstGeom prst="rect">
+            <a:avLst/>
+          </a:prstGeom>
+          <a:noFill/>
+        </p:spPr>
+        <p:txBody>
+          <a:bodyPr wrap="square" anchor="t" lIns="0" rIns="0" tIns="0" bIns="0">
+            <a:spAutoFit/>
+          </a:bodyPr>
+          <a:lstStyle/>
+          <a:p>
+            <a:pPr algn="l"/>
+            <a:r>
+              <a:rPr sz="2900" b="0" i="0">
+                <a:solidFill>
+                  <a:srgbClr val="525252"/>
+                </a:solidFill>
+                <a:latin typeface="IBM Plex Sans Light"/>
+              </a:rPr>
+              <a:t>Why a Mode — not just hand-coding?</a:t>
+            </a:r>
+          </a:p>
+        </p:txBody>
+      </p:sp>
+      <p:sp>
+        <p:nvSpPr>
+          <p:cNvPr id="4" name="TextBox 3"/>
+          <p:cNvSpPr txBox="1"/>
+          <p:nvPr/>
+        </p:nvSpPr>
+        <p:spPr>
+          <a:xfrm>
+            <a:off x="1563624" y="969264"/>
+            <a:ext cx="9418320" cy="457200"/>
+          </a:xfrm>
+          <a:prstGeom prst="rect">
+            <a:avLst/>
+          </a:prstGeom>
+          <a:noFill/>
+        </p:spPr>
+        <p:txBody>
+          <a:bodyPr wrap="square" anchor="t" lIns="0" rIns="0" tIns="0" bIns="0">
+            <a:spAutoFit/>
+          </a:bodyPr>
+          <a:lstStyle/>
+          <a:p>
+            <a:pPr algn="l"/>
+            <a:r>
+              <a:rPr sz="1350" b="0" i="1">
+                <a:solidFill>
+                  <a:srgbClr val="0F62FE"/>
+                </a:solidFill>
+                <a:latin typeface="IBM Plex Sans"/>
+              </a:rPr>
+              <a:t>You can modernize one class by hand. The value is the whole estate — identically, safely, in hours, not months.</a:t>
+            </a:r>
+          </a:p>
+        </p:txBody>
+      </p:sp>
+      <p:graphicFrame>
+        <p:nvGraphicFramePr>
+          <p:cNvPr id="5" name="Table 4"/>
+          <p:cNvGraphicFramePr>
+            <a:graphicFrameLocks noGrp="1"/>
+          </p:cNvGraphicFramePr>
+          <p:nvPr/>
+        </p:nvGraphicFramePr>
+        <p:xfrm>
+          <a:off x="457200" y="1627632"/>
+          <a:ext cx="11274552" cy="3931920"/>
+        </p:xfrm>
+        <a:graphic>
+          <a:graphicData uri="http://schemas.openxmlformats.org/drawingml/2006/table">
+            <a:tbl>
+              <a:tblPr>
+                <a:tableStyleId>{5C22544A-7EE6-4342-B048-85BDC9FD1C3A}</a:tableStyleId>
+              </a:tblPr>
+              <a:tblGrid>
+                <a:gridCol w="2057400"/>
+                <a:gridCol w="4480560"/>
+                <a:gridCol w="4736592"/>
+              </a:tblGrid>
+              <a:tr h="502920">
+                <a:tc>
+                  <a:txBody>
+                    <a:bodyPr wrap="square"/>
+                    <a:lstStyle/>
+                    <a:p>
+                      <a:pPr algn="l"/>
+                      <a:r>
+                        <a:rPr sz="1300" b="1">
+                          <a:solidFill>
+                            <a:srgbClr val="FFFFFF"/>
+                          </a:solidFill>
+                          <a:latin typeface="IBM Plex Sans"/>
+                        </a:rPr>
+                        <a:t>Dimension</a:t>
+                      </a:r>
+                    </a:p>
+                  </a:txBody>
+                  <a:tcPr anchor="ctr" marL="127000" marR="101600" marT="50800" marB="50800">
+                    <a:solidFill>
+                      <a:srgbClr val="0F62FE"/>
+                    </a:solidFill>
+                  </a:tcPr>
+                </a:tc>
+                <a:tc>
+                  <a:txBody>
+                    <a:bodyPr wrap="square"/>
+                    <a:lstStyle/>
+                    <a:p>
+                      <a:pPr algn="l"/>
+                      <a:r>
+                        <a:rPr sz="1300" b="1">
+                          <a:solidFill>
+                            <a:srgbClr val="FFFFFF"/>
+                          </a:solidFill>
+                          <a:latin typeface="IBM Plex Sans"/>
+                        </a:rPr>
+                        <a:t>By hand — developer alone</a:t>
+                      </a:r>
+                    </a:p>
+                  </a:txBody>
+                  <a:tcPr anchor="ctr" marL="127000" marR="101600" marT="50800" marB="50800">
+                    <a:solidFill>
+                      <a:srgbClr val="0F62FE"/>
+                    </a:solidFill>
+                  </a:tcPr>
+                </a:tc>
+                <a:tc>
+                  <a:txBody>
+                    <a:bodyPr wrap="square"/>
+                    <a:lstStyle/>
+                    <a:p>
+                      <a:pPr algn="l"/>
+                      <a:r>
+                        <a:rPr sz="1300" b="1">
+                          <a:solidFill>
+                            <a:srgbClr val="FFFFFF"/>
+                          </a:solidFill>
+                          <a:latin typeface="IBM Plex Sans"/>
+                        </a:rPr>
+                        <a:t>With /java-modernization mode</a:t>
+                      </a:r>
+                    </a:p>
+                  </a:txBody>
+                  <a:tcPr anchor="ctr" marL="127000" marR="101600" marT="50800" marB="50800">
+                    <a:solidFill>
+                      <a:srgbClr val="0F62FE"/>
+                    </a:solidFill>
+                  </a:tcPr>
+                </a:tc>
+              </a:tr>
+              <a:tr h="685800">
+                <a:tc>
+                  <a:txBody>
+                    <a:bodyPr wrap="square"/>
+                    <a:lstStyle/>
+                    <a:p>
+                      <a:pPr algn="l"/>
+                      <a:r>
+                        <a:rPr sz="1300" b="1">
+                          <a:solidFill>
+                            <a:srgbClr val="0E2841"/>
+                          </a:solidFill>
+                          <a:latin typeface="IBM Plex Sans"/>
+                        </a:rPr>
+                        <a:t>Scale</a:t>
+                      </a:r>
+                    </a:p>
+                  </a:txBody>
+                  <a:tcPr anchor="ctr" marL="127000" marR="101600" marT="50800" marB="50800">
+                    <a:solidFill>
+                      <a:srgbClr val="F2F4F8"/>
+                    </a:solidFill>
+                  </a:tcPr>
+                </a:tc>
+                <a:tc>
+                  <a:txBody>
+                    <a:bodyPr wrap="square"/>
+                    <a:lstStyle/>
+                    <a:p>
+                      <a:pPr algn="l"/>
+                      <a:r>
+                        <a:rPr sz="1150" b="0">
+                          <a:solidFill>
+                            <a:srgbClr val="393939"/>
+                          </a:solidFill>
+                          <a:latin typeface="IBM Plex Sans"/>
+                        </a:rPr>
+                        <a:t>One class is quick; the whole system is weeks of toil</a:t>
+                      </a:r>
+                    </a:p>
+                  </a:txBody>
+                  <a:tcPr anchor="ctr" marL="127000" marR="101600" marT="50800" marB="50800">
+                    <a:solidFill>
+                      <a:srgbClr val="FFFFFF"/>
+                    </a:solidFill>
+                  </a:tcPr>
+                </a:tc>
+                <a:tc>
+                  <a:txBody>
+                    <a:bodyPr wrap="square"/>
+                    <a:lstStyle/>
+                    <a:p>
+                      <a:pPr algn="l"/>
+                      <a:r>
+                        <a:rPr sz="1150" b="0">
+                          <a:solidFill>
+                            <a:srgbClr val="161616"/>
+                          </a:solidFill>
+                          <a:latin typeface="IBM Plex Sans"/>
+                        </a:rPr>
+                        <a:t>Hundreds of files in hours — one shared playbook</a:t>
+                      </a:r>
+                    </a:p>
+                  </a:txBody>
+                  <a:tcPr anchor="ctr" marL="127000" marR="101600" marT="50800" marB="50800">
+                    <a:solidFill>
+                      <a:srgbClr val="EDF2FF"/>
+                    </a:solidFill>
+                  </a:tcPr>
+                </a:tc>
+              </a:tr>
+              <a:tr h="685800">
+                <a:tc>
+                  <a:txBody>
+                    <a:bodyPr wrap="square"/>
+                    <a:lstStyle/>
+                    <a:p>
+                      <a:pPr algn="l"/>
+                      <a:r>
+                        <a:rPr sz="1300" b="1">
+                          <a:solidFill>
+                            <a:srgbClr val="0E2841"/>
+                          </a:solidFill>
+                          <a:latin typeface="IBM Plex Sans"/>
+                        </a:rPr>
+                        <a:t>Consistency</a:t>
+                      </a:r>
+                    </a:p>
+                  </a:txBody>
+                  <a:tcPr anchor="ctr" marL="127000" marR="101600" marT="50800" marB="50800">
+                    <a:solidFill>
+                      <a:srgbClr val="F2F4F8"/>
+                    </a:solidFill>
+                  </a:tcPr>
+                </a:tc>
+                <a:tc>
+                  <a:txBody>
+                    <a:bodyPr wrap="square"/>
+                    <a:lstStyle/>
+                    <a:p>
+                      <a:pPr algn="l"/>
+                      <a:r>
+                        <a:rPr sz="1150" b="0">
+                          <a:solidFill>
+                            <a:srgbClr val="393939"/>
+                          </a:solidFill>
+                          <a:latin typeface="IBM Plex Sans"/>
+                        </a:rPr>
+                        <a:t>Fatigue creeps in; 5 developers → 5 styles</a:t>
+                      </a:r>
+                    </a:p>
+                  </a:txBody>
+                  <a:tcPr anchor="ctr" marL="127000" marR="101600" marT="50800" marB="50800">
+                    <a:solidFill>
+                      <a:srgbClr val="FFFFFF"/>
+                    </a:solidFill>
+                  </a:tcPr>
+                </a:tc>
+                <a:tc>
+                  <a:txBody>
+                    <a:bodyPr wrap="square"/>
+                    <a:lstStyle/>
+                    <a:p>
+                      <a:pPr algn="l"/>
+                      <a:r>
+                        <a:rPr sz="1150" b="0">
+                          <a:solidFill>
+                            <a:srgbClr val="161616"/>
+                          </a:solidFill>
+                          <a:latin typeface="IBM Plex Sans"/>
+                        </a:rPr>
+                        <a:t>Identical rules applied to every file</a:t>
+                      </a:r>
+                    </a:p>
+                  </a:txBody>
+                  <a:tcPr anchor="ctr" marL="127000" marR="101600" marT="50800" marB="50800">
+                    <a:solidFill>
+                      <a:srgbClr val="EDF2FF"/>
+                    </a:solidFill>
+                  </a:tcPr>
+                </a:tc>
+              </a:tr>
+              <a:tr h="685800">
+                <a:tc>
+                  <a:txBody>
+                    <a:bodyPr wrap="square"/>
+                    <a:lstStyle/>
+                    <a:p>
+                      <a:pPr algn="l"/>
+                      <a:r>
+                        <a:rPr sz="1300" b="1">
+                          <a:solidFill>
+                            <a:srgbClr val="0E2841"/>
+                          </a:solidFill>
+                          <a:latin typeface="IBM Plex Sans"/>
+                        </a:rPr>
+                        <a:t>Expertise</a:t>
+                      </a:r>
+                    </a:p>
+                  </a:txBody>
+                  <a:tcPr anchor="ctr" marL="127000" marR="101600" marT="50800" marB="50800">
+                    <a:solidFill>
+                      <a:srgbClr val="F2F4F8"/>
+                    </a:solidFill>
+                  </a:tcPr>
+                </a:tc>
+                <a:tc>
+                  <a:txBody>
+                    <a:bodyPr wrap="square"/>
+                    <a:lstStyle/>
+                    <a:p>
+                      <a:pPr algn="l"/>
+                      <a:r>
+                        <a:rPr sz="1150" b="0">
+                          <a:solidFill>
+                            <a:srgbClr val="393939"/>
+                          </a:solidFill>
+                          <a:latin typeface="IBM Plex Sans"/>
+                        </a:rPr>
+                        <a:t>Needs a senior who knows the traps</a:t>
+                      </a:r>
+                    </a:p>
+                  </a:txBody>
+                  <a:tcPr anchor="ctr" marL="127000" marR="101600" marT="50800" marB="50800">
+                    <a:solidFill>
+                      <a:srgbClr val="FFFFFF"/>
+                    </a:solidFill>
+                  </a:tcPr>
+                </a:tc>
+                <a:tc>
+                  <a:txBody>
+                    <a:bodyPr wrap="square"/>
+                    <a:lstStyle/>
+                    <a:p>
+                      <a:pPr algn="l"/>
+                      <a:r>
+                        <a:rPr sz="1150" b="0">
+                          <a:solidFill>
+                            <a:srgbClr val="161616"/>
+                          </a:solidFill>
+                          <a:latin typeface="IBM Plex Sans"/>
+                        </a:rPr>
+                        <a:t>Senior-level know-how baked into the mode</a:t>
+                      </a:r>
+                    </a:p>
+                  </a:txBody>
+                  <a:tcPr anchor="ctr" marL="127000" marR="101600" marT="50800" marB="50800">
+                    <a:solidFill>
+                      <a:srgbClr val="EDF2FF"/>
+                    </a:solidFill>
+                  </a:tcPr>
+                </a:tc>
+              </a:tr>
+              <a:tr h="685800">
+                <a:tc>
+                  <a:txBody>
+                    <a:bodyPr wrap="square"/>
+                    <a:lstStyle/>
+                    <a:p>
+                      <a:pPr algn="l"/>
+                      <a:r>
+                        <a:rPr sz="1300" b="1">
+                          <a:solidFill>
+                            <a:srgbClr val="0E2841"/>
+                          </a:solidFill>
+                          <a:latin typeface="IBM Plex Sans"/>
+                        </a:rPr>
+                        <a:t>Risk</a:t>
+                      </a:r>
+                    </a:p>
+                  </a:txBody>
+                  <a:tcPr anchor="ctr" marL="127000" marR="101600" marT="50800" marB="50800">
+                    <a:solidFill>
+                      <a:srgbClr val="F2F4F8"/>
+                    </a:solidFill>
+                  </a:tcPr>
+                </a:tc>
+                <a:tc>
+                  <a:txBody>
+                    <a:bodyPr wrap="square"/>
+                    <a:lstStyle/>
+                    <a:p>
+                      <a:pPr algn="l"/>
+                      <a:r>
+                        <a:rPr sz="1150" b="0">
+                          <a:solidFill>
+                            <a:srgbClr val="393939"/>
+                          </a:solidFill>
+                          <a:latin typeface="IBM Plex Sans"/>
+                        </a:rPr>
+                        <a:t>Missed call sites, silent behavior changes</a:t>
+                      </a:r>
+                    </a:p>
+                  </a:txBody>
+                  <a:tcPr anchor="ctr" marL="127000" marR="101600" marT="50800" marB="50800">
+                    <a:solidFill>
+                      <a:srgbClr val="FFFFFF"/>
+                    </a:solidFill>
+                  </a:tcPr>
+                </a:tc>
+                <a:tc>
+                  <a:txBody>
+                    <a:bodyPr wrap="square"/>
+                    <a:lstStyle/>
+                    <a:p>
+                      <a:pPr algn="l"/>
+                      <a:r>
+                        <a:rPr sz="1150" b="0">
+                          <a:solidFill>
+                            <a:srgbClr val="161616"/>
+                          </a:solidFill>
+                          <a:latin typeface="IBM Plex Sans"/>
+                        </a:rPr>
+                        <a:t>Build stays green, behavior preserved, full diff audit</a:t>
+                      </a:r>
+                    </a:p>
+                  </a:txBody>
+                  <a:tcPr anchor="ctr" marL="127000" marR="101600" marT="50800" marB="50800">
+                    <a:solidFill>
+                      <a:srgbClr val="EDF2FF"/>
+                    </a:solidFill>
+                  </a:tcPr>
+                </a:tc>
+              </a:tr>
+              <a:tr h="685800">
+                <a:tc>
+                  <a:txBody>
+                    <a:bodyPr wrap="square"/>
+                    <a:lstStyle/>
+                    <a:p>
+                      <a:pPr algn="l"/>
+                      <a:r>
+                        <a:rPr sz="1300" b="1">
+                          <a:solidFill>
+                            <a:srgbClr val="0E2841"/>
+                          </a:solidFill>
+                          <a:latin typeface="IBM Plex Sans"/>
+                        </a:rPr>
+                        <a:t>Portfolio</a:t>
+                      </a:r>
+                    </a:p>
+                  </a:txBody>
+                  <a:tcPr anchor="ctr" marL="127000" marR="101600" marT="50800" marB="50800">
+                    <a:solidFill>
+                      <a:srgbClr val="F2F4F8"/>
+                    </a:solidFill>
+                  </a:tcPr>
+                </a:tc>
+                <a:tc>
+                  <a:txBody>
+                    <a:bodyPr wrap="square"/>
+                    <a:lstStyle/>
+                    <a:p>
+                      <a:pPr algn="l"/>
+                      <a:r>
+                        <a:rPr sz="1150" b="0">
+                          <a:solidFill>
+                            <a:srgbClr val="393939"/>
+                          </a:solidFill>
+                          <a:latin typeface="IBM Plex Sans"/>
+                        </a:rPr>
+                        <a:t>Re-learned for each application</a:t>
+                      </a:r>
+                    </a:p>
+                  </a:txBody>
+                  <a:tcPr anchor="ctr" marL="127000" marR="101600" marT="50800" marB="50800">
+                    <a:solidFill>
+                      <a:srgbClr val="FFFFFF"/>
+                    </a:solidFill>
+                  </a:tcPr>
+                </a:tc>
+                <a:tc>
+                  <a:txBody>
+                    <a:bodyPr wrap="square"/>
+                    <a:lstStyle/>
+                    <a:p>
+                      <a:pPr algn="l"/>
+                      <a:r>
+                        <a:rPr sz="1150" b="0">
+                          <a:solidFill>
+                            <a:srgbClr val="161616"/>
+                          </a:solidFill>
+                          <a:latin typeface="IBM Plex Sans"/>
+                        </a:rPr>
+                        <a:t>Written once → reused across the whole Java estate</a:t>
+                      </a:r>
+                    </a:p>
+                  </a:txBody>
+                  <a:tcPr anchor="ctr" marL="127000" marR="101600" marT="50800" marB="50800">
+                    <a:solidFill>
+                      <a:srgbClr val="EDF2FF"/>
+                    </a:solidFill>
+                  </a:tcPr>
+                </a:tc>
+              </a:tr>
+            </a:tbl>
+          </a:graphicData>
+        </a:graphic>
+      </p:graphicFrame>
+      <p:sp>
+        <p:nvSpPr>
+          <p:cNvPr id="6" name="TextBox 5"/>
+          <p:cNvSpPr txBox="1"/>
+          <p:nvPr/>
+        </p:nvSpPr>
+        <p:spPr>
+          <a:xfrm>
+            <a:off x="457200" y="5852160"/>
+            <a:ext cx="11274552" cy="640080"/>
+          </a:xfrm>
+          <a:prstGeom prst="rect">
+            <a:avLst/>
+          </a:prstGeom>
+          <a:noFill/>
+        </p:spPr>
+        <p:txBody>
+          <a:bodyPr wrap="square" anchor="t" lIns="0" rIns="0" tIns="0" bIns="0">
+            <a:spAutoFit/>
+          </a:bodyPr>
+          <a:lstStyle/>
+          <a:p>
+            <a:pPr algn="l"/>
+            <a:r>
+              <a:rPr sz="1400" b="1" i="0">
+                <a:solidFill>
+                  <a:srgbClr val="0E2841"/>
+                </a:solidFill>
+                <a:latin typeface="IBM Plex Sans"/>
+              </a:rPr>
+              <a:t>It isn't Bob vs the developer — it's developer + Bob. </a:t>
+            </a:r>
+            <a:r>
+              <a:rPr sz="1400" b="0" i="1">
+                <a:solidFill>
+                  <a:srgbClr val="525252"/>
+                </a:solidFill>
+                <a:latin typeface="IBM Plex Sans"/>
+              </a:rPr>
+              <a:t>The judgment stays human; the toil disappears.</a:t>
+            </a:r>
+          </a:p>
+        </p:txBody>
+      </p:sp>
+    </p:spTree>
+  </p:cSld>
+  <p:clrMapOvr>
+    <a:masterClrMapping/>
+  </p:clrMapOvr>
+</p:sld>
+</file>
+
 <file path=ppt/theme/theme1.xml><?xml version="1.0" encoding="utf-8"?>
 <a:theme xmlns:a="http://schemas.openxmlformats.org/drawingml/2006/main" name="Office Theme">
   <a:themeElements>

</xml_diff>

<commit_message>
docs: add "AI alone vs AI + Bob" value-prop slide
Two-card comparison (generic AI assistant vs AI + IBM Bob) inserted after the
"Why a Mode" slide, in the deck's IBM Carbon style.

Co-Authored-By: Claude Opus 4.8 (1M context) <noreply@anthropic.com>
</commit_message>
<xml_diff>
--- a/docs/bob-java-modernization-orchestrate.pptx
+++ b/docs/bob-java-modernization-orchestrate.pptx
@@ -16,6 +16,7 @@
     <p:sldId id="2147483256" r:id="rId7"/>
     <p:sldId id="2147483259" r:id="rId8"/>
     <p:sldId id="2147483260" r:id="rId17"/>
+    <p:sldId id="2147483261" r:id="rId18"/>
     <p:sldId id="2147483258" r:id="rId9"/>
     <p:sldId id="2147469197" r:id="rId10"/>
   </p:sldIdLst>
@@ -51771,216 +51772,6 @@
 </file>
 
 <file path=ppt/slides/slide6.xml><?xml version="1.0" encoding="utf-8"?>
-<p:sld xmlns:a="http://schemas.openxmlformats.org/drawingml/2006/main" xmlns:r="http://schemas.openxmlformats.org/officeDocument/2006/relationships" xmlns:p="http://schemas.openxmlformats.org/presentationml/2006/main">
-  <p:cSld>
-    <p:spTree>
-      <p:nvGrpSpPr>
-        <p:cNvPr id="1" name="">
-          <a:extLst>
-            <a:ext uri="{FF2B5EF4-FFF2-40B4-BE49-F238E27FC236}">
-              <a16:creationId xmlns:a16="http://schemas.microsoft.com/office/drawing/2014/main" id="{EDDF2B97-92CD-2466-3B01-5C84E1221AED}"/>
-            </a:ext>
-          </a:extLst>
-        </p:cNvPr>
-        <p:cNvGrpSpPr/>
-        <p:nvPr/>
-      </p:nvGrpSpPr>
-      <p:grpSpPr>
-        <a:xfrm>
-          <a:off x="0" y="0"/>
-          <a:ext cx="0" cy="0"/>
-          <a:chOff x="0" y="0"/>
-          <a:chExt cx="0" cy="0"/>
-        </a:xfrm>
-      </p:grpSpPr>
-      <p:sp>
-        <p:nvSpPr>
-          <p:cNvPr id="2" name="Title 1">
-            <a:extLst>
-              <a:ext uri="{FF2B5EF4-FFF2-40B4-BE49-F238E27FC236}">
-                <a16:creationId xmlns:a16="http://schemas.microsoft.com/office/drawing/2014/main" id="{A4655D6E-26DC-B3EE-14A0-D924B77032C9}"/>
-              </a:ext>
-            </a:extLst>
-          </p:cNvPr>
-          <p:cNvSpPr>
-            <a:spLocks noGrp="1"/>
-          </p:cNvSpPr>
-          <p:nvPr>
-            <p:ph type="title"/>
-          </p:nvPr>
-        </p:nvSpPr>
-        <p:spPr>
-          <a:xfrm>
-            <a:off x="5637821" y="3143684"/>
-            <a:ext cx="916358" cy="570632"/>
-          </a:xfrm>
-        </p:spPr>
-        <p:txBody>
-          <a:bodyPr vert="horz" lIns="0" tIns="0" rIns="0" bIns="0" rtlCol="0" anchor="ctr">
-            <a:noAutofit/>
-          </a:bodyPr>
-          <a:lstStyle/>
-          <a:p>
-            <a:pPr algn="ctr">
-              <a:lnSpc>
-                <a:spcPct val="90000"/>
-              </a:lnSpc>
-            </a:pPr>
-            <a:r>
-              <a:rPr lang="en-US" sz="2400" dirty="0">
-                <a:solidFill>
-                  <a:schemeClr val="tx1"/>
-                </a:solidFill>
-                <a:latin typeface="IBM Plex Sans Light" panose="020B0403050203000203" pitchFamily="34" charset="0"/>
-                <a:sym typeface="IBM Plex Sans Light"/>
-              </a:rPr>
-              <a:t>Q &amp; A</a:t>
-            </a:r>
-          </a:p>
-        </p:txBody>
-      </p:sp>
-      <p:sp>
-        <p:nvSpPr>
-          <p:cNvPr id="4" name="Slide Number Placeholder 3">
-            <a:extLst>
-              <a:ext uri="{FF2B5EF4-FFF2-40B4-BE49-F238E27FC236}">
-                <a16:creationId xmlns:a16="http://schemas.microsoft.com/office/drawing/2014/main" id="{CD955A48-AEE2-6292-237C-C83165EC5614}"/>
-              </a:ext>
-            </a:extLst>
-          </p:cNvPr>
-          <p:cNvSpPr>
-            <a:spLocks noGrp="1"/>
-          </p:cNvSpPr>
-          <p:nvPr>
-            <p:ph type="sldNum" sz="quarter" idx="4294967295"/>
-          </p:nvPr>
-        </p:nvSpPr>
-        <p:spPr>
-          <a:xfrm>
-            <a:off x="26796882" y="13061317"/>
-            <a:ext cx="61708" cy="123094"/>
-          </a:xfrm>
-        </p:spPr>
-        <p:txBody>
-          <a:bodyPr/>
-          <a:lstStyle/>
-          <a:p>
-            <a:pPr marL="0" marR="0" lvl="0" indent="0" algn="r" defTabSz="685846" rtl="0" eaLnBrk="1" fontAlgn="auto" latinLnBrk="0" hangingPunct="1">
-              <a:lnSpc>
-                <a:spcPct val="100000"/>
-              </a:lnSpc>
-              <a:spcBef>
-                <a:spcPts val="0"/>
-              </a:spcBef>
-              <a:spcAft>
-                <a:spcPts val="300"/>
-              </a:spcAft>
-              <a:buClrTx/>
-              <a:buSzTx/>
-              <a:buFontTx/>
-              <a:buNone/>
-              <a:tabLst/>
-              <a:defRPr/>
-            </a:pPr>
-            <a:fld id="{59395FB3-9C97-154F-86B2-7E381B951268}" type="slidenum">
-              <a:rPr kumimoji="0" lang="en-US" sz="1200" b="0" i="0" u="none" strike="noStrike" kern="1200" cap="none" spc="0" normalizeH="0" baseline="0" noProof="0" smtClean="0">
-                <a:ln>
-                  <a:noFill/>
-                </a:ln>
-                <a:solidFill>
-                  <a:srgbClr val="000000"/>
-                </a:solidFill>
-                <a:effectLst/>
-                <a:uLnTx/>
-                <a:uFillTx/>
-                <a:latin typeface="Aptos" panose="02110004020202020204"/>
-                <a:ea typeface="+mn-ea"/>
-                <a:cs typeface="+mn-cs"/>
-              </a:rPr>
-              <a:pPr marL="0" marR="0" lvl="0" indent="0" algn="r" defTabSz="685846" rtl="0" eaLnBrk="1" fontAlgn="auto" latinLnBrk="0" hangingPunct="1">
-                <a:lnSpc>
-                  <a:spcPct val="100000"/>
-                </a:lnSpc>
-                <a:spcBef>
-                  <a:spcPts val="0"/>
-                </a:spcBef>
-                <a:spcAft>
-                  <a:spcPts val="300"/>
-                </a:spcAft>
-                <a:buClrTx/>
-                <a:buSzTx/>
-                <a:buFontTx/>
-                <a:buNone/>
-                <a:tabLst/>
-                <a:defRPr/>
-              </a:pPr>
-              <a:t>6</a:t>
-            </a:fld>
-            <a:endParaRPr kumimoji="0" lang="en-US" sz="1200" b="0" i="0" u="none" strike="noStrike" kern="1200" cap="none" spc="0" normalizeH="0" baseline="0" noProof="0" dirty="0">
-              <a:ln>
-                <a:noFill/>
-              </a:ln>
-              <a:solidFill>
-                <a:srgbClr val="000000"/>
-              </a:solidFill>
-              <a:effectLst/>
-              <a:uLnTx/>
-              <a:uFillTx/>
-              <a:latin typeface="Aptos" panose="02110004020202020204"/>
-              <a:ea typeface="+mn-ea"/>
-              <a:cs typeface="+mn-cs"/>
-            </a:endParaRPr>
-          </a:p>
-        </p:txBody>
-      </p:sp>
-    </p:spTree>
-    <p:extLst>
-      <p:ext uri="{BB962C8B-B14F-4D97-AF65-F5344CB8AC3E}">
-        <p14:creationId xmlns:p14="http://schemas.microsoft.com/office/powerpoint/2010/main" val="336288790"/>
-      </p:ext>
-    </p:extLst>
-  </p:cSld>
-  <p:clrMapOvr>
-    <a:masterClrMapping/>
-  </p:clrMapOvr>
-  <p:transition spd="med"/>
-</p:sld>
-</file>
-
-<file path=ppt/slides/slide7.xml><?xml version="1.0" encoding="utf-8"?>
-<p:sld xmlns:a="http://schemas.openxmlformats.org/drawingml/2006/main" xmlns:r="http://schemas.openxmlformats.org/officeDocument/2006/relationships" xmlns:p="http://schemas.openxmlformats.org/presentationml/2006/main">
-  <p:cSld>
-    <p:spTree>
-      <p:nvGrpSpPr>
-        <p:cNvPr id="1" name=""/>
-        <p:cNvGrpSpPr/>
-        <p:nvPr/>
-      </p:nvGrpSpPr>
-      <p:grpSpPr>
-        <a:xfrm>
-          <a:off x="0" y="0"/>
-          <a:ext cx="0" cy="0"/>
-          <a:chOff x="0" y="0"/>
-          <a:chExt cx="0" cy="0"/>
-        </a:xfrm>
-      </p:grpSpPr>
-    </p:spTree>
-    <p:extLst>
-      <p:ext uri="{BB962C8B-B14F-4D97-AF65-F5344CB8AC3E}">
-        <p14:creationId xmlns:p14="http://schemas.microsoft.com/office/powerpoint/2010/main" val="3699106748"/>
-      </p:ext>
-    </p:extLst>
-  </p:cSld>
-  <p:clrMapOvr>
-    <a:masterClrMapping/>
-  </p:clrMapOvr>
-  <p:transition spd="slow">
-    <p:fade/>
-  </p:transition>
-</p:sld>
-</file>
-
-<file path=ppt/slides/slide8.xml><?xml version="1.0" encoding="utf-8"?>
 <p:sld xmlns:a="http://schemas.openxmlformats.org/drawingml/2006/main" xmlns:p="http://schemas.openxmlformats.org/presentationml/2006/main" xmlns:r="http://schemas.openxmlformats.org/officeDocument/2006/relationships">
   <p:cSld>
     <p:spTree>
@@ -52577,6 +52368,744 @@
                 <a:latin typeface="IBM Plex Sans"/>
               </a:rPr>
               <a:t>The judgment stays human; the toil disappears.</a:t>
+            </a:r>
+          </a:p>
+        </p:txBody>
+      </p:sp>
+    </p:spTree>
+  </p:cSld>
+  <p:clrMapOvr>
+    <a:masterClrMapping/>
+  </p:clrMapOvr>
+</p:sld>
+</file>
+
+<file path=ppt/slides/slide7.xml><?xml version="1.0" encoding="utf-8"?>
+<p:sld xmlns:a="http://schemas.openxmlformats.org/drawingml/2006/main" xmlns:r="http://schemas.openxmlformats.org/officeDocument/2006/relationships" xmlns:p="http://schemas.openxmlformats.org/presentationml/2006/main">
+  <p:cSld>
+    <p:spTree>
+      <p:nvGrpSpPr>
+        <p:cNvPr id="1" name="">
+          <a:extLst>
+            <a:ext uri="{FF2B5EF4-FFF2-40B4-BE49-F238E27FC236}">
+              <a16:creationId xmlns:a16="http://schemas.microsoft.com/office/drawing/2014/main" id="{EDDF2B97-92CD-2466-3B01-5C84E1221AED}"/>
+            </a:ext>
+          </a:extLst>
+        </p:cNvPr>
+        <p:cNvGrpSpPr/>
+        <p:nvPr/>
+      </p:nvGrpSpPr>
+      <p:grpSpPr>
+        <a:xfrm>
+          <a:off x="0" y="0"/>
+          <a:ext cx="0" cy="0"/>
+          <a:chOff x="0" y="0"/>
+          <a:chExt cx="0" cy="0"/>
+        </a:xfrm>
+      </p:grpSpPr>
+      <p:sp>
+        <p:nvSpPr>
+          <p:cNvPr id="2" name="Title 1">
+            <a:extLst>
+              <a:ext uri="{FF2B5EF4-FFF2-40B4-BE49-F238E27FC236}">
+                <a16:creationId xmlns:a16="http://schemas.microsoft.com/office/drawing/2014/main" id="{A4655D6E-26DC-B3EE-14A0-D924B77032C9}"/>
+              </a:ext>
+            </a:extLst>
+          </p:cNvPr>
+          <p:cNvSpPr>
+            <a:spLocks noGrp="1"/>
+          </p:cNvSpPr>
+          <p:nvPr>
+            <p:ph type="title"/>
+          </p:nvPr>
+        </p:nvSpPr>
+        <p:spPr>
+          <a:xfrm>
+            <a:off x="5637821" y="3143684"/>
+            <a:ext cx="916358" cy="570632"/>
+          </a:xfrm>
+        </p:spPr>
+        <p:txBody>
+          <a:bodyPr vert="horz" lIns="0" tIns="0" rIns="0" bIns="0" rtlCol="0" anchor="ctr">
+            <a:noAutofit/>
+          </a:bodyPr>
+          <a:lstStyle/>
+          <a:p>
+            <a:pPr algn="ctr">
+              <a:lnSpc>
+                <a:spcPct val="90000"/>
+              </a:lnSpc>
+            </a:pPr>
+            <a:r>
+              <a:rPr lang="en-US" sz="2400" dirty="0">
+                <a:solidFill>
+                  <a:schemeClr val="tx1"/>
+                </a:solidFill>
+                <a:latin typeface="IBM Plex Sans Light" panose="020B0403050203000203" pitchFamily="34" charset="0"/>
+                <a:sym typeface="IBM Plex Sans Light"/>
+              </a:rPr>
+              <a:t>Q &amp; A</a:t>
+            </a:r>
+          </a:p>
+        </p:txBody>
+      </p:sp>
+      <p:sp>
+        <p:nvSpPr>
+          <p:cNvPr id="4" name="Slide Number Placeholder 3">
+            <a:extLst>
+              <a:ext uri="{FF2B5EF4-FFF2-40B4-BE49-F238E27FC236}">
+                <a16:creationId xmlns:a16="http://schemas.microsoft.com/office/drawing/2014/main" id="{CD955A48-AEE2-6292-237C-C83165EC5614}"/>
+              </a:ext>
+            </a:extLst>
+          </p:cNvPr>
+          <p:cNvSpPr>
+            <a:spLocks noGrp="1"/>
+          </p:cNvSpPr>
+          <p:nvPr>
+            <p:ph type="sldNum" sz="quarter" idx="4294967295"/>
+          </p:nvPr>
+        </p:nvSpPr>
+        <p:spPr>
+          <a:xfrm>
+            <a:off x="26796882" y="13061317"/>
+            <a:ext cx="61708" cy="123094"/>
+          </a:xfrm>
+        </p:spPr>
+        <p:txBody>
+          <a:bodyPr/>
+          <a:lstStyle/>
+          <a:p>
+            <a:pPr marL="0" marR="0" lvl="0" indent="0" algn="r" defTabSz="685846" rtl="0" eaLnBrk="1" fontAlgn="auto" latinLnBrk="0" hangingPunct="1">
+              <a:lnSpc>
+                <a:spcPct val="100000"/>
+              </a:lnSpc>
+              <a:spcBef>
+                <a:spcPts val="0"/>
+              </a:spcBef>
+              <a:spcAft>
+                <a:spcPts val="300"/>
+              </a:spcAft>
+              <a:buClrTx/>
+              <a:buSzTx/>
+              <a:buFontTx/>
+              <a:buNone/>
+              <a:tabLst/>
+              <a:defRPr/>
+            </a:pPr>
+            <a:fld id="{59395FB3-9C97-154F-86B2-7E381B951268}" type="slidenum">
+              <a:rPr kumimoji="0" lang="en-US" sz="1200" b="0" i="0" u="none" strike="noStrike" kern="1200" cap="none" spc="0" normalizeH="0" baseline="0" noProof="0" smtClean="0">
+                <a:ln>
+                  <a:noFill/>
+                </a:ln>
+                <a:solidFill>
+                  <a:srgbClr val="000000"/>
+                </a:solidFill>
+                <a:effectLst/>
+                <a:uLnTx/>
+                <a:uFillTx/>
+                <a:latin typeface="Aptos" panose="02110004020202020204"/>
+                <a:ea typeface="+mn-ea"/>
+                <a:cs typeface="+mn-cs"/>
+              </a:rPr>
+              <a:pPr marL="0" marR="0" lvl="0" indent="0" algn="r" defTabSz="685846" rtl="0" eaLnBrk="1" fontAlgn="auto" latinLnBrk="0" hangingPunct="1">
+                <a:lnSpc>
+                  <a:spcPct val="100000"/>
+                </a:lnSpc>
+                <a:spcBef>
+                  <a:spcPts val="0"/>
+                </a:spcBef>
+                <a:spcAft>
+                  <a:spcPts val="300"/>
+                </a:spcAft>
+                <a:buClrTx/>
+                <a:buSzTx/>
+                <a:buFontTx/>
+                <a:buNone/>
+                <a:tabLst/>
+                <a:defRPr/>
+              </a:pPr>
+              <a:t>6</a:t>
+            </a:fld>
+            <a:endParaRPr kumimoji="0" lang="en-US" sz="1200" b="0" i="0" u="none" strike="noStrike" kern="1200" cap="none" spc="0" normalizeH="0" baseline="0" noProof="0" dirty="0">
+              <a:ln>
+                <a:noFill/>
+              </a:ln>
+              <a:solidFill>
+                <a:srgbClr val="000000"/>
+              </a:solidFill>
+              <a:effectLst/>
+              <a:uLnTx/>
+              <a:uFillTx/>
+              <a:latin typeface="Aptos" panose="02110004020202020204"/>
+              <a:ea typeface="+mn-ea"/>
+              <a:cs typeface="+mn-cs"/>
+            </a:endParaRPr>
+          </a:p>
+        </p:txBody>
+      </p:sp>
+    </p:spTree>
+    <p:extLst>
+      <p:ext uri="{BB962C8B-B14F-4D97-AF65-F5344CB8AC3E}">
+        <p14:creationId xmlns:p14="http://schemas.microsoft.com/office/powerpoint/2010/main" val="336288790"/>
+      </p:ext>
+    </p:extLst>
+  </p:cSld>
+  <p:clrMapOvr>
+    <a:masterClrMapping/>
+  </p:clrMapOvr>
+  <p:transition spd="med"/>
+</p:sld>
+</file>
+
+<file path=ppt/slides/slide8.xml><?xml version="1.0" encoding="utf-8"?>
+<p:sld xmlns:a="http://schemas.openxmlformats.org/drawingml/2006/main" xmlns:r="http://schemas.openxmlformats.org/officeDocument/2006/relationships" xmlns:p="http://schemas.openxmlformats.org/presentationml/2006/main">
+  <p:cSld>
+    <p:spTree>
+      <p:nvGrpSpPr>
+        <p:cNvPr id="1" name=""/>
+        <p:cNvGrpSpPr/>
+        <p:nvPr/>
+      </p:nvGrpSpPr>
+      <p:grpSpPr>
+        <a:xfrm>
+          <a:off x="0" y="0"/>
+          <a:ext cx="0" cy="0"/>
+          <a:chOff x="0" y="0"/>
+          <a:chExt cx="0" cy="0"/>
+        </a:xfrm>
+      </p:grpSpPr>
+    </p:spTree>
+    <p:extLst>
+      <p:ext uri="{BB962C8B-B14F-4D97-AF65-F5344CB8AC3E}">
+        <p14:creationId xmlns:p14="http://schemas.microsoft.com/office/powerpoint/2010/main" val="3699106748"/>
+      </p:ext>
+    </p:extLst>
+  </p:cSld>
+  <p:clrMapOvr>
+    <a:masterClrMapping/>
+  </p:clrMapOvr>
+  <p:transition spd="slow">
+    <p:fade/>
+  </p:transition>
+</p:sld>
+</file>
+
+<file path=ppt/slides/slide9.xml><?xml version="1.0" encoding="utf-8"?>
+<p:sld xmlns:a="http://schemas.openxmlformats.org/drawingml/2006/main" xmlns:p="http://schemas.openxmlformats.org/presentationml/2006/main" xmlns:r="http://schemas.openxmlformats.org/officeDocument/2006/relationships">
+  <p:cSld>
+    <p:spTree>
+      <p:nvGrpSpPr>
+        <p:cNvPr id="1" name=""/>
+        <p:cNvGrpSpPr/>
+        <p:nvPr/>
+      </p:nvGrpSpPr>
+      <p:grpSpPr/>
+      <p:pic>
+        <p:nvPicPr>
+          <p:cNvPr id="2" name="Picture 1" descr="image.png"/>
+          <p:cNvPicPr>
+            <a:picLocks noChangeAspect="1"/>
+          </p:cNvPicPr>
+          <p:nvPr/>
+        </p:nvPicPr>
+        <p:blipFill>
+          <a:blip r:embed="rId2"/>
+          <a:stretch>
+            <a:fillRect/>
+          </a:stretch>
+        </p:blipFill>
+        <p:spPr>
+          <a:xfrm>
+            <a:off x="0" y="91440"/>
+            <a:ext cx="1563624" cy="1563624"/>
+          </a:xfrm>
+          <a:prstGeom prst="rect">
+            <a:avLst/>
+          </a:prstGeom>
+        </p:spPr>
+      </p:pic>
+      <p:sp>
+        <p:nvSpPr>
+          <p:cNvPr id="3" name="TextBox 2"/>
+          <p:cNvSpPr txBox="1"/>
+          <p:nvPr/>
+        </p:nvSpPr>
+        <p:spPr>
+          <a:xfrm>
+            <a:off x="1563624" y="310896"/>
+            <a:ext cx="9418320" cy="640080"/>
+          </a:xfrm>
+          <a:prstGeom prst="rect">
+            <a:avLst/>
+          </a:prstGeom>
+          <a:noFill/>
+        </p:spPr>
+        <p:txBody>
+          <a:bodyPr wrap="square" anchor="t" lIns="0" rIns="0" tIns="0" bIns="0">
+            <a:spAutoFit/>
+          </a:bodyPr>
+          <a:lstStyle/>
+          <a:p>
+            <a:pPr algn="l"/>
+            <a:r>
+              <a:rPr sz="2900" b="0" i="0">
+                <a:solidFill>
+                  <a:srgbClr val="525252"/>
+                </a:solidFill>
+                <a:latin typeface="IBM Plex Sans Light"/>
+              </a:rPr>
+              <a:t>AI alone  vs  AI + Bob</a:t>
+            </a:r>
+          </a:p>
+        </p:txBody>
+      </p:sp>
+      <p:sp>
+        <p:nvSpPr>
+          <p:cNvPr id="4" name="TextBox 3"/>
+          <p:cNvSpPr txBox="1"/>
+          <p:nvPr/>
+        </p:nvSpPr>
+        <p:spPr>
+          <a:xfrm>
+            <a:off x="1563624" y="969264"/>
+            <a:ext cx="9601200" cy="457200"/>
+          </a:xfrm>
+          <a:prstGeom prst="rect">
+            <a:avLst/>
+          </a:prstGeom>
+          <a:noFill/>
+        </p:spPr>
+        <p:txBody>
+          <a:bodyPr wrap="square" anchor="t" lIns="0" rIns="0" tIns="0" bIns="0">
+            <a:spAutoFit/>
+          </a:bodyPr>
+          <a:lstStyle/>
+          <a:p>
+            <a:pPr algn="l"/>
+            <a:r>
+              <a:rPr sz="1350" b="0" i="1">
+                <a:solidFill>
+                  <a:srgbClr val="0F62FE"/>
+                </a:solidFill>
+                <a:latin typeface="IBM Plex Sans"/>
+              </a:rPr>
+              <a:t>Bob isn't a different AI — it's the same model, made enterprise-ready.</a:t>
+            </a:r>
+          </a:p>
+        </p:txBody>
+      </p:sp>
+      <p:sp>
+        <p:nvSpPr>
+          <p:cNvPr id="5" name="Rounded Rectangle 4"/>
+          <p:cNvSpPr/>
+          <p:nvPr/>
+        </p:nvSpPr>
+        <p:spPr>
+          <a:xfrm>
+            <a:off x="457200" y="1783080"/>
+            <a:ext cx="5349240" cy="3383280"/>
+          </a:xfrm>
+          <a:prstGeom prst="roundRect">
+            <a:avLst>
+              <a:gd name="adj" fmla="val 4500"/>
+            </a:avLst>
+          </a:prstGeom>
+          <a:solidFill>
+            <a:srgbClr val="F2F4F8"/>
+          </a:solidFill>
+          <a:ln w="9525">
+            <a:solidFill>
+              <a:srgbClr val="C7CBD6"/>
+            </a:solidFill>
+          </a:ln>
+          <a:effectLst/>
+        </p:spPr>
+        <p:style>
+          <a:lnRef idx="1">
+            <a:schemeClr val="accent1"/>
+          </a:lnRef>
+          <a:fillRef idx="3">
+            <a:schemeClr val="accent1"/>
+          </a:fillRef>
+          <a:effectRef idx="2">
+            <a:schemeClr val="accent1"/>
+          </a:effectRef>
+          <a:fontRef idx="minor">
+            <a:schemeClr val="lt1"/>
+          </a:fontRef>
+        </p:style>
+        <p:txBody>
+          <a:bodyPr rtlCol="0" anchor="t" wrap="square" lIns="228600" rIns="203200" tIns="279400" bIns="152400"/>
+          <a:lstStyle/>
+          <a:p>
+            <a:pPr algn="ctr">
+              <a:spcAft>
+                <a:spcPts val="1600"/>
+              </a:spcAft>
+            </a:pPr>
+            <a:r>
+              <a:rPr sz="1700" b="1">
+                <a:solidFill>
+                  <a:srgbClr val="525252"/>
+                </a:solidFill>
+                <a:latin typeface="IBM Plex Sans"/>
+              </a:rPr>
+              <a:t>AI alone — a generic assistant</a:t>
+            </a:r>
+          </a:p>
+          <a:p>
+            <a:pPr>
+              <a:spcAft>
+                <a:spcPts val="1400"/>
+              </a:spcAft>
+            </a:pPr>
+            <a:r>
+              <a:rPr sz="1350" b="1">
+                <a:solidFill>
+                  <a:srgbClr val="525252"/>
+                </a:solidFill>
+                <a:latin typeface="IBM Plex Sans"/>
+              </a:rPr>
+              <a:t>•  </a:t>
+            </a:r>
+            <a:r>
+              <a:rPr sz="1350" b="0">
+                <a:solidFill>
+                  <a:srgbClr val="393939"/>
+                </a:solidFill>
+                <a:latin typeface="IBM Plex Sans"/>
+              </a:rPr>
+              <a:t>Improvises per prompt — output varies with phrasing</a:t>
+            </a:r>
+          </a:p>
+          <a:p>
+            <a:pPr>
+              <a:spcAft>
+                <a:spcPts val="1400"/>
+              </a:spcAft>
+            </a:pPr>
+            <a:r>
+              <a:rPr sz="1350" b="1">
+                <a:solidFill>
+                  <a:srgbClr val="525252"/>
+                </a:solidFill>
+                <a:latin typeface="IBM Plex Sans"/>
+              </a:rPr>
+              <a:t>•  </a:t>
+            </a:r>
+            <a:r>
+              <a:rPr sz="1350" b="0">
+                <a:solidFill>
+                  <a:srgbClr val="393939"/>
+                </a:solidFill>
+                <a:latin typeface="IBM Plex Sans"/>
+              </a:rPr>
+              <a:t>No enterprise methodology or guardrails</a:t>
+            </a:r>
+          </a:p>
+          <a:p>
+            <a:pPr>
+              <a:spcAft>
+                <a:spcPts val="1400"/>
+              </a:spcAft>
+            </a:pPr>
+            <a:r>
+              <a:rPr sz="1350" b="1">
+                <a:solidFill>
+                  <a:srgbClr val="525252"/>
+                </a:solidFill>
+                <a:latin typeface="IBM Plex Sans"/>
+              </a:rPr>
+              <a:t>•  </a:t>
+            </a:r>
+            <a:r>
+              <a:rPr sz="1350" b="0">
+                <a:solidFill>
+                  <a:srgbClr val="393939"/>
+                </a:solidFill>
+                <a:latin typeface="IBM Plex Sans"/>
+              </a:rPr>
+              <a:t>Generic — no access to your systems or the IBM stack</a:t>
+            </a:r>
+          </a:p>
+          <a:p>
+            <a:pPr>
+              <a:spcAft>
+                <a:spcPts val="1400"/>
+              </a:spcAft>
+            </a:pPr>
+            <a:r>
+              <a:rPr sz="1350" b="1">
+                <a:solidFill>
+                  <a:srgbClr val="525252"/>
+                </a:solidFill>
+                <a:latin typeface="IBM Plex Sans"/>
+              </a:rPr>
+              <a:t>•  </a:t>
+            </a:r>
+            <a:r>
+              <a:rPr sz="1350" b="0">
+                <a:solidFill>
+                  <a:srgbClr val="393939"/>
+                </a:solidFill>
+                <a:latin typeface="IBM Plex Sans"/>
+              </a:rPr>
+              <a:t>Black box — no built-in review or audit trail</a:t>
+            </a:r>
+          </a:p>
+          <a:p>
+            <a:pPr>
+              <a:spcAft>
+                <a:spcPts val="1400"/>
+              </a:spcAft>
+            </a:pPr>
+            <a:r>
+              <a:rPr sz="1350" b="1">
+                <a:solidFill>
+                  <a:srgbClr val="525252"/>
+                </a:solidFill>
+                <a:latin typeface="IBM Plex Sans"/>
+              </a:rPr>
+              <a:t>•  </a:t>
+            </a:r>
+            <a:r>
+              <a:rPr sz="1350" b="0">
+                <a:solidFill>
+                  <a:srgbClr val="393939"/>
+                </a:solidFill>
+                <a:latin typeface="IBM Plex Sans"/>
+              </a:rPr>
+              <a:t>Stateless — you re-explain the context every time</a:t>
+            </a:r>
+          </a:p>
+        </p:txBody>
+      </p:sp>
+      <p:sp>
+        <p:nvSpPr>
+          <p:cNvPr id="6" name="Rounded Rectangle 5"/>
+          <p:cNvSpPr/>
+          <p:nvPr/>
+        </p:nvSpPr>
+        <p:spPr>
+          <a:xfrm>
+            <a:off x="6382512" y="1783080"/>
+            <a:ext cx="5349240" cy="3383280"/>
+          </a:xfrm>
+          <a:prstGeom prst="roundRect">
+            <a:avLst>
+              <a:gd name="adj" fmla="val 4500"/>
+            </a:avLst>
+          </a:prstGeom>
+          <a:solidFill>
+            <a:srgbClr val="EDF2FF"/>
+          </a:solidFill>
+          <a:ln w="15875">
+            <a:solidFill>
+              <a:srgbClr val="0F62FE"/>
+            </a:solidFill>
+          </a:ln>
+          <a:effectLst/>
+        </p:spPr>
+        <p:style>
+          <a:lnRef idx="1">
+            <a:schemeClr val="accent1"/>
+          </a:lnRef>
+          <a:fillRef idx="3">
+            <a:schemeClr val="accent1"/>
+          </a:fillRef>
+          <a:effectRef idx="2">
+            <a:schemeClr val="accent1"/>
+          </a:effectRef>
+          <a:fontRef idx="minor">
+            <a:schemeClr val="lt1"/>
+          </a:fontRef>
+        </p:style>
+        <p:txBody>
+          <a:bodyPr rtlCol="0" anchor="t" wrap="square" lIns="228600" rIns="203200" tIns="279400" bIns="152400"/>
+          <a:lstStyle/>
+          <a:p>
+            <a:pPr algn="ctr">
+              <a:spcAft>
+                <a:spcPts val="1600"/>
+              </a:spcAft>
+            </a:pPr>
+            <a:r>
+              <a:rPr sz="1700" b="1">
+                <a:solidFill>
+                  <a:srgbClr val="0F62FE"/>
+                </a:solidFill>
+                <a:latin typeface="IBM Plex Sans"/>
+              </a:rPr>
+              <a:t>AI + Bob — enterprise-ready</a:t>
+            </a:r>
+          </a:p>
+          <a:p>
+            <a:pPr>
+              <a:spcAft>
+                <a:spcPts val="1400"/>
+              </a:spcAft>
+            </a:pPr>
+            <a:r>
+              <a:rPr sz="1350" b="1">
+                <a:solidFill>
+                  <a:srgbClr val="0F62FE"/>
+                </a:solidFill>
+                <a:latin typeface="IBM Plex Sans"/>
+              </a:rPr>
+              <a:t>+  </a:t>
+            </a:r>
+            <a:r>
+              <a:rPr sz="1350" b="0">
+                <a:solidFill>
+                  <a:srgbClr val="161616"/>
+                </a:solidFill>
+                <a:latin typeface="IBM Plex Sans"/>
+              </a:rPr>
+              <a:t>Specialized modes &amp; playbooks (e.g. /java-modernization)</a:t>
+            </a:r>
+          </a:p>
+          <a:p>
+            <a:pPr>
+              <a:spcAft>
+                <a:spcPts val="1400"/>
+              </a:spcAft>
+            </a:pPr>
+            <a:r>
+              <a:rPr sz="1350" b="1">
+                <a:solidFill>
+                  <a:srgbClr val="0F62FE"/>
+                </a:solidFill>
+                <a:latin typeface="IBM Plex Sans"/>
+              </a:rPr>
+              <a:t>+  </a:t>
+            </a:r>
+            <a:r>
+              <a:rPr sz="1350" b="0">
+                <a:solidFill>
+                  <a:srgbClr val="161616"/>
+                </a:solidFill>
+                <a:latin typeface="IBM Plex Sans"/>
+              </a:rPr>
+              <a:t>Skills &amp; MCP servers — TechZone, watsonx Orchestrate, web</a:t>
+            </a:r>
+          </a:p>
+          <a:p>
+            <a:pPr>
+              <a:spcAft>
+                <a:spcPts val="1400"/>
+              </a:spcAft>
+            </a:pPr>
+            <a:r>
+              <a:rPr sz="1350" b="1">
+                <a:solidFill>
+                  <a:srgbClr val="0F62FE"/>
+                </a:solidFill>
+                <a:latin typeface="IBM Plex Sans"/>
+              </a:rPr>
+              <a:t>+  </a:t>
+            </a:r>
+            <a:r>
+              <a:rPr sz="1350" b="0">
+                <a:solidFill>
+                  <a:srgbClr val="161616"/>
+                </a:solidFill>
+                <a:latin typeface="IBM Plex Sans"/>
+              </a:rPr>
+              <a:t>Native IBM stack — Liberty, Semeru, IBM Cloud, Code Engine</a:t>
+            </a:r>
+          </a:p>
+          <a:p>
+            <a:pPr>
+              <a:spcAft>
+                <a:spcPts val="1400"/>
+              </a:spcAft>
+            </a:pPr>
+            <a:r>
+              <a:rPr sz="1350" b="1">
+                <a:solidFill>
+                  <a:srgbClr val="0F62FE"/>
+                </a:solidFill>
+                <a:latin typeface="IBM Plex Sans"/>
+              </a:rPr>
+              <a:t>+  </a:t>
+            </a:r>
+            <a:r>
+              <a:rPr sz="1350" b="0">
+                <a:solidFill>
+                  <a:srgbClr val="161616"/>
+                </a:solidFill>
+                <a:latin typeface="IBM Plex Sans"/>
+              </a:rPr>
+              <a:t>Per-file approval, build-green discipline, full diff audit</a:t>
+            </a:r>
+          </a:p>
+          <a:p>
+            <a:pPr>
+              <a:spcAft>
+                <a:spcPts val="1400"/>
+              </a:spcAft>
+            </a:pPr>
+            <a:r>
+              <a:rPr sz="1350" b="1">
+                <a:solidFill>
+                  <a:srgbClr val="0F62FE"/>
+                </a:solidFill>
+                <a:latin typeface="IBM Plex Sans"/>
+              </a:rPr>
+              <a:t>+  </a:t>
+            </a:r>
+            <a:r>
+              <a:rPr sz="1350" b="0">
+                <a:solidFill>
+                  <a:srgbClr val="161616"/>
+                </a:solidFill>
+                <a:latin typeface="IBM Plex Sans"/>
+              </a:rPr>
+              <a:t>Knowledge baked in, reused across the whole estate</a:t>
+            </a:r>
+          </a:p>
+        </p:txBody>
+      </p:sp>
+      <p:sp>
+        <p:nvSpPr>
+          <p:cNvPr id="7" name="TextBox 6"/>
+          <p:cNvSpPr txBox="1"/>
+          <p:nvPr/>
+        </p:nvSpPr>
+        <p:spPr>
+          <a:xfrm>
+            <a:off x="457200" y="5806440"/>
+            <a:ext cx="11274552" cy="640080"/>
+          </a:xfrm>
+          <a:prstGeom prst="rect">
+            <a:avLst/>
+          </a:prstGeom>
+          <a:noFill/>
+        </p:spPr>
+        <p:txBody>
+          <a:bodyPr wrap="square" anchor="t" lIns="0" rIns="0" tIns="0" bIns="0">
+            <a:spAutoFit/>
+          </a:bodyPr>
+          <a:lstStyle/>
+          <a:p>
+            <a:pPr algn="l"/>
+            <a:r>
+              <a:rPr sz="1400" b="1" i="0">
+                <a:solidFill>
+                  <a:srgbClr val="0E2841"/>
+                </a:solidFill>
+                <a:latin typeface="IBM Plex Sans"/>
+              </a:rPr>
+              <a:t>Same AI horsepower — </a:t>
+            </a:r>
+            <a:r>
+              <a:rPr sz="1400" b="0" i="1">
+                <a:solidFill>
+                  <a:srgbClr val="525252"/>
+                </a:solidFill>
+                <a:latin typeface="IBM Plex Sans"/>
+              </a:rPr>
+              <a:t>plus the methodology, tools, and governance an enterprise needs.</a:t>
             </a:r>
           </a:p>
         </p:txBody>

</xml_diff>

<commit_message>
docs: add "What IBM says about Bob" slide (official IBM figures)
Stat-callout slide with IBM's official metrics (20–80% productivity, 90%+ time
savings, 20–40% faster, ~40% lower compute) and the scale/security/governance
pillars, sourced from ibm.com/products/ai-coding-agent. Inserted after the
"AI vs AI + Bob" slide.

Co-Authored-By: Claude Opus 4.8 (1M context) <noreply@anthropic.com>
</commit_message>
<xml_diff>
--- a/docs/bob-java-modernization-orchestrate.pptx
+++ b/docs/bob-java-modernization-orchestrate.pptx
@@ -17,6 +17,7 @@
     <p:sldId id="2147483259" r:id="rId8"/>
     <p:sldId id="2147483260" r:id="rId17"/>
     <p:sldId id="2147483261" r:id="rId18"/>
+    <p:sldId id="2147483262" r:id="rId19"/>
     <p:sldId id="2147483258" r:id="rId9"/>
     <p:sldId id="2147469197" r:id="rId10"/>
   </p:sldIdLst>
@@ -49733,6 +49734,781 @@
 </p:sld>
 </file>
 
+<file path=ppt/slides/slide10.xml><?xml version="1.0" encoding="utf-8"?>
+<p:sld xmlns:a="http://schemas.openxmlformats.org/drawingml/2006/main" xmlns:p="http://schemas.openxmlformats.org/presentationml/2006/main" xmlns:r="http://schemas.openxmlformats.org/officeDocument/2006/relationships">
+  <p:cSld>
+    <p:spTree>
+      <p:nvGrpSpPr>
+        <p:cNvPr id="1" name=""/>
+        <p:cNvGrpSpPr/>
+        <p:nvPr/>
+      </p:nvGrpSpPr>
+      <p:grpSpPr/>
+      <p:pic>
+        <p:nvPicPr>
+          <p:cNvPr id="2" name="Picture 1" descr="image.png"/>
+          <p:cNvPicPr>
+            <a:picLocks noChangeAspect="1"/>
+          </p:cNvPicPr>
+          <p:nvPr/>
+        </p:nvPicPr>
+        <p:blipFill>
+          <a:blip r:embed="rId2"/>
+          <a:stretch>
+            <a:fillRect/>
+          </a:stretch>
+        </p:blipFill>
+        <p:spPr>
+          <a:xfrm>
+            <a:off x="0" y="91440"/>
+            <a:ext cx="1563624" cy="1563624"/>
+          </a:xfrm>
+          <a:prstGeom prst="rect">
+            <a:avLst/>
+          </a:prstGeom>
+        </p:spPr>
+      </p:pic>
+      <p:sp>
+        <p:nvSpPr>
+          <p:cNvPr id="3" name="TextBox 2"/>
+          <p:cNvSpPr txBox="1"/>
+          <p:nvPr/>
+        </p:nvSpPr>
+        <p:spPr>
+          <a:xfrm>
+            <a:off x="1563624" y="310896"/>
+            <a:ext cx="9509760" cy="640080"/>
+          </a:xfrm>
+          <a:prstGeom prst="rect">
+            <a:avLst/>
+          </a:prstGeom>
+          <a:noFill/>
+        </p:spPr>
+        <p:txBody>
+          <a:bodyPr wrap="square" anchor="t" lIns="0" rIns="0" tIns="0" bIns="0">
+            <a:spAutoFit/>
+          </a:bodyPr>
+          <a:lstStyle/>
+          <a:p>
+            <a:pPr algn="l">
+              <a:spcAft>
+                <a:spcPts val="0"/>
+              </a:spcAft>
+            </a:pPr>
+            <a:r>
+              <a:rPr sz="2900" b="0" i="0">
+                <a:solidFill>
+                  <a:srgbClr val="525252"/>
+                </a:solidFill>
+                <a:latin typeface="IBM Plex Sans Light"/>
+              </a:rPr>
+              <a:t>What IBM says about Bob</a:t>
+            </a:r>
+          </a:p>
+        </p:txBody>
+      </p:sp>
+      <p:sp>
+        <p:nvSpPr>
+          <p:cNvPr id="4" name="TextBox 3"/>
+          <p:cNvSpPr txBox="1"/>
+          <p:nvPr/>
+        </p:nvSpPr>
+        <p:spPr>
+          <a:xfrm>
+            <a:off x="1563624" y="969264"/>
+            <a:ext cx="9692640" cy="457200"/>
+          </a:xfrm>
+          <a:prstGeom prst="rect">
+            <a:avLst/>
+          </a:prstGeom>
+          <a:noFill/>
+        </p:spPr>
+        <p:txBody>
+          <a:bodyPr wrap="square" anchor="t" lIns="0" rIns="0" tIns="0" bIns="0">
+            <a:spAutoFit/>
+          </a:bodyPr>
+          <a:lstStyle/>
+          <a:p>
+            <a:pPr algn="l">
+              <a:spcAft>
+                <a:spcPts val="0"/>
+              </a:spcAft>
+            </a:pPr>
+            <a:r>
+              <a:rPr sz="1350" b="0" i="1">
+                <a:solidFill>
+                  <a:srgbClr val="0F62FE"/>
+                </a:solidFill>
+                <a:latin typeface="IBM Plex Sans"/>
+              </a:rPr>
+              <a:t>Faster innovation, higher productivity — built for scale, security and governance.</a:t>
+            </a:r>
+          </a:p>
+        </p:txBody>
+      </p:sp>
+      <p:sp>
+        <p:nvSpPr>
+          <p:cNvPr id="5" name="TextBox 4"/>
+          <p:cNvSpPr txBox="1"/>
+          <p:nvPr/>
+        </p:nvSpPr>
+        <p:spPr>
+          <a:xfrm>
+            <a:off x="457200" y="1828800"/>
+            <a:ext cx="2743200" cy="868680"/>
+          </a:xfrm>
+          <a:prstGeom prst="rect">
+            <a:avLst/>
+          </a:prstGeom>
+          <a:noFill/>
+        </p:spPr>
+        <p:txBody>
+          <a:bodyPr wrap="square" anchor="ctr" lIns="0" rIns="0" tIns="0" bIns="0">
+            <a:spAutoFit/>
+          </a:bodyPr>
+          <a:lstStyle/>
+          <a:p>
+            <a:pPr algn="ctr">
+              <a:spcAft>
+                <a:spcPts val="0"/>
+              </a:spcAft>
+            </a:pPr>
+            <a:r>
+              <a:rPr sz="4400" b="1" i="0">
+                <a:solidFill>
+                  <a:srgbClr val="0F62FE"/>
+                </a:solidFill>
+                <a:latin typeface="IBM Plex Sans"/>
+              </a:rPr>
+              <a:t>20–80%</a:t>
+            </a:r>
+          </a:p>
+        </p:txBody>
+      </p:sp>
+      <p:sp>
+        <p:nvSpPr>
+          <p:cNvPr id="6" name="TextBox 5"/>
+          <p:cNvSpPr txBox="1"/>
+          <p:nvPr/>
+        </p:nvSpPr>
+        <p:spPr>
+          <a:xfrm>
+            <a:off x="457200" y="2724912"/>
+            <a:ext cx="2743200" cy="640080"/>
+          </a:xfrm>
+          <a:prstGeom prst="rect">
+            <a:avLst/>
+          </a:prstGeom>
+          <a:noFill/>
+        </p:spPr>
+        <p:txBody>
+          <a:bodyPr wrap="square" anchor="t" lIns="0" rIns="0" tIns="0" bIns="0">
+            <a:spAutoFit/>
+          </a:bodyPr>
+          <a:lstStyle/>
+          <a:p>
+            <a:pPr algn="ctr">
+              <a:spcAft>
+                <a:spcPts val="0"/>
+              </a:spcAft>
+            </a:pPr>
+            <a:r>
+              <a:rPr sz="1250" b="0" i="0">
+                <a:solidFill>
+                  <a:srgbClr val="525252"/>
+                </a:solidFill>
+                <a:latin typeface="IBM Plex Sans"/>
+              </a:rPr>
+              <a:t>productivity gains</a:t>
+            </a:r>
+          </a:p>
+          <a:p>
+            <a:pPr algn="ctr">
+              <a:spcAft>
+                <a:spcPts val="0"/>
+              </a:spcAft>
+            </a:pPr>
+            <a:r>
+              <a:rPr sz="1250" b="0" i="0">
+                <a:solidFill>
+                  <a:srgbClr val="525252"/>
+                </a:solidFill>
+                <a:latin typeface="IBM Plex Sans"/>
+              </a:rPr>
+              <a:t>across SDLC tasks</a:t>
+            </a:r>
+          </a:p>
+        </p:txBody>
+      </p:sp>
+      <p:sp>
+        <p:nvSpPr>
+          <p:cNvPr id="7" name="TextBox 6"/>
+          <p:cNvSpPr txBox="1"/>
+          <p:nvPr/>
+        </p:nvSpPr>
+        <p:spPr>
+          <a:xfrm>
+            <a:off x="3273552" y="1828800"/>
+            <a:ext cx="2743200" cy="868680"/>
+          </a:xfrm>
+          <a:prstGeom prst="rect">
+            <a:avLst/>
+          </a:prstGeom>
+          <a:noFill/>
+        </p:spPr>
+        <p:txBody>
+          <a:bodyPr wrap="square" anchor="ctr" lIns="0" rIns="0" tIns="0" bIns="0">
+            <a:spAutoFit/>
+          </a:bodyPr>
+          <a:lstStyle/>
+          <a:p>
+            <a:pPr algn="ctr">
+              <a:spcAft>
+                <a:spcPts val="0"/>
+              </a:spcAft>
+            </a:pPr>
+            <a:r>
+              <a:rPr sz="4400" b="1" i="0">
+                <a:solidFill>
+                  <a:srgbClr val="0F62FE"/>
+                </a:solidFill>
+                <a:latin typeface="IBM Plex Sans"/>
+              </a:rPr>
+              <a:t>90%+</a:t>
+            </a:r>
+          </a:p>
+        </p:txBody>
+      </p:sp>
+      <p:sp>
+        <p:nvSpPr>
+          <p:cNvPr id="8" name="TextBox 7"/>
+          <p:cNvSpPr txBox="1"/>
+          <p:nvPr/>
+        </p:nvSpPr>
+        <p:spPr>
+          <a:xfrm>
+            <a:off x="3273552" y="2724912"/>
+            <a:ext cx="2743200" cy="640080"/>
+          </a:xfrm>
+          <a:prstGeom prst="rect">
+            <a:avLst/>
+          </a:prstGeom>
+          <a:noFill/>
+        </p:spPr>
+        <p:txBody>
+          <a:bodyPr wrap="square" anchor="t" lIns="0" rIns="0" tIns="0" bIns="0">
+            <a:spAutoFit/>
+          </a:bodyPr>
+          <a:lstStyle/>
+          <a:p>
+            <a:pPr algn="ctr">
+              <a:spcAft>
+                <a:spcPts val="0"/>
+              </a:spcAft>
+            </a:pPr>
+            <a:r>
+              <a:rPr sz="1250" b="0" i="0">
+                <a:solidFill>
+                  <a:srgbClr val="525252"/>
+                </a:solidFill>
+                <a:latin typeface="IBM Plex Sans"/>
+              </a:rPr>
+              <a:t>time savings on</a:t>
+            </a:r>
+          </a:p>
+          <a:p>
+            <a:pPr algn="ctr">
+              <a:spcAft>
+                <a:spcPts val="0"/>
+              </a:spcAft>
+            </a:pPr>
+            <a:r>
+              <a:rPr sz="1250" b="0" i="0">
+                <a:solidFill>
+                  <a:srgbClr val="525252"/>
+                </a:solidFill>
+                <a:latin typeface="IBM Plex Sans"/>
+              </a:rPr>
+              <a:t>repetitive work</a:t>
+            </a:r>
+          </a:p>
+        </p:txBody>
+      </p:sp>
+      <p:sp>
+        <p:nvSpPr>
+          <p:cNvPr id="9" name="TextBox 8"/>
+          <p:cNvSpPr txBox="1"/>
+          <p:nvPr/>
+        </p:nvSpPr>
+        <p:spPr>
+          <a:xfrm>
+            <a:off x="6089904" y="1828800"/>
+            <a:ext cx="2743200" cy="868680"/>
+          </a:xfrm>
+          <a:prstGeom prst="rect">
+            <a:avLst/>
+          </a:prstGeom>
+          <a:noFill/>
+        </p:spPr>
+        <p:txBody>
+          <a:bodyPr wrap="square" anchor="ctr" lIns="0" rIns="0" tIns="0" bIns="0">
+            <a:spAutoFit/>
+          </a:bodyPr>
+          <a:lstStyle/>
+          <a:p>
+            <a:pPr algn="ctr">
+              <a:spcAft>
+                <a:spcPts val="0"/>
+              </a:spcAft>
+            </a:pPr>
+            <a:r>
+              <a:rPr sz="4400" b="1" i="0">
+                <a:solidFill>
+                  <a:srgbClr val="0F62FE"/>
+                </a:solidFill>
+                <a:latin typeface="IBM Plex Sans"/>
+              </a:rPr>
+              <a:t>20–40%</a:t>
+            </a:r>
+          </a:p>
+        </p:txBody>
+      </p:sp>
+      <p:sp>
+        <p:nvSpPr>
+          <p:cNvPr id="10" name="TextBox 9"/>
+          <p:cNvSpPr txBox="1"/>
+          <p:nvPr/>
+        </p:nvSpPr>
+        <p:spPr>
+          <a:xfrm>
+            <a:off x="6089904" y="2724912"/>
+            <a:ext cx="2743200" cy="640080"/>
+          </a:xfrm>
+          <a:prstGeom prst="rect">
+            <a:avLst/>
+          </a:prstGeom>
+          <a:noFill/>
+        </p:spPr>
+        <p:txBody>
+          <a:bodyPr wrap="square" anchor="t" lIns="0" rIns="0" tIns="0" bIns="0">
+            <a:spAutoFit/>
+          </a:bodyPr>
+          <a:lstStyle/>
+          <a:p>
+            <a:pPr algn="ctr">
+              <a:spcAft>
+                <a:spcPts val="0"/>
+              </a:spcAft>
+            </a:pPr>
+            <a:r>
+              <a:rPr sz="1250" b="0" i="0">
+                <a:solidFill>
+                  <a:srgbClr val="525252"/>
+                </a:solidFill>
+                <a:latin typeface="IBM Plex Sans"/>
+              </a:rPr>
+              <a:t>faster on complex</a:t>
+            </a:r>
+          </a:p>
+          <a:p>
+            <a:pPr algn="ctr">
+              <a:spcAft>
+                <a:spcPts val="0"/>
+              </a:spcAft>
+            </a:pPr>
+            <a:r>
+              <a:rPr sz="1250" b="0" i="0">
+                <a:solidFill>
+                  <a:srgbClr val="525252"/>
+                </a:solidFill>
+                <a:latin typeface="IBM Plex Sans"/>
+              </a:rPr>
+              <a:t>engineering work</a:t>
+            </a:r>
+          </a:p>
+        </p:txBody>
+      </p:sp>
+      <p:sp>
+        <p:nvSpPr>
+          <p:cNvPr id="11" name="TextBox 10"/>
+          <p:cNvSpPr txBox="1"/>
+          <p:nvPr/>
+        </p:nvSpPr>
+        <p:spPr>
+          <a:xfrm>
+            <a:off x="8906256" y="1828800"/>
+            <a:ext cx="2743200" cy="868680"/>
+          </a:xfrm>
+          <a:prstGeom prst="rect">
+            <a:avLst/>
+          </a:prstGeom>
+          <a:noFill/>
+        </p:spPr>
+        <p:txBody>
+          <a:bodyPr wrap="square" anchor="ctr" lIns="0" rIns="0" tIns="0" bIns="0">
+            <a:spAutoFit/>
+          </a:bodyPr>
+          <a:lstStyle/>
+          <a:p>
+            <a:pPr algn="ctr">
+              <a:spcAft>
+                <a:spcPts val="0"/>
+              </a:spcAft>
+            </a:pPr>
+            <a:r>
+              <a:rPr sz="4400" b="1" i="0">
+                <a:solidFill>
+                  <a:srgbClr val="0F62FE"/>
+                </a:solidFill>
+                <a:latin typeface="IBM Plex Sans"/>
+              </a:rPr>
+              <a:t>~40%</a:t>
+            </a:r>
+          </a:p>
+        </p:txBody>
+      </p:sp>
+      <p:sp>
+        <p:nvSpPr>
+          <p:cNvPr id="12" name="TextBox 11"/>
+          <p:cNvSpPr txBox="1"/>
+          <p:nvPr/>
+        </p:nvSpPr>
+        <p:spPr>
+          <a:xfrm>
+            <a:off x="8906256" y="2724912"/>
+            <a:ext cx="2743200" cy="640080"/>
+          </a:xfrm>
+          <a:prstGeom prst="rect">
+            <a:avLst/>
+          </a:prstGeom>
+          <a:noFill/>
+        </p:spPr>
+        <p:txBody>
+          <a:bodyPr wrap="square" anchor="t" lIns="0" rIns="0" tIns="0" bIns="0">
+            <a:spAutoFit/>
+          </a:bodyPr>
+          <a:lstStyle/>
+          <a:p>
+            <a:pPr algn="ctr">
+              <a:spcAft>
+                <a:spcPts val="0"/>
+              </a:spcAft>
+            </a:pPr>
+            <a:r>
+              <a:rPr sz="1250" b="0" i="0">
+                <a:solidFill>
+                  <a:srgbClr val="525252"/>
+                </a:solidFill>
+                <a:latin typeface="IBM Plex Sans"/>
+              </a:rPr>
+              <a:t>lower AI</a:t>
+            </a:r>
+          </a:p>
+          <a:p>
+            <a:pPr algn="ctr">
+              <a:spcAft>
+                <a:spcPts val="0"/>
+              </a:spcAft>
+            </a:pPr>
+            <a:r>
+              <a:rPr sz="1250" b="0" i="0">
+                <a:solidFill>
+                  <a:srgbClr val="525252"/>
+                </a:solidFill>
+                <a:latin typeface="IBM Plex Sans"/>
+              </a:rPr>
+              <a:t>compute spend</a:t>
+            </a:r>
+          </a:p>
+        </p:txBody>
+      </p:sp>
+      <p:sp>
+        <p:nvSpPr>
+          <p:cNvPr id="13" name="TextBox 12"/>
+          <p:cNvSpPr txBox="1"/>
+          <p:nvPr/>
+        </p:nvSpPr>
+        <p:spPr>
+          <a:xfrm>
+            <a:off x="457200" y="3977639"/>
+            <a:ext cx="3520440" cy="1280160"/>
+          </a:xfrm>
+          <a:prstGeom prst="rect">
+            <a:avLst/>
+          </a:prstGeom>
+          <a:noFill/>
+        </p:spPr>
+        <p:txBody>
+          <a:bodyPr wrap="square" anchor="t" lIns="0" rIns="0" tIns="0" bIns="0">
+            <a:spAutoFit/>
+          </a:bodyPr>
+          <a:lstStyle/>
+          <a:p>
+            <a:pPr algn="l">
+              <a:spcAft>
+                <a:spcPts val="700"/>
+              </a:spcAft>
+            </a:pPr>
+            <a:r>
+              <a:rPr sz="1300" b="1" i="0">
+                <a:solidFill>
+                  <a:srgbClr val="0F62FE"/>
+                </a:solidFill>
+                <a:latin typeface="IBM Plex Sans"/>
+              </a:rPr>
+              <a:t>▪  </a:t>
+            </a:r>
+            <a:r>
+              <a:rPr sz="1500" b="1" i="0">
+                <a:solidFill>
+                  <a:srgbClr val="0E2841"/>
+                </a:solidFill>
+                <a:latin typeface="IBM Plex Sans"/>
+              </a:rPr>
+              <a:t>Scale</a:t>
+            </a:r>
+          </a:p>
+          <a:p>
+            <a:pPr algn="l">
+              <a:spcAft>
+                <a:spcPts val="0"/>
+              </a:spcAft>
+            </a:pPr>
+            <a:r>
+              <a:rPr sz="1250" b="0" i="0">
+                <a:solidFill>
+                  <a:srgbClr val="393939"/>
+                </a:solidFill>
+                <a:latin typeface="IBM Plex Sans"/>
+              </a:rPr>
+              <a:t>Orchestrates planning, execution and verification across the full SDLC.</a:t>
+            </a:r>
+          </a:p>
+        </p:txBody>
+      </p:sp>
+      <p:sp>
+        <p:nvSpPr>
+          <p:cNvPr id="14" name="TextBox 13"/>
+          <p:cNvSpPr txBox="1"/>
+          <p:nvPr/>
+        </p:nvSpPr>
+        <p:spPr>
+          <a:xfrm>
+            <a:off x="4215384" y="3977639"/>
+            <a:ext cx="3520440" cy="1280160"/>
+          </a:xfrm>
+          <a:prstGeom prst="rect">
+            <a:avLst/>
+          </a:prstGeom>
+          <a:noFill/>
+        </p:spPr>
+        <p:txBody>
+          <a:bodyPr wrap="square" anchor="t" lIns="0" rIns="0" tIns="0" bIns="0">
+            <a:spAutoFit/>
+          </a:bodyPr>
+          <a:lstStyle/>
+          <a:p>
+            <a:pPr algn="l">
+              <a:spcAft>
+                <a:spcPts val="700"/>
+              </a:spcAft>
+            </a:pPr>
+            <a:r>
+              <a:rPr sz="1300" b="1" i="0">
+                <a:solidFill>
+                  <a:srgbClr val="0F62FE"/>
+                </a:solidFill>
+                <a:latin typeface="IBM Plex Sans"/>
+              </a:rPr>
+              <a:t>▪  </a:t>
+            </a:r>
+            <a:r>
+              <a:rPr sz="1500" b="1" i="0">
+                <a:solidFill>
+                  <a:srgbClr val="0E2841"/>
+                </a:solidFill>
+                <a:latin typeface="IBM Plex Sans"/>
+              </a:rPr>
+              <a:t>Security-first</a:t>
+            </a:r>
+          </a:p>
+          <a:p>
+            <a:pPr algn="l">
+              <a:spcAft>
+                <a:spcPts val="0"/>
+              </a:spcAft>
+            </a:pPr>
+            <a:r>
+              <a:rPr sz="1250" b="0" i="0">
+                <a:solidFill>
+                  <a:srgbClr val="393939"/>
+                </a:solidFill>
+                <a:latin typeface="IBM Plex Sans"/>
+              </a:rPr>
+              <a:t>Detects vulnerabilities during code authoring — not after the fact.</a:t>
+            </a:r>
+          </a:p>
+        </p:txBody>
+      </p:sp>
+      <p:sp>
+        <p:nvSpPr>
+          <p:cNvPr id="15" name="TextBox 14"/>
+          <p:cNvSpPr txBox="1"/>
+          <p:nvPr/>
+        </p:nvSpPr>
+        <p:spPr>
+          <a:xfrm>
+            <a:off x="7973568" y="3977639"/>
+            <a:ext cx="3520440" cy="1280160"/>
+          </a:xfrm>
+          <a:prstGeom prst="rect">
+            <a:avLst/>
+          </a:prstGeom>
+          <a:noFill/>
+        </p:spPr>
+        <p:txBody>
+          <a:bodyPr wrap="square" anchor="t" lIns="0" rIns="0" tIns="0" bIns="0">
+            <a:spAutoFit/>
+          </a:bodyPr>
+          <a:lstStyle/>
+          <a:p>
+            <a:pPr algn="l">
+              <a:spcAft>
+                <a:spcPts val="700"/>
+              </a:spcAft>
+            </a:pPr>
+            <a:r>
+              <a:rPr sz="1300" b="1" i="0">
+                <a:solidFill>
+                  <a:srgbClr val="0F62FE"/>
+                </a:solidFill>
+                <a:latin typeface="IBM Plex Sans"/>
+              </a:rPr>
+              <a:t>▪  </a:t>
+            </a:r>
+            <a:r>
+              <a:rPr sz="1500" b="1" i="0">
+                <a:solidFill>
+                  <a:srgbClr val="0E2841"/>
+                </a:solidFill>
+                <a:latin typeface="IBM Plex Sans"/>
+              </a:rPr>
+              <a:t>Governance</a:t>
+            </a:r>
+          </a:p>
+          <a:p>
+            <a:pPr algn="l">
+              <a:spcAft>
+                <a:spcPts val="0"/>
+              </a:spcAft>
+            </a:pPr>
+            <a:r>
+              <a:rPr sz="1250" b="0" i="0">
+                <a:solidFill>
+                  <a:srgbClr val="393939"/>
+                </a:solidFill>
+                <a:latin typeface="IBM Plex Sans"/>
+              </a:rPr>
+              <a:t>Auditable guardrails and audit-readiness embedded at authoring time.</a:t>
+            </a:r>
+          </a:p>
+        </p:txBody>
+      </p:sp>
+      <p:sp>
+        <p:nvSpPr>
+          <p:cNvPr id="16" name="TextBox 15"/>
+          <p:cNvSpPr txBox="1"/>
+          <p:nvPr/>
+        </p:nvSpPr>
+        <p:spPr>
+          <a:xfrm>
+            <a:off x="457200" y="5486400"/>
+            <a:ext cx="8686800" cy="457200"/>
+          </a:xfrm>
+          <a:prstGeom prst="rect">
+            <a:avLst/>
+          </a:prstGeom>
+          <a:noFill/>
+        </p:spPr>
+        <p:txBody>
+          <a:bodyPr wrap="square" anchor="t" lIns="0" rIns="0" tIns="0" bIns="0">
+            <a:spAutoFit/>
+          </a:bodyPr>
+          <a:lstStyle/>
+          <a:p>
+            <a:pPr algn="l">
+              <a:spcAft>
+                <a:spcPts val="0"/>
+              </a:spcAft>
+            </a:pPr>
+            <a:r>
+              <a:rPr sz="1350" b="1" i="0">
+                <a:solidFill>
+                  <a:srgbClr val="0E2841"/>
+                </a:solidFill>
+                <a:latin typeface="IBM Plex Sans"/>
+              </a:rPr>
+              <a:t>IBM's own positioning — </a:t>
+            </a:r>
+            <a:r>
+              <a:rPr sz="1350" b="0" i="1">
+                <a:solidFill>
+                  <a:srgbClr val="525252"/>
+                </a:solidFill>
+                <a:latin typeface="IBM Plex Sans"/>
+              </a:rPr>
+              <a:t>ship faster, modernize continuously, stay secure and governed.</a:t>
+            </a:r>
+          </a:p>
+        </p:txBody>
+      </p:sp>
+      <p:sp>
+        <p:nvSpPr>
+          <p:cNvPr id="17" name="TextBox 16"/>
+          <p:cNvSpPr txBox="1"/>
+          <p:nvPr/>
+        </p:nvSpPr>
+        <p:spPr>
+          <a:xfrm>
+            <a:off x="5943600" y="6382512"/>
+            <a:ext cx="5788152" cy="320040"/>
+          </a:xfrm>
+          <a:prstGeom prst="rect">
+            <a:avLst/>
+          </a:prstGeom>
+          <a:noFill/>
+        </p:spPr>
+        <p:txBody>
+          <a:bodyPr wrap="square" anchor="t" lIns="0" rIns="0" tIns="0" bIns="0">
+            <a:spAutoFit/>
+          </a:bodyPr>
+          <a:lstStyle/>
+          <a:p>
+            <a:pPr algn="r">
+              <a:spcAft>
+                <a:spcPts val="0"/>
+              </a:spcAft>
+            </a:pPr>
+            <a:r>
+              <a:rPr sz="950" b="0" i="1">
+                <a:solidFill>
+                  <a:srgbClr val="6F6F6F"/>
+                </a:solidFill>
+                <a:latin typeface="IBM Plex Sans"/>
+              </a:rPr>
+              <a:t>Source: ibm.com/products/ai-coding-agent — IBM official figures</a:t>
+            </a:r>
+          </a:p>
+        </p:txBody>
+      </p:sp>
+    </p:spTree>
+  </p:cSld>
+  <p:clrMapOvr>
+    <a:masterClrMapping/>
+  </p:clrMapOvr>
+</p:sld>
+</file>
+
 <file path=ppt/slides/slide2.xml><?xml version="1.0" encoding="utf-8"?>
 <p:sld xmlns:a="http://schemas.openxmlformats.org/drawingml/2006/main" xmlns:r="http://schemas.openxmlformats.org/officeDocument/2006/relationships" xmlns:p="http://schemas.openxmlformats.org/presentationml/2006/main">
   <p:cSld>
@@ -52381,6 +53157,534 @@
 </file>
 
 <file path=ppt/slides/slide7.xml><?xml version="1.0" encoding="utf-8"?>
+<p:sld xmlns:a="http://schemas.openxmlformats.org/drawingml/2006/main" xmlns:p="http://schemas.openxmlformats.org/presentationml/2006/main" xmlns:r="http://schemas.openxmlformats.org/officeDocument/2006/relationships">
+  <p:cSld>
+    <p:spTree>
+      <p:nvGrpSpPr>
+        <p:cNvPr id="1" name=""/>
+        <p:cNvGrpSpPr/>
+        <p:nvPr/>
+      </p:nvGrpSpPr>
+      <p:grpSpPr/>
+      <p:pic>
+        <p:nvPicPr>
+          <p:cNvPr id="2" name="Picture 1" descr="image.png"/>
+          <p:cNvPicPr>
+            <a:picLocks noChangeAspect="1"/>
+          </p:cNvPicPr>
+          <p:nvPr/>
+        </p:nvPicPr>
+        <p:blipFill>
+          <a:blip r:embed="rId2"/>
+          <a:stretch>
+            <a:fillRect/>
+          </a:stretch>
+        </p:blipFill>
+        <p:spPr>
+          <a:xfrm>
+            <a:off x="0" y="91440"/>
+            <a:ext cx="1563624" cy="1563624"/>
+          </a:xfrm>
+          <a:prstGeom prst="rect">
+            <a:avLst/>
+          </a:prstGeom>
+        </p:spPr>
+      </p:pic>
+      <p:sp>
+        <p:nvSpPr>
+          <p:cNvPr id="3" name="TextBox 2"/>
+          <p:cNvSpPr txBox="1"/>
+          <p:nvPr/>
+        </p:nvSpPr>
+        <p:spPr>
+          <a:xfrm>
+            <a:off x="1563624" y="310896"/>
+            <a:ext cx="9418320" cy="640080"/>
+          </a:xfrm>
+          <a:prstGeom prst="rect">
+            <a:avLst/>
+          </a:prstGeom>
+          <a:noFill/>
+        </p:spPr>
+        <p:txBody>
+          <a:bodyPr wrap="square" anchor="t" lIns="0" rIns="0" tIns="0" bIns="0">
+            <a:spAutoFit/>
+          </a:bodyPr>
+          <a:lstStyle/>
+          <a:p>
+            <a:pPr algn="l"/>
+            <a:r>
+              <a:rPr sz="2900" b="0" i="0">
+                <a:solidFill>
+                  <a:srgbClr val="525252"/>
+                </a:solidFill>
+                <a:latin typeface="IBM Plex Sans Light"/>
+              </a:rPr>
+              <a:t>AI alone  vs  AI + Bob</a:t>
+            </a:r>
+          </a:p>
+        </p:txBody>
+      </p:sp>
+      <p:sp>
+        <p:nvSpPr>
+          <p:cNvPr id="4" name="TextBox 3"/>
+          <p:cNvSpPr txBox="1"/>
+          <p:nvPr/>
+        </p:nvSpPr>
+        <p:spPr>
+          <a:xfrm>
+            <a:off x="1563624" y="969264"/>
+            <a:ext cx="9601200" cy="457200"/>
+          </a:xfrm>
+          <a:prstGeom prst="rect">
+            <a:avLst/>
+          </a:prstGeom>
+          <a:noFill/>
+        </p:spPr>
+        <p:txBody>
+          <a:bodyPr wrap="square" anchor="t" lIns="0" rIns="0" tIns="0" bIns="0">
+            <a:spAutoFit/>
+          </a:bodyPr>
+          <a:lstStyle/>
+          <a:p>
+            <a:pPr algn="l"/>
+            <a:r>
+              <a:rPr sz="1350" b="0" i="1">
+                <a:solidFill>
+                  <a:srgbClr val="0F62FE"/>
+                </a:solidFill>
+                <a:latin typeface="IBM Plex Sans"/>
+              </a:rPr>
+              <a:t>Bob isn't a different AI — it's the same model, made enterprise-ready.</a:t>
+            </a:r>
+          </a:p>
+        </p:txBody>
+      </p:sp>
+      <p:sp>
+        <p:nvSpPr>
+          <p:cNvPr id="5" name="Rounded Rectangle 4"/>
+          <p:cNvSpPr/>
+          <p:nvPr/>
+        </p:nvSpPr>
+        <p:spPr>
+          <a:xfrm>
+            <a:off x="457200" y="1783080"/>
+            <a:ext cx="5349240" cy="3383280"/>
+          </a:xfrm>
+          <a:prstGeom prst="roundRect">
+            <a:avLst>
+              <a:gd name="adj" fmla="val 4500"/>
+            </a:avLst>
+          </a:prstGeom>
+          <a:solidFill>
+            <a:srgbClr val="F2F4F8"/>
+          </a:solidFill>
+          <a:ln w="9525">
+            <a:solidFill>
+              <a:srgbClr val="C7CBD6"/>
+            </a:solidFill>
+          </a:ln>
+          <a:effectLst/>
+        </p:spPr>
+        <p:style>
+          <a:lnRef idx="1">
+            <a:schemeClr val="accent1"/>
+          </a:lnRef>
+          <a:fillRef idx="3">
+            <a:schemeClr val="accent1"/>
+          </a:fillRef>
+          <a:effectRef idx="2">
+            <a:schemeClr val="accent1"/>
+          </a:effectRef>
+          <a:fontRef idx="minor">
+            <a:schemeClr val="lt1"/>
+          </a:fontRef>
+        </p:style>
+        <p:txBody>
+          <a:bodyPr rtlCol="0" anchor="t" wrap="square" lIns="228600" rIns="203200" tIns="279400" bIns="152400"/>
+          <a:lstStyle/>
+          <a:p>
+            <a:pPr algn="ctr">
+              <a:spcAft>
+                <a:spcPts val="1600"/>
+              </a:spcAft>
+            </a:pPr>
+            <a:r>
+              <a:rPr sz="1700" b="1">
+                <a:solidFill>
+                  <a:srgbClr val="525252"/>
+                </a:solidFill>
+                <a:latin typeface="IBM Plex Sans"/>
+              </a:rPr>
+              <a:t>AI alone — a generic assistant</a:t>
+            </a:r>
+          </a:p>
+          <a:p>
+            <a:pPr>
+              <a:spcAft>
+                <a:spcPts val="1400"/>
+              </a:spcAft>
+            </a:pPr>
+            <a:r>
+              <a:rPr sz="1350" b="1">
+                <a:solidFill>
+                  <a:srgbClr val="525252"/>
+                </a:solidFill>
+                <a:latin typeface="IBM Plex Sans"/>
+              </a:rPr>
+              <a:t>•  </a:t>
+            </a:r>
+            <a:r>
+              <a:rPr sz="1350" b="0">
+                <a:solidFill>
+                  <a:srgbClr val="393939"/>
+                </a:solidFill>
+                <a:latin typeface="IBM Plex Sans"/>
+              </a:rPr>
+              <a:t>Improvises per prompt — output varies with phrasing</a:t>
+            </a:r>
+          </a:p>
+          <a:p>
+            <a:pPr>
+              <a:spcAft>
+                <a:spcPts val="1400"/>
+              </a:spcAft>
+            </a:pPr>
+            <a:r>
+              <a:rPr sz="1350" b="1">
+                <a:solidFill>
+                  <a:srgbClr val="525252"/>
+                </a:solidFill>
+                <a:latin typeface="IBM Plex Sans"/>
+              </a:rPr>
+              <a:t>•  </a:t>
+            </a:r>
+            <a:r>
+              <a:rPr sz="1350" b="0">
+                <a:solidFill>
+                  <a:srgbClr val="393939"/>
+                </a:solidFill>
+                <a:latin typeface="IBM Plex Sans"/>
+              </a:rPr>
+              <a:t>No enterprise methodology or guardrails</a:t>
+            </a:r>
+          </a:p>
+          <a:p>
+            <a:pPr>
+              <a:spcAft>
+                <a:spcPts val="1400"/>
+              </a:spcAft>
+            </a:pPr>
+            <a:r>
+              <a:rPr sz="1350" b="1">
+                <a:solidFill>
+                  <a:srgbClr val="525252"/>
+                </a:solidFill>
+                <a:latin typeface="IBM Plex Sans"/>
+              </a:rPr>
+              <a:t>•  </a:t>
+            </a:r>
+            <a:r>
+              <a:rPr sz="1350" b="0">
+                <a:solidFill>
+                  <a:srgbClr val="393939"/>
+                </a:solidFill>
+                <a:latin typeface="IBM Plex Sans"/>
+              </a:rPr>
+              <a:t>Generic — no access to your systems or the IBM stack</a:t>
+            </a:r>
+          </a:p>
+          <a:p>
+            <a:pPr>
+              <a:spcAft>
+                <a:spcPts val="1400"/>
+              </a:spcAft>
+            </a:pPr>
+            <a:r>
+              <a:rPr sz="1350" b="1">
+                <a:solidFill>
+                  <a:srgbClr val="525252"/>
+                </a:solidFill>
+                <a:latin typeface="IBM Plex Sans"/>
+              </a:rPr>
+              <a:t>•  </a:t>
+            </a:r>
+            <a:r>
+              <a:rPr sz="1350" b="0">
+                <a:solidFill>
+                  <a:srgbClr val="393939"/>
+                </a:solidFill>
+                <a:latin typeface="IBM Plex Sans"/>
+              </a:rPr>
+              <a:t>Black box — no built-in review or audit trail</a:t>
+            </a:r>
+          </a:p>
+          <a:p>
+            <a:pPr>
+              <a:spcAft>
+                <a:spcPts val="1400"/>
+              </a:spcAft>
+            </a:pPr>
+            <a:r>
+              <a:rPr sz="1350" b="1">
+                <a:solidFill>
+                  <a:srgbClr val="525252"/>
+                </a:solidFill>
+                <a:latin typeface="IBM Plex Sans"/>
+              </a:rPr>
+              <a:t>•  </a:t>
+            </a:r>
+            <a:r>
+              <a:rPr sz="1350" b="0">
+                <a:solidFill>
+                  <a:srgbClr val="393939"/>
+                </a:solidFill>
+                <a:latin typeface="IBM Plex Sans"/>
+              </a:rPr>
+              <a:t>Stateless — you re-explain the context every time</a:t>
+            </a:r>
+          </a:p>
+        </p:txBody>
+      </p:sp>
+      <p:sp>
+        <p:nvSpPr>
+          <p:cNvPr id="6" name="Rounded Rectangle 5"/>
+          <p:cNvSpPr/>
+          <p:nvPr/>
+        </p:nvSpPr>
+        <p:spPr>
+          <a:xfrm>
+            <a:off x="6382512" y="1783080"/>
+            <a:ext cx="5349240" cy="3383280"/>
+          </a:xfrm>
+          <a:prstGeom prst="roundRect">
+            <a:avLst>
+              <a:gd name="adj" fmla="val 4500"/>
+            </a:avLst>
+          </a:prstGeom>
+          <a:solidFill>
+            <a:srgbClr val="EDF2FF"/>
+          </a:solidFill>
+          <a:ln w="15875">
+            <a:solidFill>
+              <a:srgbClr val="0F62FE"/>
+            </a:solidFill>
+          </a:ln>
+          <a:effectLst/>
+        </p:spPr>
+        <p:style>
+          <a:lnRef idx="1">
+            <a:schemeClr val="accent1"/>
+          </a:lnRef>
+          <a:fillRef idx="3">
+            <a:schemeClr val="accent1"/>
+          </a:fillRef>
+          <a:effectRef idx="2">
+            <a:schemeClr val="accent1"/>
+          </a:effectRef>
+          <a:fontRef idx="minor">
+            <a:schemeClr val="lt1"/>
+          </a:fontRef>
+        </p:style>
+        <p:txBody>
+          <a:bodyPr rtlCol="0" anchor="t" wrap="square" lIns="228600" rIns="203200" tIns="279400" bIns="152400"/>
+          <a:lstStyle/>
+          <a:p>
+            <a:pPr algn="ctr">
+              <a:spcAft>
+                <a:spcPts val="1600"/>
+              </a:spcAft>
+            </a:pPr>
+            <a:r>
+              <a:rPr sz="1700" b="1">
+                <a:solidFill>
+                  <a:srgbClr val="0F62FE"/>
+                </a:solidFill>
+                <a:latin typeface="IBM Plex Sans"/>
+              </a:rPr>
+              <a:t>AI + Bob — enterprise-ready</a:t>
+            </a:r>
+          </a:p>
+          <a:p>
+            <a:pPr>
+              <a:spcAft>
+                <a:spcPts val="1400"/>
+              </a:spcAft>
+            </a:pPr>
+            <a:r>
+              <a:rPr sz="1350" b="1">
+                <a:solidFill>
+                  <a:srgbClr val="0F62FE"/>
+                </a:solidFill>
+                <a:latin typeface="IBM Plex Sans"/>
+              </a:rPr>
+              <a:t>+  </a:t>
+            </a:r>
+            <a:r>
+              <a:rPr sz="1350" b="0">
+                <a:solidFill>
+                  <a:srgbClr val="161616"/>
+                </a:solidFill>
+                <a:latin typeface="IBM Plex Sans"/>
+              </a:rPr>
+              <a:t>Specialized modes &amp; playbooks (e.g. /java-modernization)</a:t>
+            </a:r>
+          </a:p>
+          <a:p>
+            <a:pPr>
+              <a:spcAft>
+                <a:spcPts val="1400"/>
+              </a:spcAft>
+            </a:pPr>
+            <a:r>
+              <a:rPr sz="1350" b="1">
+                <a:solidFill>
+                  <a:srgbClr val="0F62FE"/>
+                </a:solidFill>
+                <a:latin typeface="IBM Plex Sans"/>
+              </a:rPr>
+              <a:t>+  </a:t>
+            </a:r>
+            <a:r>
+              <a:rPr sz="1350" b="0">
+                <a:solidFill>
+                  <a:srgbClr val="161616"/>
+                </a:solidFill>
+                <a:latin typeface="IBM Plex Sans"/>
+              </a:rPr>
+              <a:t>Skills &amp; MCP servers — TechZone, watsonx Orchestrate, web</a:t>
+            </a:r>
+          </a:p>
+          <a:p>
+            <a:pPr>
+              <a:spcAft>
+                <a:spcPts val="1400"/>
+              </a:spcAft>
+            </a:pPr>
+            <a:r>
+              <a:rPr sz="1350" b="1">
+                <a:solidFill>
+                  <a:srgbClr val="0F62FE"/>
+                </a:solidFill>
+                <a:latin typeface="IBM Plex Sans"/>
+              </a:rPr>
+              <a:t>+  </a:t>
+            </a:r>
+            <a:r>
+              <a:rPr sz="1350" b="0">
+                <a:solidFill>
+                  <a:srgbClr val="161616"/>
+                </a:solidFill>
+                <a:latin typeface="IBM Plex Sans"/>
+              </a:rPr>
+              <a:t>Native IBM stack — Liberty, Semeru, IBM Cloud, Code Engine</a:t>
+            </a:r>
+          </a:p>
+          <a:p>
+            <a:pPr>
+              <a:spcAft>
+                <a:spcPts val="1400"/>
+              </a:spcAft>
+            </a:pPr>
+            <a:r>
+              <a:rPr sz="1350" b="1">
+                <a:solidFill>
+                  <a:srgbClr val="0F62FE"/>
+                </a:solidFill>
+                <a:latin typeface="IBM Plex Sans"/>
+              </a:rPr>
+              <a:t>+  </a:t>
+            </a:r>
+            <a:r>
+              <a:rPr sz="1350" b="0">
+                <a:solidFill>
+                  <a:srgbClr val="161616"/>
+                </a:solidFill>
+                <a:latin typeface="IBM Plex Sans"/>
+              </a:rPr>
+              <a:t>Per-file approval, build-green discipline, full diff audit</a:t>
+            </a:r>
+          </a:p>
+          <a:p>
+            <a:pPr>
+              <a:spcAft>
+                <a:spcPts val="1400"/>
+              </a:spcAft>
+            </a:pPr>
+            <a:r>
+              <a:rPr sz="1350" b="1">
+                <a:solidFill>
+                  <a:srgbClr val="0F62FE"/>
+                </a:solidFill>
+                <a:latin typeface="IBM Plex Sans"/>
+              </a:rPr>
+              <a:t>+  </a:t>
+            </a:r>
+            <a:r>
+              <a:rPr sz="1350" b="0">
+                <a:solidFill>
+                  <a:srgbClr val="161616"/>
+                </a:solidFill>
+                <a:latin typeface="IBM Plex Sans"/>
+              </a:rPr>
+              <a:t>Knowledge baked in, reused across the whole estate</a:t>
+            </a:r>
+          </a:p>
+        </p:txBody>
+      </p:sp>
+      <p:sp>
+        <p:nvSpPr>
+          <p:cNvPr id="7" name="TextBox 6"/>
+          <p:cNvSpPr txBox="1"/>
+          <p:nvPr/>
+        </p:nvSpPr>
+        <p:spPr>
+          <a:xfrm>
+            <a:off x="457200" y="5806440"/>
+            <a:ext cx="11274552" cy="640080"/>
+          </a:xfrm>
+          <a:prstGeom prst="rect">
+            <a:avLst/>
+          </a:prstGeom>
+          <a:noFill/>
+        </p:spPr>
+        <p:txBody>
+          <a:bodyPr wrap="square" anchor="t" lIns="0" rIns="0" tIns="0" bIns="0">
+            <a:spAutoFit/>
+          </a:bodyPr>
+          <a:lstStyle/>
+          <a:p>
+            <a:pPr algn="l"/>
+            <a:r>
+              <a:rPr sz="1400" b="1" i="0">
+                <a:solidFill>
+                  <a:srgbClr val="0E2841"/>
+                </a:solidFill>
+                <a:latin typeface="IBM Plex Sans"/>
+              </a:rPr>
+              <a:t>Same AI horsepower — </a:t>
+            </a:r>
+            <a:r>
+              <a:rPr sz="1400" b="0" i="1">
+                <a:solidFill>
+                  <a:srgbClr val="525252"/>
+                </a:solidFill>
+                <a:latin typeface="IBM Plex Sans"/>
+              </a:rPr>
+              <a:t>plus the methodology, tools, and governance an enterprise needs.</a:t>
+            </a:r>
+          </a:p>
+        </p:txBody>
+      </p:sp>
+    </p:spTree>
+  </p:cSld>
+  <p:clrMapOvr>
+    <a:masterClrMapping/>
+  </p:clrMapOvr>
+</p:sld>
+</file>
+
+<file path=ppt/slides/slide8.xml><?xml version="1.0" encoding="utf-8"?>
 <p:sld xmlns:a="http://schemas.openxmlformats.org/drawingml/2006/main" xmlns:r="http://schemas.openxmlformats.org/officeDocument/2006/relationships" xmlns:p="http://schemas.openxmlformats.org/presentationml/2006/main">
   <p:cSld>
     <p:spTree>
@@ -52557,7 +53861,7 @@
 </p:sld>
 </file>
 
-<file path=ppt/slides/slide8.xml><?xml version="1.0" encoding="utf-8"?>
+<file path=ppt/slides/slide9.xml><?xml version="1.0" encoding="utf-8"?>
 <p:sld xmlns:a="http://schemas.openxmlformats.org/drawingml/2006/main" xmlns:r="http://schemas.openxmlformats.org/officeDocument/2006/relationships" xmlns:p="http://schemas.openxmlformats.org/presentationml/2006/main">
   <p:cSld>
     <p:spTree>
@@ -52587,534 +53891,6 @@
   <p:transition spd="slow">
     <p:fade/>
   </p:transition>
-</p:sld>
-</file>
-
-<file path=ppt/slides/slide9.xml><?xml version="1.0" encoding="utf-8"?>
-<p:sld xmlns:a="http://schemas.openxmlformats.org/drawingml/2006/main" xmlns:p="http://schemas.openxmlformats.org/presentationml/2006/main" xmlns:r="http://schemas.openxmlformats.org/officeDocument/2006/relationships">
-  <p:cSld>
-    <p:spTree>
-      <p:nvGrpSpPr>
-        <p:cNvPr id="1" name=""/>
-        <p:cNvGrpSpPr/>
-        <p:nvPr/>
-      </p:nvGrpSpPr>
-      <p:grpSpPr/>
-      <p:pic>
-        <p:nvPicPr>
-          <p:cNvPr id="2" name="Picture 1" descr="image.png"/>
-          <p:cNvPicPr>
-            <a:picLocks noChangeAspect="1"/>
-          </p:cNvPicPr>
-          <p:nvPr/>
-        </p:nvPicPr>
-        <p:blipFill>
-          <a:blip r:embed="rId2"/>
-          <a:stretch>
-            <a:fillRect/>
-          </a:stretch>
-        </p:blipFill>
-        <p:spPr>
-          <a:xfrm>
-            <a:off x="0" y="91440"/>
-            <a:ext cx="1563624" cy="1563624"/>
-          </a:xfrm>
-          <a:prstGeom prst="rect">
-            <a:avLst/>
-          </a:prstGeom>
-        </p:spPr>
-      </p:pic>
-      <p:sp>
-        <p:nvSpPr>
-          <p:cNvPr id="3" name="TextBox 2"/>
-          <p:cNvSpPr txBox="1"/>
-          <p:nvPr/>
-        </p:nvSpPr>
-        <p:spPr>
-          <a:xfrm>
-            <a:off x="1563624" y="310896"/>
-            <a:ext cx="9418320" cy="640080"/>
-          </a:xfrm>
-          <a:prstGeom prst="rect">
-            <a:avLst/>
-          </a:prstGeom>
-          <a:noFill/>
-        </p:spPr>
-        <p:txBody>
-          <a:bodyPr wrap="square" anchor="t" lIns="0" rIns="0" tIns="0" bIns="0">
-            <a:spAutoFit/>
-          </a:bodyPr>
-          <a:lstStyle/>
-          <a:p>
-            <a:pPr algn="l"/>
-            <a:r>
-              <a:rPr sz="2900" b="0" i="0">
-                <a:solidFill>
-                  <a:srgbClr val="525252"/>
-                </a:solidFill>
-                <a:latin typeface="IBM Plex Sans Light"/>
-              </a:rPr>
-              <a:t>AI alone  vs  AI + Bob</a:t>
-            </a:r>
-          </a:p>
-        </p:txBody>
-      </p:sp>
-      <p:sp>
-        <p:nvSpPr>
-          <p:cNvPr id="4" name="TextBox 3"/>
-          <p:cNvSpPr txBox="1"/>
-          <p:nvPr/>
-        </p:nvSpPr>
-        <p:spPr>
-          <a:xfrm>
-            <a:off x="1563624" y="969264"/>
-            <a:ext cx="9601200" cy="457200"/>
-          </a:xfrm>
-          <a:prstGeom prst="rect">
-            <a:avLst/>
-          </a:prstGeom>
-          <a:noFill/>
-        </p:spPr>
-        <p:txBody>
-          <a:bodyPr wrap="square" anchor="t" lIns="0" rIns="0" tIns="0" bIns="0">
-            <a:spAutoFit/>
-          </a:bodyPr>
-          <a:lstStyle/>
-          <a:p>
-            <a:pPr algn="l"/>
-            <a:r>
-              <a:rPr sz="1350" b="0" i="1">
-                <a:solidFill>
-                  <a:srgbClr val="0F62FE"/>
-                </a:solidFill>
-                <a:latin typeface="IBM Plex Sans"/>
-              </a:rPr>
-              <a:t>Bob isn't a different AI — it's the same model, made enterprise-ready.</a:t>
-            </a:r>
-          </a:p>
-        </p:txBody>
-      </p:sp>
-      <p:sp>
-        <p:nvSpPr>
-          <p:cNvPr id="5" name="Rounded Rectangle 4"/>
-          <p:cNvSpPr/>
-          <p:nvPr/>
-        </p:nvSpPr>
-        <p:spPr>
-          <a:xfrm>
-            <a:off x="457200" y="1783080"/>
-            <a:ext cx="5349240" cy="3383280"/>
-          </a:xfrm>
-          <a:prstGeom prst="roundRect">
-            <a:avLst>
-              <a:gd name="adj" fmla="val 4500"/>
-            </a:avLst>
-          </a:prstGeom>
-          <a:solidFill>
-            <a:srgbClr val="F2F4F8"/>
-          </a:solidFill>
-          <a:ln w="9525">
-            <a:solidFill>
-              <a:srgbClr val="C7CBD6"/>
-            </a:solidFill>
-          </a:ln>
-          <a:effectLst/>
-        </p:spPr>
-        <p:style>
-          <a:lnRef idx="1">
-            <a:schemeClr val="accent1"/>
-          </a:lnRef>
-          <a:fillRef idx="3">
-            <a:schemeClr val="accent1"/>
-          </a:fillRef>
-          <a:effectRef idx="2">
-            <a:schemeClr val="accent1"/>
-          </a:effectRef>
-          <a:fontRef idx="minor">
-            <a:schemeClr val="lt1"/>
-          </a:fontRef>
-        </p:style>
-        <p:txBody>
-          <a:bodyPr rtlCol="0" anchor="t" wrap="square" lIns="228600" rIns="203200" tIns="279400" bIns="152400"/>
-          <a:lstStyle/>
-          <a:p>
-            <a:pPr algn="ctr">
-              <a:spcAft>
-                <a:spcPts val="1600"/>
-              </a:spcAft>
-            </a:pPr>
-            <a:r>
-              <a:rPr sz="1700" b="1">
-                <a:solidFill>
-                  <a:srgbClr val="525252"/>
-                </a:solidFill>
-                <a:latin typeface="IBM Plex Sans"/>
-              </a:rPr>
-              <a:t>AI alone — a generic assistant</a:t>
-            </a:r>
-          </a:p>
-          <a:p>
-            <a:pPr>
-              <a:spcAft>
-                <a:spcPts val="1400"/>
-              </a:spcAft>
-            </a:pPr>
-            <a:r>
-              <a:rPr sz="1350" b="1">
-                <a:solidFill>
-                  <a:srgbClr val="525252"/>
-                </a:solidFill>
-                <a:latin typeface="IBM Plex Sans"/>
-              </a:rPr>
-              <a:t>•  </a:t>
-            </a:r>
-            <a:r>
-              <a:rPr sz="1350" b="0">
-                <a:solidFill>
-                  <a:srgbClr val="393939"/>
-                </a:solidFill>
-                <a:latin typeface="IBM Plex Sans"/>
-              </a:rPr>
-              <a:t>Improvises per prompt — output varies with phrasing</a:t>
-            </a:r>
-          </a:p>
-          <a:p>
-            <a:pPr>
-              <a:spcAft>
-                <a:spcPts val="1400"/>
-              </a:spcAft>
-            </a:pPr>
-            <a:r>
-              <a:rPr sz="1350" b="1">
-                <a:solidFill>
-                  <a:srgbClr val="525252"/>
-                </a:solidFill>
-                <a:latin typeface="IBM Plex Sans"/>
-              </a:rPr>
-              <a:t>•  </a:t>
-            </a:r>
-            <a:r>
-              <a:rPr sz="1350" b="0">
-                <a:solidFill>
-                  <a:srgbClr val="393939"/>
-                </a:solidFill>
-                <a:latin typeface="IBM Plex Sans"/>
-              </a:rPr>
-              <a:t>No enterprise methodology or guardrails</a:t>
-            </a:r>
-          </a:p>
-          <a:p>
-            <a:pPr>
-              <a:spcAft>
-                <a:spcPts val="1400"/>
-              </a:spcAft>
-            </a:pPr>
-            <a:r>
-              <a:rPr sz="1350" b="1">
-                <a:solidFill>
-                  <a:srgbClr val="525252"/>
-                </a:solidFill>
-                <a:latin typeface="IBM Plex Sans"/>
-              </a:rPr>
-              <a:t>•  </a:t>
-            </a:r>
-            <a:r>
-              <a:rPr sz="1350" b="0">
-                <a:solidFill>
-                  <a:srgbClr val="393939"/>
-                </a:solidFill>
-                <a:latin typeface="IBM Plex Sans"/>
-              </a:rPr>
-              <a:t>Generic — no access to your systems or the IBM stack</a:t>
-            </a:r>
-          </a:p>
-          <a:p>
-            <a:pPr>
-              <a:spcAft>
-                <a:spcPts val="1400"/>
-              </a:spcAft>
-            </a:pPr>
-            <a:r>
-              <a:rPr sz="1350" b="1">
-                <a:solidFill>
-                  <a:srgbClr val="525252"/>
-                </a:solidFill>
-                <a:latin typeface="IBM Plex Sans"/>
-              </a:rPr>
-              <a:t>•  </a:t>
-            </a:r>
-            <a:r>
-              <a:rPr sz="1350" b="0">
-                <a:solidFill>
-                  <a:srgbClr val="393939"/>
-                </a:solidFill>
-                <a:latin typeface="IBM Plex Sans"/>
-              </a:rPr>
-              <a:t>Black box — no built-in review or audit trail</a:t>
-            </a:r>
-          </a:p>
-          <a:p>
-            <a:pPr>
-              <a:spcAft>
-                <a:spcPts val="1400"/>
-              </a:spcAft>
-            </a:pPr>
-            <a:r>
-              <a:rPr sz="1350" b="1">
-                <a:solidFill>
-                  <a:srgbClr val="525252"/>
-                </a:solidFill>
-                <a:latin typeface="IBM Plex Sans"/>
-              </a:rPr>
-              <a:t>•  </a:t>
-            </a:r>
-            <a:r>
-              <a:rPr sz="1350" b="0">
-                <a:solidFill>
-                  <a:srgbClr val="393939"/>
-                </a:solidFill>
-                <a:latin typeface="IBM Plex Sans"/>
-              </a:rPr>
-              <a:t>Stateless — you re-explain the context every time</a:t>
-            </a:r>
-          </a:p>
-        </p:txBody>
-      </p:sp>
-      <p:sp>
-        <p:nvSpPr>
-          <p:cNvPr id="6" name="Rounded Rectangle 5"/>
-          <p:cNvSpPr/>
-          <p:nvPr/>
-        </p:nvSpPr>
-        <p:spPr>
-          <a:xfrm>
-            <a:off x="6382512" y="1783080"/>
-            <a:ext cx="5349240" cy="3383280"/>
-          </a:xfrm>
-          <a:prstGeom prst="roundRect">
-            <a:avLst>
-              <a:gd name="adj" fmla="val 4500"/>
-            </a:avLst>
-          </a:prstGeom>
-          <a:solidFill>
-            <a:srgbClr val="EDF2FF"/>
-          </a:solidFill>
-          <a:ln w="15875">
-            <a:solidFill>
-              <a:srgbClr val="0F62FE"/>
-            </a:solidFill>
-          </a:ln>
-          <a:effectLst/>
-        </p:spPr>
-        <p:style>
-          <a:lnRef idx="1">
-            <a:schemeClr val="accent1"/>
-          </a:lnRef>
-          <a:fillRef idx="3">
-            <a:schemeClr val="accent1"/>
-          </a:fillRef>
-          <a:effectRef idx="2">
-            <a:schemeClr val="accent1"/>
-          </a:effectRef>
-          <a:fontRef idx="minor">
-            <a:schemeClr val="lt1"/>
-          </a:fontRef>
-        </p:style>
-        <p:txBody>
-          <a:bodyPr rtlCol="0" anchor="t" wrap="square" lIns="228600" rIns="203200" tIns="279400" bIns="152400"/>
-          <a:lstStyle/>
-          <a:p>
-            <a:pPr algn="ctr">
-              <a:spcAft>
-                <a:spcPts val="1600"/>
-              </a:spcAft>
-            </a:pPr>
-            <a:r>
-              <a:rPr sz="1700" b="1">
-                <a:solidFill>
-                  <a:srgbClr val="0F62FE"/>
-                </a:solidFill>
-                <a:latin typeface="IBM Plex Sans"/>
-              </a:rPr>
-              <a:t>AI + Bob — enterprise-ready</a:t>
-            </a:r>
-          </a:p>
-          <a:p>
-            <a:pPr>
-              <a:spcAft>
-                <a:spcPts val="1400"/>
-              </a:spcAft>
-            </a:pPr>
-            <a:r>
-              <a:rPr sz="1350" b="1">
-                <a:solidFill>
-                  <a:srgbClr val="0F62FE"/>
-                </a:solidFill>
-                <a:latin typeface="IBM Plex Sans"/>
-              </a:rPr>
-              <a:t>+  </a:t>
-            </a:r>
-            <a:r>
-              <a:rPr sz="1350" b="0">
-                <a:solidFill>
-                  <a:srgbClr val="161616"/>
-                </a:solidFill>
-                <a:latin typeface="IBM Plex Sans"/>
-              </a:rPr>
-              <a:t>Specialized modes &amp; playbooks (e.g. /java-modernization)</a:t>
-            </a:r>
-          </a:p>
-          <a:p>
-            <a:pPr>
-              <a:spcAft>
-                <a:spcPts val="1400"/>
-              </a:spcAft>
-            </a:pPr>
-            <a:r>
-              <a:rPr sz="1350" b="1">
-                <a:solidFill>
-                  <a:srgbClr val="0F62FE"/>
-                </a:solidFill>
-                <a:latin typeface="IBM Plex Sans"/>
-              </a:rPr>
-              <a:t>+  </a:t>
-            </a:r>
-            <a:r>
-              <a:rPr sz="1350" b="0">
-                <a:solidFill>
-                  <a:srgbClr val="161616"/>
-                </a:solidFill>
-                <a:latin typeface="IBM Plex Sans"/>
-              </a:rPr>
-              <a:t>Skills &amp; MCP servers — TechZone, watsonx Orchestrate, web</a:t>
-            </a:r>
-          </a:p>
-          <a:p>
-            <a:pPr>
-              <a:spcAft>
-                <a:spcPts val="1400"/>
-              </a:spcAft>
-            </a:pPr>
-            <a:r>
-              <a:rPr sz="1350" b="1">
-                <a:solidFill>
-                  <a:srgbClr val="0F62FE"/>
-                </a:solidFill>
-                <a:latin typeface="IBM Plex Sans"/>
-              </a:rPr>
-              <a:t>+  </a:t>
-            </a:r>
-            <a:r>
-              <a:rPr sz="1350" b="0">
-                <a:solidFill>
-                  <a:srgbClr val="161616"/>
-                </a:solidFill>
-                <a:latin typeface="IBM Plex Sans"/>
-              </a:rPr>
-              <a:t>Native IBM stack — Liberty, Semeru, IBM Cloud, Code Engine</a:t>
-            </a:r>
-          </a:p>
-          <a:p>
-            <a:pPr>
-              <a:spcAft>
-                <a:spcPts val="1400"/>
-              </a:spcAft>
-            </a:pPr>
-            <a:r>
-              <a:rPr sz="1350" b="1">
-                <a:solidFill>
-                  <a:srgbClr val="0F62FE"/>
-                </a:solidFill>
-                <a:latin typeface="IBM Plex Sans"/>
-              </a:rPr>
-              <a:t>+  </a:t>
-            </a:r>
-            <a:r>
-              <a:rPr sz="1350" b="0">
-                <a:solidFill>
-                  <a:srgbClr val="161616"/>
-                </a:solidFill>
-                <a:latin typeface="IBM Plex Sans"/>
-              </a:rPr>
-              <a:t>Per-file approval, build-green discipline, full diff audit</a:t>
-            </a:r>
-          </a:p>
-          <a:p>
-            <a:pPr>
-              <a:spcAft>
-                <a:spcPts val="1400"/>
-              </a:spcAft>
-            </a:pPr>
-            <a:r>
-              <a:rPr sz="1350" b="1">
-                <a:solidFill>
-                  <a:srgbClr val="0F62FE"/>
-                </a:solidFill>
-                <a:latin typeface="IBM Plex Sans"/>
-              </a:rPr>
-              <a:t>+  </a:t>
-            </a:r>
-            <a:r>
-              <a:rPr sz="1350" b="0">
-                <a:solidFill>
-                  <a:srgbClr val="161616"/>
-                </a:solidFill>
-                <a:latin typeface="IBM Plex Sans"/>
-              </a:rPr>
-              <a:t>Knowledge baked in, reused across the whole estate</a:t>
-            </a:r>
-          </a:p>
-        </p:txBody>
-      </p:sp>
-      <p:sp>
-        <p:nvSpPr>
-          <p:cNvPr id="7" name="TextBox 6"/>
-          <p:cNvSpPr txBox="1"/>
-          <p:nvPr/>
-        </p:nvSpPr>
-        <p:spPr>
-          <a:xfrm>
-            <a:off x="457200" y="5806440"/>
-            <a:ext cx="11274552" cy="640080"/>
-          </a:xfrm>
-          <a:prstGeom prst="rect">
-            <a:avLst/>
-          </a:prstGeom>
-          <a:noFill/>
-        </p:spPr>
-        <p:txBody>
-          <a:bodyPr wrap="square" anchor="t" lIns="0" rIns="0" tIns="0" bIns="0">
-            <a:spAutoFit/>
-          </a:bodyPr>
-          <a:lstStyle/>
-          <a:p>
-            <a:pPr algn="l"/>
-            <a:r>
-              <a:rPr sz="1400" b="1" i="0">
-                <a:solidFill>
-                  <a:srgbClr val="0E2841"/>
-                </a:solidFill>
-                <a:latin typeface="IBM Plex Sans"/>
-              </a:rPr>
-              <a:t>Same AI horsepower — </a:t>
-            </a:r>
-            <a:r>
-              <a:rPr sz="1400" b="0" i="1">
-                <a:solidFill>
-                  <a:srgbClr val="525252"/>
-                </a:solidFill>
-                <a:latin typeface="IBM Plex Sans"/>
-              </a:rPr>
-              <a:t>plus the methodology, tools, and governance an enterprise needs.</a:t>
-            </a:r>
-          </a:p>
-        </p:txBody>
-      </p:sp>
-    </p:spTree>
-  </p:cSld>
-  <p:clrMapOvr>
-    <a:masterClrMapping/>
-  </p:clrMapOvr>
 </p:sld>
 </file>
 

</xml_diff>

<commit_message>
docs: rename slide title to "IBM about Bob"
Co-Authored-By: Claude Opus 4.8 (1M context) <noreply@anthropic.com>
</commit_message>
<xml_diff>
--- a/docs/bob-java-modernization-orchestrate.pptx
+++ b/docs/bob-java-modernization-orchestrate.pptx
@@ -49735,7 +49735,7 @@
 </file>
 
 <file path=ppt/slides/slide10.xml><?xml version="1.0" encoding="utf-8"?>
-<p:sld xmlns:a="http://schemas.openxmlformats.org/drawingml/2006/main" xmlns:p="http://schemas.openxmlformats.org/presentationml/2006/main" xmlns:r="http://schemas.openxmlformats.org/officeDocument/2006/relationships">
+<p:sld xmlns:a="http://schemas.openxmlformats.org/drawingml/2006/main" xmlns:r="http://schemas.openxmlformats.org/officeDocument/2006/relationships" xmlns:p="http://schemas.openxmlformats.org/presentationml/2006/main">
   <p:cSld>
     <p:spTree>
       <p:nvGrpSpPr>
@@ -49743,769 +49743,27 @@
         <p:cNvGrpSpPr/>
         <p:nvPr/>
       </p:nvGrpSpPr>
-      <p:grpSpPr/>
-      <p:pic>
-        <p:nvPicPr>
-          <p:cNvPr id="2" name="Picture 1" descr="image.png"/>
-          <p:cNvPicPr>
-            <a:picLocks noChangeAspect="1"/>
-          </p:cNvPicPr>
-          <p:nvPr/>
-        </p:nvPicPr>
-        <p:blipFill>
-          <a:blip r:embed="rId2"/>
-          <a:stretch>
-            <a:fillRect/>
-          </a:stretch>
-        </p:blipFill>
-        <p:spPr>
-          <a:xfrm>
-            <a:off x="0" y="91440"/>
-            <a:ext cx="1563624" cy="1563624"/>
-          </a:xfrm>
-          <a:prstGeom prst="rect">
-            <a:avLst/>
-          </a:prstGeom>
-        </p:spPr>
-      </p:pic>
-      <p:sp>
-        <p:nvSpPr>
-          <p:cNvPr id="3" name="TextBox 2"/>
-          <p:cNvSpPr txBox="1"/>
-          <p:nvPr/>
-        </p:nvSpPr>
-        <p:spPr>
-          <a:xfrm>
-            <a:off x="1563624" y="310896"/>
-            <a:ext cx="9509760" cy="640080"/>
-          </a:xfrm>
-          <a:prstGeom prst="rect">
-            <a:avLst/>
-          </a:prstGeom>
-          <a:noFill/>
-        </p:spPr>
-        <p:txBody>
-          <a:bodyPr wrap="square" anchor="t" lIns="0" rIns="0" tIns="0" bIns="0">
-            <a:spAutoFit/>
-          </a:bodyPr>
-          <a:lstStyle/>
-          <a:p>
-            <a:pPr algn="l">
-              <a:spcAft>
-                <a:spcPts val="0"/>
-              </a:spcAft>
-            </a:pPr>
-            <a:r>
-              <a:rPr sz="2900" b="0" i="0">
-                <a:solidFill>
-                  <a:srgbClr val="525252"/>
-                </a:solidFill>
-                <a:latin typeface="IBM Plex Sans Light"/>
-              </a:rPr>
-              <a:t>What IBM says about Bob</a:t>
-            </a:r>
-          </a:p>
-        </p:txBody>
-      </p:sp>
-      <p:sp>
-        <p:nvSpPr>
-          <p:cNvPr id="4" name="TextBox 3"/>
-          <p:cNvSpPr txBox="1"/>
-          <p:nvPr/>
-        </p:nvSpPr>
-        <p:spPr>
-          <a:xfrm>
-            <a:off x="1563624" y="969264"/>
-            <a:ext cx="9692640" cy="457200"/>
-          </a:xfrm>
-          <a:prstGeom prst="rect">
-            <a:avLst/>
-          </a:prstGeom>
-          <a:noFill/>
-        </p:spPr>
-        <p:txBody>
-          <a:bodyPr wrap="square" anchor="t" lIns="0" rIns="0" tIns="0" bIns="0">
-            <a:spAutoFit/>
-          </a:bodyPr>
-          <a:lstStyle/>
-          <a:p>
-            <a:pPr algn="l">
-              <a:spcAft>
-                <a:spcPts val="0"/>
-              </a:spcAft>
-            </a:pPr>
-            <a:r>
-              <a:rPr sz="1350" b="0" i="1">
-                <a:solidFill>
-                  <a:srgbClr val="0F62FE"/>
-                </a:solidFill>
-                <a:latin typeface="IBM Plex Sans"/>
-              </a:rPr>
-              <a:t>Faster innovation, higher productivity — built for scale, security and governance.</a:t>
-            </a:r>
-          </a:p>
-        </p:txBody>
-      </p:sp>
-      <p:sp>
-        <p:nvSpPr>
-          <p:cNvPr id="5" name="TextBox 4"/>
-          <p:cNvSpPr txBox="1"/>
-          <p:nvPr/>
-        </p:nvSpPr>
-        <p:spPr>
-          <a:xfrm>
-            <a:off x="457200" y="1828800"/>
-            <a:ext cx="2743200" cy="868680"/>
-          </a:xfrm>
-          <a:prstGeom prst="rect">
-            <a:avLst/>
-          </a:prstGeom>
-          <a:noFill/>
-        </p:spPr>
-        <p:txBody>
-          <a:bodyPr wrap="square" anchor="ctr" lIns="0" rIns="0" tIns="0" bIns="0">
-            <a:spAutoFit/>
-          </a:bodyPr>
-          <a:lstStyle/>
-          <a:p>
-            <a:pPr algn="ctr">
-              <a:spcAft>
-                <a:spcPts val="0"/>
-              </a:spcAft>
-            </a:pPr>
-            <a:r>
-              <a:rPr sz="4400" b="1" i="0">
-                <a:solidFill>
-                  <a:srgbClr val="0F62FE"/>
-                </a:solidFill>
-                <a:latin typeface="IBM Plex Sans"/>
-              </a:rPr>
-              <a:t>20–80%</a:t>
-            </a:r>
-          </a:p>
-        </p:txBody>
-      </p:sp>
-      <p:sp>
-        <p:nvSpPr>
-          <p:cNvPr id="6" name="TextBox 5"/>
-          <p:cNvSpPr txBox="1"/>
-          <p:nvPr/>
-        </p:nvSpPr>
-        <p:spPr>
-          <a:xfrm>
-            <a:off x="457200" y="2724912"/>
-            <a:ext cx="2743200" cy="640080"/>
-          </a:xfrm>
-          <a:prstGeom prst="rect">
-            <a:avLst/>
-          </a:prstGeom>
-          <a:noFill/>
-        </p:spPr>
-        <p:txBody>
-          <a:bodyPr wrap="square" anchor="t" lIns="0" rIns="0" tIns="0" bIns="0">
-            <a:spAutoFit/>
-          </a:bodyPr>
-          <a:lstStyle/>
-          <a:p>
-            <a:pPr algn="ctr">
-              <a:spcAft>
-                <a:spcPts val="0"/>
-              </a:spcAft>
-            </a:pPr>
-            <a:r>
-              <a:rPr sz="1250" b="0" i="0">
-                <a:solidFill>
-                  <a:srgbClr val="525252"/>
-                </a:solidFill>
-                <a:latin typeface="IBM Plex Sans"/>
-              </a:rPr>
-              <a:t>productivity gains</a:t>
-            </a:r>
-          </a:p>
-          <a:p>
-            <a:pPr algn="ctr">
-              <a:spcAft>
-                <a:spcPts val="0"/>
-              </a:spcAft>
-            </a:pPr>
-            <a:r>
-              <a:rPr sz="1250" b="0" i="0">
-                <a:solidFill>
-                  <a:srgbClr val="525252"/>
-                </a:solidFill>
-                <a:latin typeface="IBM Plex Sans"/>
-              </a:rPr>
-              <a:t>across SDLC tasks</a:t>
-            </a:r>
-          </a:p>
-        </p:txBody>
-      </p:sp>
-      <p:sp>
-        <p:nvSpPr>
-          <p:cNvPr id="7" name="TextBox 6"/>
-          <p:cNvSpPr txBox="1"/>
-          <p:nvPr/>
-        </p:nvSpPr>
-        <p:spPr>
-          <a:xfrm>
-            <a:off x="3273552" y="1828800"/>
-            <a:ext cx="2743200" cy="868680"/>
-          </a:xfrm>
-          <a:prstGeom prst="rect">
-            <a:avLst/>
-          </a:prstGeom>
-          <a:noFill/>
-        </p:spPr>
-        <p:txBody>
-          <a:bodyPr wrap="square" anchor="ctr" lIns="0" rIns="0" tIns="0" bIns="0">
-            <a:spAutoFit/>
-          </a:bodyPr>
-          <a:lstStyle/>
-          <a:p>
-            <a:pPr algn="ctr">
-              <a:spcAft>
-                <a:spcPts val="0"/>
-              </a:spcAft>
-            </a:pPr>
-            <a:r>
-              <a:rPr sz="4400" b="1" i="0">
-                <a:solidFill>
-                  <a:srgbClr val="0F62FE"/>
-                </a:solidFill>
-                <a:latin typeface="IBM Plex Sans"/>
-              </a:rPr>
-              <a:t>90%+</a:t>
-            </a:r>
-          </a:p>
-        </p:txBody>
-      </p:sp>
-      <p:sp>
-        <p:nvSpPr>
-          <p:cNvPr id="8" name="TextBox 7"/>
-          <p:cNvSpPr txBox="1"/>
-          <p:nvPr/>
-        </p:nvSpPr>
-        <p:spPr>
-          <a:xfrm>
-            <a:off x="3273552" y="2724912"/>
-            <a:ext cx="2743200" cy="640080"/>
-          </a:xfrm>
-          <a:prstGeom prst="rect">
-            <a:avLst/>
-          </a:prstGeom>
-          <a:noFill/>
-        </p:spPr>
-        <p:txBody>
-          <a:bodyPr wrap="square" anchor="t" lIns="0" rIns="0" tIns="0" bIns="0">
-            <a:spAutoFit/>
-          </a:bodyPr>
-          <a:lstStyle/>
-          <a:p>
-            <a:pPr algn="ctr">
-              <a:spcAft>
-                <a:spcPts val="0"/>
-              </a:spcAft>
-            </a:pPr>
-            <a:r>
-              <a:rPr sz="1250" b="0" i="0">
-                <a:solidFill>
-                  <a:srgbClr val="525252"/>
-                </a:solidFill>
-                <a:latin typeface="IBM Plex Sans"/>
-              </a:rPr>
-              <a:t>time savings on</a:t>
-            </a:r>
-          </a:p>
-          <a:p>
-            <a:pPr algn="ctr">
-              <a:spcAft>
-                <a:spcPts val="0"/>
-              </a:spcAft>
-            </a:pPr>
-            <a:r>
-              <a:rPr sz="1250" b="0" i="0">
-                <a:solidFill>
-                  <a:srgbClr val="525252"/>
-                </a:solidFill>
-                <a:latin typeface="IBM Plex Sans"/>
-              </a:rPr>
-              <a:t>repetitive work</a:t>
-            </a:r>
-          </a:p>
-        </p:txBody>
-      </p:sp>
-      <p:sp>
-        <p:nvSpPr>
-          <p:cNvPr id="9" name="TextBox 8"/>
-          <p:cNvSpPr txBox="1"/>
-          <p:nvPr/>
-        </p:nvSpPr>
-        <p:spPr>
-          <a:xfrm>
-            <a:off x="6089904" y="1828800"/>
-            <a:ext cx="2743200" cy="868680"/>
-          </a:xfrm>
-          <a:prstGeom prst="rect">
-            <a:avLst/>
-          </a:prstGeom>
-          <a:noFill/>
-        </p:spPr>
-        <p:txBody>
-          <a:bodyPr wrap="square" anchor="ctr" lIns="0" rIns="0" tIns="0" bIns="0">
-            <a:spAutoFit/>
-          </a:bodyPr>
-          <a:lstStyle/>
-          <a:p>
-            <a:pPr algn="ctr">
-              <a:spcAft>
-                <a:spcPts val="0"/>
-              </a:spcAft>
-            </a:pPr>
-            <a:r>
-              <a:rPr sz="4400" b="1" i="0">
-                <a:solidFill>
-                  <a:srgbClr val="0F62FE"/>
-                </a:solidFill>
-                <a:latin typeface="IBM Plex Sans"/>
-              </a:rPr>
-              <a:t>20–40%</a:t>
-            </a:r>
-          </a:p>
-        </p:txBody>
-      </p:sp>
-      <p:sp>
-        <p:nvSpPr>
-          <p:cNvPr id="10" name="TextBox 9"/>
-          <p:cNvSpPr txBox="1"/>
-          <p:nvPr/>
-        </p:nvSpPr>
-        <p:spPr>
-          <a:xfrm>
-            <a:off x="6089904" y="2724912"/>
-            <a:ext cx="2743200" cy="640080"/>
-          </a:xfrm>
-          <a:prstGeom prst="rect">
-            <a:avLst/>
-          </a:prstGeom>
-          <a:noFill/>
-        </p:spPr>
-        <p:txBody>
-          <a:bodyPr wrap="square" anchor="t" lIns="0" rIns="0" tIns="0" bIns="0">
-            <a:spAutoFit/>
-          </a:bodyPr>
-          <a:lstStyle/>
-          <a:p>
-            <a:pPr algn="ctr">
-              <a:spcAft>
-                <a:spcPts val="0"/>
-              </a:spcAft>
-            </a:pPr>
-            <a:r>
-              <a:rPr sz="1250" b="0" i="0">
-                <a:solidFill>
-                  <a:srgbClr val="525252"/>
-                </a:solidFill>
-                <a:latin typeface="IBM Plex Sans"/>
-              </a:rPr>
-              <a:t>faster on complex</a:t>
-            </a:r>
-          </a:p>
-          <a:p>
-            <a:pPr algn="ctr">
-              <a:spcAft>
-                <a:spcPts val="0"/>
-              </a:spcAft>
-            </a:pPr>
-            <a:r>
-              <a:rPr sz="1250" b="0" i="0">
-                <a:solidFill>
-                  <a:srgbClr val="525252"/>
-                </a:solidFill>
-                <a:latin typeface="IBM Plex Sans"/>
-              </a:rPr>
-              <a:t>engineering work</a:t>
-            </a:r>
-          </a:p>
-        </p:txBody>
-      </p:sp>
-      <p:sp>
-        <p:nvSpPr>
-          <p:cNvPr id="11" name="TextBox 10"/>
-          <p:cNvSpPr txBox="1"/>
-          <p:nvPr/>
-        </p:nvSpPr>
-        <p:spPr>
-          <a:xfrm>
-            <a:off x="8906256" y="1828800"/>
-            <a:ext cx="2743200" cy="868680"/>
-          </a:xfrm>
-          <a:prstGeom prst="rect">
-            <a:avLst/>
-          </a:prstGeom>
-          <a:noFill/>
-        </p:spPr>
-        <p:txBody>
-          <a:bodyPr wrap="square" anchor="ctr" lIns="0" rIns="0" tIns="0" bIns="0">
-            <a:spAutoFit/>
-          </a:bodyPr>
-          <a:lstStyle/>
-          <a:p>
-            <a:pPr algn="ctr">
-              <a:spcAft>
-                <a:spcPts val="0"/>
-              </a:spcAft>
-            </a:pPr>
-            <a:r>
-              <a:rPr sz="4400" b="1" i="0">
-                <a:solidFill>
-                  <a:srgbClr val="0F62FE"/>
-                </a:solidFill>
-                <a:latin typeface="IBM Plex Sans"/>
-              </a:rPr>
-              <a:t>~40%</a:t>
-            </a:r>
-          </a:p>
-        </p:txBody>
-      </p:sp>
-      <p:sp>
-        <p:nvSpPr>
-          <p:cNvPr id="12" name="TextBox 11"/>
-          <p:cNvSpPr txBox="1"/>
-          <p:nvPr/>
-        </p:nvSpPr>
-        <p:spPr>
-          <a:xfrm>
-            <a:off x="8906256" y="2724912"/>
-            <a:ext cx="2743200" cy="640080"/>
-          </a:xfrm>
-          <a:prstGeom prst="rect">
-            <a:avLst/>
-          </a:prstGeom>
-          <a:noFill/>
-        </p:spPr>
-        <p:txBody>
-          <a:bodyPr wrap="square" anchor="t" lIns="0" rIns="0" tIns="0" bIns="0">
-            <a:spAutoFit/>
-          </a:bodyPr>
-          <a:lstStyle/>
-          <a:p>
-            <a:pPr algn="ctr">
-              <a:spcAft>
-                <a:spcPts val="0"/>
-              </a:spcAft>
-            </a:pPr>
-            <a:r>
-              <a:rPr sz="1250" b="0" i="0">
-                <a:solidFill>
-                  <a:srgbClr val="525252"/>
-                </a:solidFill>
-                <a:latin typeface="IBM Plex Sans"/>
-              </a:rPr>
-              <a:t>lower AI</a:t>
-            </a:r>
-          </a:p>
-          <a:p>
-            <a:pPr algn="ctr">
-              <a:spcAft>
-                <a:spcPts val="0"/>
-              </a:spcAft>
-            </a:pPr>
-            <a:r>
-              <a:rPr sz="1250" b="0" i="0">
-                <a:solidFill>
-                  <a:srgbClr val="525252"/>
-                </a:solidFill>
-                <a:latin typeface="IBM Plex Sans"/>
-              </a:rPr>
-              <a:t>compute spend</a:t>
-            </a:r>
-          </a:p>
-        </p:txBody>
-      </p:sp>
-      <p:sp>
-        <p:nvSpPr>
-          <p:cNvPr id="13" name="TextBox 12"/>
-          <p:cNvSpPr txBox="1"/>
-          <p:nvPr/>
-        </p:nvSpPr>
-        <p:spPr>
-          <a:xfrm>
-            <a:off x="457200" y="3977639"/>
-            <a:ext cx="3520440" cy="1280160"/>
-          </a:xfrm>
-          <a:prstGeom prst="rect">
-            <a:avLst/>
-          </a:prstGeom>
-          <a:noFill/>
-        </p:spPr>
-        <p:txBody>
-          <a:bodyPr wrap="square" anchor="t" lIns="0" rIns="0" tIns="0" bIns="0">
-            <a:spAutoFit/>
-          </a:bodyPr>
-          <a:lstStyle/>
-          <a:p>
-            <a:pPr algn="l">
-              <a:spcAft>
-                <a:spcPts val="700"/>
-              </a:spcAft>
-            </a:pPr>
-            <a:r>
-              <a:rPr sz="1300" b="1" i="0">
-                <a:solidFill>
-                  <a:srgbClr val="0F62FE"/>
-                </a:solidFill>
-                <a:latin typeface="IBM Plex Sans"/>
-              </a:rPr>
-              <a:t>▪  </a:t>
-            </a:r>
-            <a:r>
-              <a:rPr sz="1500" b="1" i="0">
-                <a:solidFill>
-                  <a:srgbClr val="0E2841"/>
-                </a:solidFill>
-                <a:latin typeface="IBM Plex Sans"/>
-              </a:rPr>
-              <a:t>Scale</a:t>
-            </a:r>
-          </a:p>
-          <a:p>
-            <a:pPr algn="l">
-              <a:spcAft>
-                <a:spcPts val="0"/>
-              </a:spcAft>
-            </a:pPr>
-            <a:r>
-              <a:rPr sz="1250" b="0" i="0">
-                <a:solidFill>
-                  <a:srgbClr val="393939"/>
-                </a:solidFill>
-                <a:latin typeface="IBM Plex Sans"/>
-              </a:rPr>
-              <a:t>Orchestrates planning, execution and verification across the full SDLC.</a:t>
-            </a:r>
-          </a:p>
-        </p:txBody>
-      </p:sp>
-      <p:sp>
-        <p:nvSpPr>
-          <p:cNvPr id="14" name="TextBox 13"/>
-          <p:cNvSpPr txBox="1"/>
-          <p:nvPr/>
-        </p:nvSpPr>
-        <p:spPr>
-          <a:xfrm>
-            <a:off x="4215384" y="3977639"/>
-            <a:ext cx="3520440" cy="1280160"/>
-          </a:xfrm>
-          <a:prstGeom prst="rect">
-            <a:avLst/>
-          </a:prstGeom>
-          <a:noFill/>
-        </p:spPr>
-        <p:txBody>
-          <a:bodyPr wrap="square" anchor="t" lIns="0" rIns="0" tIns="0" bIns="0">
-            <a:spAutoFit/>
-          </a:bodyPr>
-          <a:lstStyle/>
-          <a:p>
-            <a:pPr algn="l">
-              <a:spcAft>
-                <a:spcPts val="700"/>
-              </a:spcAft>
-            </a:pPr>
-            <a:r>
-              <a:rPr sz="1300" b="1" i="0">
-                <a:solidFill>
-                  <a:srgbClr val="0F62FE"/>
-                </a:solidFill>
-                <a:latin typeface="IBM Plex Sans"/>
-              </a:rPr>
-              <a:t>▪  </a:t>
-            </a:r>
-            <a:r>
-              <a:rPr sz="1500" b="1" i="0">
-                <a:solidFill>
-                  <a:srgbClr val="0E2841"/>
-                </a:solidFill>
-                <a:latin typeface="IBM Plex Sans"/>
-              </a:rPr>
-              <a:t>Security-first</a:t>
-            </a:r>
-          </a:p>
-          <a:p>
-            <a:pPr algn="l">
-              <a:spcAft>
-                <a:spcPts val="0"/>
-              </a:spcAft>
-            </a:pPr>
-            <a:r>
-              <a:rPr sz="1250" b="0" i="0">
-                <a:solidFill>
-                  <a:srgbClr val="393939"/>
-                </a:solidFill>
-                <a:latin typeface="IBM Plex Sans"/>
-              </a:rPr>
-              <a:t>Detects vulnerabilities during code authoring — not after the fact.</a:t>
-            </a:r>
-          </a:p>
-        </p:txBody>
-      </p:sp>
-      <p:sp>
-        <p:nvSpPr>
-          <p:cNvPr id="15" name="TextBox 14"/>
-          <p:cNvSpPr txBox="1"/>
-          <p:nvPr/>
-        </p:nvSpPr>
-        <p:spPr>
-          <a:xfrm>
-            <a:off x="7973568" y="3977639"/>
-            <a:ext cx="3520440" cy="1280160"/>
-          </a:xfrm>
-          <a:prstGeom prst="rect">
-            <a:avLst/>
-          </a:prstGeom>
-          <a:noFill/>
-        </p:spPr>
-        <p:txBody>
-          <a:bodyPr wrap="square" anchor="t" lIns="0" rIns="0" tIns="0" bIns="0">
-            <a:spAutoFit/>
-          </a:bodyPr>
-          <a:lstStyle/>
-          <a:p>
-            <a:pPr algn="l">
-              <a:spcAft>
-                <a:spcPts val="700"/>
-              </a:spcAft>
-            </a:pPr>
-            <a:r>
-              <a:rPr sz="1300" b="1" i="0">
-                <a:solidFill>
-                  <a:srgbClr val="0F62FE"/>
-                </a:solidFill>
-                <a:latin typeface="IBM Plex Sans"/>
-              </a:rPr>
-              <a:t>▪  </a:t>
-            </a:r>
-            <a:r>
-              <a:rPr sz="1500" b="1" i="0">
-                <a:solidFill>
-                  <a:srgbClr val="0E2841"/>
-                </a:solidFill>
-                <a:latin typeface="IBM Plex Sans"/>
-              </a:rPr>
-              <a:t>Governance</a:t>
-            </a:r>
-          </a:p>
-          <a:p>
-            <a:pPr algn="l">
-              <a:spcAft>
-                <a:spcPts val="0"/>
-              </a:spcAft>
-            </a:pPr>
-            <a:r>
-              <a:rPr sz="1250" b="0" i="0">
-                <a:solidFill>
-                  <a:srgbClr val="393939"/>
-                </a:solidFill>
-                <a:latin typeface="IBM Plex Sans"/>
-              </a:rPr>
-              <a:t>Auditable guardrails and audit-readiness embedded at authoring time.</a:t>
-            </a:r>
-          </a:p>
-        </p:txBody>
-      </p:sp>
-      <p:sp>
-        <p:nvSpPr>
-          <p:cNvPr id="16" name="TextBox 15"/>
-          <p:cNvSpPr txBox="1"/>
-          <p:nvPr/>
-        </p:nvSpPr>
-        <p:spPr>
-          <a:xfrm>
-            <a:off x="457200" y="5486400"/>
-            <a:ext cx="8686800" cy="457200"/>
-          </a:xfrm>
-          <a:prstGeom prst="rect">
-            <a:avLst/>
-          </a:prstGeom>
-          <a:noFill/>
-        </p:spPr>
-        <p:txBody>
-          <a:bodyPr wrap="square" anchor="t" lIns="0" rIns="0" tIns="0" bIns="0">
-            <a:spAutoFit/>
-          </a:bodyPr>
-          <a:lstStyle/>
-          <a:p>
-            <a:pPr algn="l">
-              <a:spcAft>
-                <a:spcPts val="0"/>
-              </a:spcAft>
-            </a:pPr>
-            <a:r>
-              <a:rPr sz="1350" b="1" i="0">
-                <a:solidFill>
-                  <a:srgbClr val="0E2841"/>
-                </a:solidFill>
-                <a:latin typeface="IBM Plex Sans"/>
-              </a:rPr>
-              <a:t>IBM's own positioning — </a:t>
-            </a:r>
-            <a:r>
-              <a:rPr sz="1350" b="0" i="1">
-                <a:solidFill>
-                  <a:srgbClr val="525252"/>
-                </a:solidFill>
-                <a:latin typeface="IBM Plex Sans"/>
-              </a:rPr>
-              <a:t>ship faster, modernize continuously, stay secure and governed.</a:t>
-            </a:r>
-          </a:p>
-        </p:txBody>
-      </p:sp>
-      <p:sp>
-        <p:nvSpPr>
-          <p:cNvPr id="17" name="TextBox 16"/>
-          <p:cNvSpPr txBox="1"/>
-          <p:nvPr/>
-        </p:nvSpPr>
-        <p:spPr>
-          <a:xfrm>
-            <a:off x="5943600" y="6382512"/>
-            <a:ext cx="5788152" cy="320040"/>
-          </a:xfrm>
-          <a:prstGeom prst="rect">
-            <a:avLst/>
-          </a:prstGeom>
-          <a:noFill/>
-        </p:spPr>
-        <p:txBody>
-          <a:bodyPr wrap="square" anchor="t" lIns="0" rIns="0" tIns="0" bIns="0">
-            <a:spAutoFit/>
-          </a:bodyPr>
-          <a:lstStyle/>
-          <a:p>
-            <a:pPr algn="r">
-              <a:spcAft>
-                <a:spcPts val="0"/>
-              </a:spcAft>
-            </a:pPr>
-            <a:r>
-              <a:rPr sz="950" b="0" i="1">
-                <a:solidFill>
-                  <a:srgbClr val="6F6F6F"/>
-                </a:solidFill>
-                <a:latin typeface="IBM Plex Sans"/>
-              </a:rPr>
-              <a:t>Source: ibm.com/products/ai-coding-agent — IBM official figures</a:t>
-            </a:r>
-          </a:p>
-        </p:txBody>
-      </p:sp>
+      <p:grpSpPr>
+        <a:xfrm>
+          <a:off x="0" y="0"/>
+          <a:ext cx="0" cy="0"/>
+          <a:chOff x="0" y="0"/>
+          <a:chExt cx="0" cy="0"/>
+        </a:xfrm>
+      </p:grpSpPr>
     </p:spTree>
+    <p:extLst>
+      <p:ext uri="{BB962C8B-B14F-4D97-AF65-F5344CB8AC3E}">
+        <p14:creationId xmlns:p14="http://schemas.microsoft.com/office/powerpoint/2010/main" val="3699106748"/>
+      </p:ext>
+    </p:extLst>
   </p:cSld>
   <p:clrMapOvr>
     <a:masterClrMapping/>
   </p:clrMapOvr>
+  <p:transition spd="slow">
+    <p:fade/>
+  </p:transition>
 </p:sld>
 </file>
 
@@ -53685,6 +52943,781 @@
 </file>
 
 <file path=ppt/slides/slide8.xml><?xml version="1.0" encoding="utf-8"?>
+<p:sld xmlns:a="http://schemas.openxmlformats.org/drawingml/2006/main" xmlns:p="http://schemas.openxmlformats.org/presentationml/2006/main" xmlns:r="http://schemas.openxmlformats.org/officeDocument/2006/relationships">
+  <p:cSld>
+    <p:spTree>
+      <p:nvGrpSpPr>
+        <p:cNvPr id="1" name=""/>
+        <p:cNvGrpSpPr/>
+        <p:nvPr/>
+      </p:nvGrpSpPr>
+      <p:grpSpPr/>
+      <p:pic>
+        <p:nvPicPr>
+          <p:cNvPr id="2" name="Picture 1" descr="image.png"/>
+          <p:cNvPicPr>
+            <a:picLocks noChangeAspect="1"/>
+          </p:cNvPicPr>
+          <p:nvPr/>
+        </p:nvPicPr>
+        <p:blipFill>
+          <a:blip r:embed="rId2"/>
+          <a:stretch>
+            <a:fillRect/>
+          </a:stretch>
+        </p:blipFill>
+        <p:spPr>
+          <a:xfrm>
+            <a:off x="0" y="91440"/>
+            <a:ext cx="1563624" cy="1563624"/>
+          </a:xfrm>
+          <a:prstGeom prst="rect">
+            <a:avLst/>
+          </a:prstGeom>
+        </p:spPr>
+      </p:pic>
+      <p:sp>
+        <p:nvSpPr>
+          <p:cNvPr id="3" name="TextBox 2"/>
+          <p:cNvSpPr txBox="1"/>
+          <p:nvPr/>
+        </p:nvSpPr>
+        <p:spPr>
+          <a:xfrm>
+            <a:off x="1563624" y="310896"/>
+            <a:ext cx="9509760" cy="640080"/>
+          </a:xfrm>
+          <a:prstGeom prst="rect">
+            <a:avLst/>
+          </a:prstGeom>
+          <a:noFill/>
+        </p:spPr>
+        <p:txBody>
+          <a:bodyPr wrap="square" anchor="t" lIns="0" rIns="0" tIns="0" bIns="0">
+            <a:spAutoFit/>
+          </a:bodyPr>
+          <a:lstStyle/>
+          <a:p>
+            <a:pPr algn="l">
+              <a:spcAft>
+                <a:spcPts val="0"/>
+              </a:spcAft>
+            </a:pPr>
+            <a:r>
+              <a:rPr sz="2900" b="0" i="0">
+                <a:solidFill>
+                  <a:srgbClr val="525252"/>
+                </a:solidFill>
+                <a:latin typeface="IBM Plex Sans Light"/>
+              </a:rPr>
+              <a:t>IBM about Bob</a:t>
+            </a:r>
+          </a:p>
+        </p:txBody>
+      </p:sp>
+      <p:sp>
+        <p:nvSpPr>
+          <p:cNvPr id="4" name="TextBox 3"/>
+          <p:cNvSpPr txBox="1"/>
+          <p:nvPr/>
+        </p:nvSpPr>
+        <p:spPr>
+          <a:xfrm>
+            <a:off x="1563624" y="969264"/>
+            <a:ext cx="9692640" cy="457200"/>
+          </a:xfrm>
+          <a:prstGeom prst="rect">
+            <a:avLst/>
+          </a:prstGeom>
+          <a:noFill/>
+        </p:spPr>
+        <p:txBody>
+          <a:bodyPr wrap="square" anchor="t" lIns="0" rIns="0" tIns="0" bIns="0">
+            <a:spAutoFit/>
+          </a:bodyPr>
+          <a:lstStyle/>
+          <a:p>
+            <a:pPr algn="l">
+              <a:spcAft>
+                <a:spcPts val="0"/>
+              </a:spcAft>
+            </a:pPr>
+            <a:r>
+              <a:rPr sz="1350" b="0" i="1">
+                <a:solidFill>
+                  <a:srgbClr val="0F62FE"/>
+                </a:solidFill>
+                <a:latin typeface="IBM Plex Sans"/>
+              </a:rPr>
+              <a:t>Faster innovation, higher productivity — built for scale, security and governance.</a:t>
+            </a:r>
+          </a:p>
+        </p:txBody>
+      </p:sp>
+      <p:sp>
+        <p:nvSpPr>
+          <p:cNvPr id="5" name="TextBox 4"/>
+          <p:cNvSpPr txBox="1"/>
+          <p:nvPr/>
+        </p:nvSpPr>
+        <p:spPr>
+          <a:xfrm>
+            <a:off x="457200" y="1828800"/>
+            <a:ext cx="2743200" cy="868680"/>
+          </a:xfrm>
+          <a:prstGeom prst="rect">
+            <a:avLst/>
+          </a:prstGeom>
+          <a:noFill/>
+        </p:spPr>
+        <p:txBody>
+          <a:bodyPr wrap="square" anchor="ctr" lIns="0" rIns="0" tIns="0" bIns="0">
+            <a:spAutoFit/>
+          </a:bodyPr>
+          <a:lstStyle/>
+          <a:p>
+            <a:pPr algn="ctr">
+              <a:spcAft>
+                <a:spcPts val="0"/>
+              </a:spcAft>
+            </a:pPr>
+            <a:r>
+              <a:rPr sz="4400" b="1" i="0">
+                <a:solidFill>
+                  <a:srgbClr val="0F62FE"/>
+                </a:solidFill>
+                <a:latin typeface="IBM Plex Sans"/>
+              </a:rPr>
+              <a:t>20–80%</a:t>
+            </a:r>
+          </a:p>
+        </p:txBody>
+      </p:sp>
+      <p:sp>
+        <p:nvSpPr>
+          <p:cNvPr id="6" name="TextBox 5"/>
+          <p:cNvSpPr txBox="1"/>
+          <p:nvPr/>
+        </p:nvSpPr>
+        <p:spPr>
+          <a:xfrm>
+            <a:off x="457200" y="2724912"/>
+            <a:ext cx="2743200" cy="640080"/>
+          </a:xfrm>
+          <a:prstGeom prst="rect">
+            <a:avLst/>
+          </a:prstGeom>
+          <a:noFill/>
+        </p:spPr>
+        <p:txBody>
+          <a:bodyPr wrap="square" anchor="t" lIns="0" rIns="0" tIns="0" bIns="0">
+            <a:spAutoFit/>
+          </a:bodyPr>
+          <a:lstStyle/>
+          <a:p>
+            <a:pPr algn="ctr">
+              <a:spcAft>
+                <a:spcPts val="0"/>
+              </a:spcAft>
+            </a:pPr>
+            <a:r>
+              <a:rPr sz="1250" b="0" i="0">
+                <a:solidFill>
+                  <a:srgbClr val="525252"/>
+                </a:solidFill>
+                <a:latin typeface="IBM Plex Sans"/>
+              </a:rPr>
+              <a:t>productivity gains</a:t>
+            </a:r>
+          </a:p>
+          <a:p>
+            <a:pPr algn="ctr">
+              <a:spcAft>
+                <a:spcPts val="0"/>
+              </a:spcAft>
+            </a:pPr>
+            <a:r>
+              <a:rPr sz="1250" b="0" i="0">
+                <a:solidFill>
+                  <a:srgbClr val="525252"/>
+                </a:solidFill>
+                <a:latin typeface="IBM Plex Sans"/>
+              </a:rPr>
+              <a:t>across SDLC tasks</a:t>
+            </a:r>
+          </a:p>
+        </p:txBody>
+      </p:sp>
+      <p:sp>
+        <p:nvSpPr>
+          <p:cNvPr id="7" name="TextBox 6"/>
+          <p:cNvSpPr txBox="1"/>
+          <p:nvPr/>
+        </p:nvSpPr>
+        <p:spPr>
+          <a:xfrm>
+            <a:off x="3273552" y="1828800"/>
+            <a:ext cx="2743200" cy="868680"/>
+          </a:xfrm>
+          <a:prstGeom prst="rect">
+            <a:avLst/>
+          </a:prstGeom>
+          <a:noFill/>
+        </p:spPr>
+        <p:txBody>
+          <a:bodyPr wrap="square" anchor="ctr" lIns="0" rIns="0" tIns="0" bIns="0">
+            <a:spAutoFit/>
+          </a:bodyPr>
+          <a:lstStyle/>
+          <a:p>
+            <a:pPr algn="ctr">
+              <a:spcAft>
+                <a:spcPts val="0"/>
+              </a:spcAft>
+            </a:pPr>
+            <a:r>
+              <a:rPr sz="4400" b="1" i="0">
+                <a:solidFill>
+                  <a:srgbClr val="0F62FE"/>
+                </a:solidFill>
+                <a:latin typeface="IBM Plex Sans"/>
+              </a:rPr>
+              <a:t>90%+</a:t>
+            </a:r>
+          </a:p>
+        </p:txBody>
+      </p:sp>
+      <p:sp>
+        <p:nvSpPr>
+          <p:cNvPr id="8" name="TextBox 7"/>
+          <p:cNvSpPr txBox="1"/>
+          <p:nvPr/>
+        </p:nvSpPr>
+        <p:spPr>
+          <a:xfrm>
+            <a:off x="3273552" y="2724912"/>
+            <a:ext cx="2743200" cy="640080"/>
+          </a:xfrm>
+          <a:prstGeom prst="rect">
+            <a:avLst/>
+          </a:prstGeom>
+          <a:noFill/>
+        </p:spPr>
+        <p:txBody>
+          <a:bodyPr wrap="square" anchor="t" lIns="0" rIns="0" tIns="0" bIns="0">
+            <a:spAutoFit/>
+          </a:bodyPr>
+          <a:lstStyle/>
+          <a:p>
+            <a:pPr algn="ctr">
+              <a:spcAft>
+                <a:spcPts val="0"/>
+              </a:spcAft>
+            </a:pPr>
+            <a:r>
+              <a:rPr sz="1250" b="0" i="0">
+                <a:solidFill>
+                  <a:srgbClr val="525252"/>
+                </a:solidFill>
+                <a:latin typeface="IBM Plex Sans"/>
+              </a:rPr>
+              <a:t>time savings on</a:t>
+            </a:r>
+          </a:p>
+          <a:p>
+            <a:pPr algn="ctr">
+              <a:spcAft>
+                <a:spcPts val="0"/>
+              </a:spcAft>
+            </a:pPr>
+            <a:r>
+              <a:rPr sz="1250" b="0" i="0">
+                <a:solidFill>
+                  <a:srgbClr val="525252"/>
+                </a:solidFill>
+                <a:latin typeface="IBM Plex Sans"/>
+              </a:rPr>
+              <a:t>repetitive work</a:t>
+            </a:r>
+          </a:p>
+        </p:txBody>
+      </p:sp>
+      <p:sp>
+        <p:nvSpPr>
+          <p:cNvPr id="9" name="TextBox 8"/>
+          <p:cNvSpPr txBox="1"/>
+          <p:nvPr/>
+        </p:nvSpPr>
+        <p:spPr>
+          <a:xfrm>
+            <a:off x="6089904" y="1828800"/>
+            <a:ext cx="2743200" cy="868680"/>
+          </a:xfrm>
+          <a:prstGeom prst="rect">
+            <a:avLst/>
+          </a:prstGeom>
+          <a:noFill/>
+        </p:spPr>
+        <p:txBody>
+          <a:bodyPr wrap="square" anchor="ctr" lIns="0" rIns="0" tIns="0" bIns="0">
+            <a:spAutoFit/>
+          </a:bodyPr>
+          <a:lstStyle/>
+          <a:p>
+            <a:pPr algn="ctr">
+              <a:spcAft>
+                <a:spcPts val="0"/>
+              </a:spcAft>
+            </a:pPr>
+            <a:r>
+              <a:rPr sz="4400" b="1" i="0">
+                <a:solidFill>
+                  <a:srgbClr val="0F62FE"/>
+                </a:solidFill>
+                <a:latin typeface="IBM Plex Sans"/>
+              </a:rPr>
+              <a:t>20–40%</a:t>
+            </a:r>
+          </a:p>
+        </p:txBody>
+      </p:sp>
+      <p:sp>
+        <p:nvSpPr>
+          <p:cNvPr id="10" name="TextBox 9"/>
+          <p:cNvSpPr txBox="1"/>
+          <p:nvPr/>
+        </p:nvSpPr>
+        <p:spPr>
+          <a:xfrm>
+            <a:off x="6089904" y="2724912"/>
+            <a:ext cx="2743200" cy="640080"/>
+          </a:xfrm>
+          <a:prstGeom prst="rect">
+            <a:avLst/>
+          </a:prstGeom>
+          <a:noFill/>
+        </p:spPr>
+        <p:txBody>
+          <a:bodyPr wrap="square" anchor="t" lIns="0" rIns="0" tIns="0" bIns="0">
+            <a:spAutoFit/>
+          </a:bodyPr>
+          <a:lstStyle/>
+          <a:p>
+            <a:pPr algn="ctr">
+              <a:spcAft>
+                <a:spcPts val="0"/>
+              </a:spcAft>
+            </a:pPr>
+            <a:r>
+              <a:rPr sz="1250" b="0" i="0">
+                <a:solidFill>
+                  <a:srgbClr val="525252"/>
+                </a:solidFill>
+                <a:latin typeface="IBM Plex Sans"/>
+              </a:rPr>
+              <a:t>faster on complex</a:t>
+            </a:r>
+          </a:p>
+          <a:p>
+            <a:pPr algn="ctr">
+              <a:spcAft>
+                <a:spcPts val="0"/>
+              </a:spcAft>
+            </a:pPr>
+            <a:r>
+              <a:rPr sz="1250" b="0" i="0">
+                <a:solidFill>
+                  <a:srgbClr val="525252"/>
+                </a:solidFill>
+                <a:latin typeface="IBM Plex Sans"/>
+              </a:rPr>
+              <a:t>engineering work</a:t>
+            </a:r>
+          </a:p>
+        </p:txBody>
+      </p:sp>
+      <p:sp>
+        <p:nvSpPr>
+          <p:cNvPr id="11" name="TextBox 10"/>
+          <p:cNvSpPr txBox="1"/>
+          <p:nvPr/>
+        </p:nvSpPr>
+        <p:spPr>
+          <a:xfrm>
+            <a:off x="8906256" y="1828800"/>
+            <a:ext cx="2743200" cy="868680"/>
+          </a:xfrm>
+          <a:prstGeom prst="rect">
+            <a:avLst/>
+          </a:prstGeom>
+          <a:noFill/>
+        </p:spPr>
+        <p:txBody>
+          <a:bodyPr wrap="square" anchor="ctr" lIns="0" rIns="0" tIns="0" bIns="0">
+            <a:spAutoFit/>
+          </a:bodyPr>
+          <a:lstStyle/>
+          <a:p>
+            <a:pPr algn="ctr">
+              <a:spcAft>
+                <a:spcPts val="0"/>
+              </a:spcAft>
+            </a:pPr>
+            <a:r>
+              <a:rPr sz="4400" b="1" i="0">
+                <a:solidFill>
+                  <a:srgbClr val="0F62FE"/>
+                </a:solidFill>
+                <a:latin typeface="IBM Plex Sans"/>
+              </a:rPr>
+              <a:t>~40%</a:t>
+            </a:r>
+          </a:p>
+        </p:txBody>
+      </p:sp>
+      <p:sp>
+        <p:nvSpPr>
+          <p:cNvPr id="12" name="TextBox 11"/>
+          <p:cNvSpPr txBox="1"/>
+          <p:nvPr/>
+        </p:nvSpPr>
+        <p:spPr>
+          <a:xfrm>
+            <a:off x="8906256" y="2724912"/>
+            <a:ext cx="2743200" cy="640080"/>
+          </a:xfrm>
+          <a:prstGeom prst="rect">
+            <a:avLst/>
+          </a:prstGeom>
+          <a:noFill/>
+        </p:spPr>
+        <p:txBody>
+          <a:bodyPr wrap="square" anchor="t" lIns="0" rIns="0" tIns="0" bIns="0">
+            <a:spAutoFit/>
+          </a:bodyPr>
+          <a:lstStyle/>
+          <a:p>
+            <a:pPr algn="ctr">
+              <a:spcAft>
+                <a:spcPts val="0"/>
+              </a:spcAft>
+            </a:pPr>
+            <a:r>
+              <a:rPr sz="1250" b="0" i="0">
+                <a:solidFill>
+                  <a:srgbClr val="525252"/>
+                </a:solidFill>
+                <a:latin typeface="IBM Plex Sans"/>
+              </a:rPr>
+              <a:t>lower AI</a:t>
+            </a:r>
+          </a:p>
+          <a:p>
+            <a:pPr algn="ctr">
+              <a:spcAft>
+                <a:spcPts val="0"/>
+              </a:spcAft>
+            </a:pPr>
+            <a:r>
+              <a:rPr sz="1250" b="0" i="0">
+                <a:solidFill>
+                  <a:srgbClr val="525252"/>
+                </a:solidFill>
+                <a:latin typeface="IBM Plex Sans"/>
+              </a:rPr>
+              <a:t>compute spend</a:t>
+            </a:r>
+          </a:p>
+        </p:txBody>
+      </p:sp>
+      <p:sp>
+        <p:nvSpPr>
+          <p:cNvPr id="13" name="TextBox 12"/>
+          <p:cNvSpPr txBox="1"/>
+          <p:nvPr/>
+        </p:nvSpPr>
+        <p:spPr>
+          <a:xfrm>
+            <a:off x="457200" y="3977639"/>
+            <a:ext cx="3520440" cy="1280160"/>
+          </a:xfrm>
+          <a:prstGeom prst="rect">
+            <a:avLst/>
+          </a:prstGeom>
+          <a:noFill/>
+        </p:spPr>
+        <p:txBody>
+          <a:bodyPr wrap="square" anchor="t" lIns="0" rIns="0" tIns="0" bIns="0">
+            <a:spAutoFit/>
+          </a:bodyPr>
+          <a:lstStyle/>
+          <a:p>
+            <a:pPr algn="l">
+              <a:spcAft>
+                <a:spcPts val="700"/>
+              </a:spcAft>
+            </a:pPr>
+            <a:r>
+              <a:rPr sz="1300" b="1" i="0">
+                <a:solidFill>
+                  <a:srgbClr val="0F62FE"/>
+                </a:solidFill>
+                <a:latin typeface="IBM Plex Sans"/>
+              </a:rPr>
+              <a:t>▪  </a:t>
+            </a:r>
+            <a:r>
+              <a:rPr sz="1500" b="1" i="0">
+                <a:solidFill>
+                  <a:srgbClr val="0E2841"/>
+                </a:solidFill>
+                <a:latin typeface="IBM Plex Sans"/>
+              </a:rPr>
+              <a:t>Scale</a:t>
+            </a:r>
+          </a:p>
+          <a:p>
+            <a:pPr algn="l">
+              <a:spcAft>
+                <a:spcPts val="0"/>
+              </a:spcAft>
+            </a:pPr>
+            <a:r>
+              <a:rPr sz="1250" b="0" i="0">
+                <a:solidFill>
+                  <a:srgbClr val="393939"/>
+                </a:solidFill>
+                <a:latin typeface="IBM Plex Sans"/>
+              </a:rPr>
+              <a:t>Orchestrates planning, execution and verification across the full SDLC.</a:t>
+            </a:r>
+          </a:p>
+        </p:txBody>
+      </p:sp>
+      <p:sp>
+        <p:nvSpPr>
+          <p:cNvPr id="14" name="TextBox 13"/>
+          <p:cNvSpPr txBox="1"/>
+          <p:nvPr/>
+        </p:nvSpPr>
+        <p:spPr>
+          <a:xfrm>
+            <a:off x="4215384" y="3977639"/>
+            <a:ext cx="3520440" cy="1280160"/>
+          </a:xfrm>
+          <a:prstGeom prst="rect">
+            <a:avLst/>
+          </a:prstGeom>
+          <a:noFill/>
+        </p:spPr>
+        <p:txBody>
+          <a:bodyPr wrap="square" anchor="t" lIns="0" rIns="0" tIns="0" bIns="0">
+            <a:spAutoFit/>
+          </a:bodyPr>
+          <a:lstStyle/>
+          <a:p>
+            <a:pPr algn="l">
+              <a:spcAft>
+                <a:spcPts val="700"/>
+              </a:spcAft>
+            </a:pPr>
+            <a:r>
+              <a:rPr sz="1300" b="1" i="0">
+                <a:solidFill>
+                  <a:srgbClr val="0F62FE"/>
+                </a:solidFill>
+                <a:latin typeface="IBM Plex Sans"/>
+              </a:rPr>
+              <a:t>▪  </a:t>
+            </a:r>
+            <a:r>
+              <a:rPr sz="1500" b="1" i="0">
+                <a:solidFill>
+                  <a:srgbClr val="0E2841"/>
+                </a:solidFill>
+                <a:latin typeface="IBM Plex Sans"/>
+              </a:rPr>
+              <a:t>Security-first</a:t>
+            </a:r>
+          </a:p>
+          <a:p>
+            <a:pPr algn="l">
+              <a:spcAft>
+                <a:spcPts val="0"/>
+              </a:spcAft>
+            </a:pPr>
+            <a:r>
+              <a:rPr sz="1250" b="0" i="0">
+                <a:solidFill>
+                  <a:srgbClr val="393939"/>
+                </a:solidFill>
+                <a:latin typeface="IBM Plex Sans"/>
+              </a:rPr>
+              <a:t>Detects vulnerabilities during code authoring — not after the fact.</a:t>
+            </a:r>
+          </a:p>
+        </p:txBody>
+      </p:sp>
+      <p:sp>
+        <p:nvSpPr>
+          <p:cNvPr id="15" name="TextBox 14"/>
+          <p:cNvSpPr txBox="1"/>
+          <p:nvPr/>
+        </p:nvSpPr>
+        <p:spPr>
+          <a:xfrm>
+            <a:off x="7973568" y="3977639"/>
+            <a:ext cx="3520440" cy="1280160"/>
+          </a:xfrm>
+          <a:prstGeom prst="rect">
+            <a:avLst/>
+          </a:prstGeom>
+          <a:noFill/>
+        </p:spPr>
+        <p:txBody>
+          <a:bodyPr wrap="square" anchor="t" lIns="0" rIns="0" tIns="0" bIns="0">
+            <a:spAutoFit/>
+          </a:bodyPr>
+          <a:lstStyle/>
+          <a:p>
+            <a:pPr algn="l">
+              <a:spcAft>
+                <a:spcPts val="700"/>
+              </a:spcAft>
+            </a:pPr>
+            <a:r>
+              <a:rPr sz="1300" b="1" i="0">
+                <a:solidFill>
+                  <a:srgbClr val="0F62FE"/>
+                </a:solidFill>
+                <a:latin typeface="IBM Plex Sans"/>
+              </a:rPr>
+              <a:t>▪  </a:t>
+            </a:r>
+            <a:r>
+              <a:rPr sz="1500" b="1" i="0">
+                <a:solidFill>
+                  <a:srgbClr val="0E2841"/>
+                </a:solidFill>
+                <a:latin typeface="IBM Plex Sans"/>
+              </a:rPr>
+              <a:t>Governance</a:t>
+            </a:r>
+          </a:p>
+          <a:p>
+            <a:pPr algn="l">
+              <a:spcAft>
+                <a:spcPts val="0"/>
+              </a:spcAft>
+            </a:pPr>
+            <a:r>
+              <a:rPr sz="1250" b="0" i="0">
+                <a:solidFill>
+                  <a:srgbClr val="393939"/>
+                </a:solidFill>
+                <a:latin typeface="IBM Plex Sans"/>
+              </a:rPr>
+              <a:t>Auditable guardrails and audit-readiness embedded at authoring time.</a:t>
+            </a:r>
+          </a:p>
+        </p:txBody>
+      </p:sp>
+      <p:sp>
+        <p:nvSpPr>
+          <p:cNvPr id="16" name="TextBox 15"/>
+          <p:cNvSpPr txBox="1"/>
+          <p:nvPr/>
+        </p:nvSpPr>
+        <p:spPr>
+          <a:xfrm>
+            <a:off x="457200" y="5486400"/>
+            <a:ext cx="8686800" cy="457200"/>
+          </a:xfrm>
+          <a:prstGeom prst="rect">
+            <a:avLst/>
+          </a:prstGeom>
+          <a:noFill/>
+        </p:spPr>
+        <p:txBody>
+          <a:bodyPr wrap="square" anchor="t" lIns="0" rIns="0" tIns="0" bIns="0">
+            <a:spAutoFit/>
+          </a:bodyPr>
+          <a:lstStyle/>
+          <a:p>
+            <a:pPr algn="l">
+              <a:spcAft>
+                <a:spcPts val="0"/>
+              </a:spcAft>
+            </a:pPr>
+            <a:r>
+              <a:rPr sz="1350" b="1" i="0">
+                <a:solidFill>
+                  <a:srgbClr val="0E2841"/>
+                </a:solidFill>
+                <a:latin typeface="IBM Plex Sans"/>
+              </a:rPr>
+              <a:t>IBM's own positioning — </a:t>
+            </a:r>
+            <a:r>
+              <a:rPr sz="1350" b="0" i="1">
+                <a:solidFill>
+                  <a:srgbClr val="525252"/>
+                </a:solidFill>
+                <a:latin typeface="IBM Plex Sans"/>
+              </a:rPr>
+              <a:t>ship faster, modernize continuously, stay secure and governed.</a:t>
+            </a:r>
+          </a:p>
+        </p:txBody>
+      </p:sp>
+      <p:sp>
+        <p:nvSpPr>
+          <p:cNvPr id="17" name="TextBox 16"/>
+          <p:cNvSpPr txBox="1"/>
+          <p:nvPr/>
+        </p:nvSpPr>
+        <p:spPr>
+          <a:xfrm>
+            <a:off x="5943600" y="6382512"/>
+            <a:ext cx="5788152" cy="320040"/>
+          </a:xfrm>
+          <a:prstGeom prst="rect">
+            <a:avLst/>
+          </a:prstGeom>
+          <a:noFill/>
+        </p:spPr>
+        <p:txBody>
+          <a:bodyPr wrap="square" anchor="t" lIns="0" rIns="0" tIns="0" bIns="0">
+            <a:spAutoFit/>
+          </a:bodyPr>
+          <a:lstStyle/>
+          <a:p>
+            <a:pPr algn="r">
+              <a:spcAft>
+                <a:spcPts val="0"/>
+              </a:spcAft>
+            </a:pPr>
+            <a:r>
+              <a:rPr sz="950" b="0" i="1">
+                <a:solidFill>
+                  <a:srgbClr val="6F6F6F"/>
+                </a:solidFill>
+                <a:latin typeface="IBM Plex Sans"/>
+              </a:rPr>
+              <a:t>Source: ibm.com/products/ai-coding-agent — IBM official figures</a:t>
+            </a:r>
+          </a:p>
+        </p:txBody>
+      </p:sp>
+    </p:spTree>
+  </p:cSld>
+  <p:clrMapOvr>
+    <a:masterClrMapping/>
+  </p:clrMapOvr>
+</p:sld>
+</file>
+
+<file path=ppt/slides/slide9.xml><?xml version="1.0" encoding="utf-8"?>
 <p:sld xmlns:a="http://schemas.openxmlformats.org/drawingml/2006/main" xmlns:r="http://schemas.openxmlformats.org/officeDocument/2006/relationships" xmlns:p="http://schemas.openxmlformats.org/presentationml/2006/main">
   <p:cSld>
     <p:spTree>
@@ -53858,39 +53891,6 @@
     <a:masterClrMapping/>
   </p:clrMapOvr>
   <p:transition spd="med"/>
-</p:sld>
-</file>
-
-<file path=ppt/slides/slide9.xml><?xml version="1.0" encoding="utf-8"?>
-<p:sld xmlns:a="http://schemas.openxmlformats.org/drawingml/2006/main" xmlns:r="http://schemas.openxmlformats.org/officeDocument/2006/relationships" xmlns:p="http://schemas.openxmlformats.org/presentationml/2006/main">
-  <p:cSld>
-    <p:spTree>
-      <p:nvGrpSpPr>
-        <p:cNvPr id="1" name=""/>
-        <p:cNvGrpSpPr/>
-        <p:nvPr/>
-      </p:nvGrpSpPr>
-      <p:grpSpPr>
-        <a:xfrm>
-          <a:off x="0" y="0"/>
-          <a:ext cx="0" cy="0"/>
-          <a:chOff x="0" y="0"/>
-          <a:chExt cx="0" cy="0"/>
-        </a:xfrm>
-      </p:grpSpPr>
-    </p:spTree>
-    <p:extLst>
-      <p:ext uri="{BB962C8B-B14F-4D97-AF65-F5344CB8AC3E}">
-        <p14:creationId xmlns:p14="http://schemas.microsoft.com/office/powerpoint/2010/main" val="3699106748"/>
-      </p:ext>
-    </p:extLst>
-  </p:cSld>
-  <p:clrMapOvr>
-    <a:masterClrMapping/>
-  </p:clrMapOvr>
-  <p:transition spd="slow">
-    <p:fade/>
-  </p:transition>
 </p:sld>
 </file>
 

</xml_diff>